<commit_message>
Scalability curves for Neo4j, matching the SQLite ones run_scaling_neo4j.py measures load, clustering and the 8 queries on thesame four sizes.
</commit_message>
<xml_diff>
--- a/presentation/NodeCoin - Damiano Spadaccini.pptx
+++ b/presentation/NodeCoin - Damiano Spadaccini.pptx
@@ -17,6 +17,9 @@
     <p:sldId id="265" r:id="rId11"/>
     <p:sldId id="266" r:id="rId12"/>
     <p:sldId id="267" r:id="rId13"/>
+    <p:sldId id="268" r:id="rId14"/>
+    <p:sldId id="269" r:id="rId15"/>
+    <p:sldId id="270" r:id="rId16"/>
   </p:sldIdLst>
   <p:sldSz cx="12192000" cy="6858000"/>
   <p:notesSz cx="6858000" cy="12192000"/>
@@ -547,7 +550,7 @@
                 </a:solidFill>
                 <a:latin typeface="Trebuchet MS"/>
               </a:rPr>
-              <a:t>TRADE-OFFS</a:t>
+              <a:t>SCALING</a:t>
             </a:r>
           </a:p>
         </p:txBody>
@@ -585,7 +588,7 @@
                 </a:solidFill>
                 <a:latin typeface="Georgia"/>
               </a:rPr>
-              <a:t>The cost you don't see in query timings</a:t>
+              <a:t>And the same on Neo4j</a:t>
             </a:r>
           </a:p>
         </p:txBody>
@@ -628,16 +631,40 @@
           </a:p>
         </p:txBody>
       </p:sp>
-      <p:sp>
-        <p:nvSpPr>
-          <p:cNvPr id="10" name="tb10"/>
+      <p:pic>
+        <p:nvPicPr>
+          <p:cNvPr id="10" name="pic10"/>
+          <p:cNvPicPr>
+            <a:picLocks noChangeAspect="1"/>
+          </p:cNvPicPr>
+          <p:nvPr/>
+        </p:nvPicPr>
+        <p:blipFill>
+          <a:blip r:embed="rId2"/>
+          <a:stretch>
+            <a:fillRect/>
+          </a:stretch>
+        </p:blipFill>
+        <p:spPr>
+          <a:xfrm>
+            <a:off x="1000000" y="1560000"/>
+            <a:ext cx="10200000" cy="4020000"/>
+          </a:xfrm>
+          <a:prstGeom prst="rect">
+            <a:avLst/>
+          </a:prstGeom>
+        </p:spPr>
+      </p:pic>
+      <p:sp>
+        <p:nvSpPr>
+          <p:cNvPr id="11" name="tb11"/>
           <p:cNvSpPr txBox="1"/>
           <p:nvPr/>
         </p:nvSpPr>
         <p:spPr>
           <a:xfrm>
-            <a:off x="700000" y="1700000"/>
-            <a:ext cx="10800000" cy="330000"/>
+            <a:off x="700000" y="5700000"/>
+            <a:ext cx="10800000" cy="600000"/>
           </a:xfrm>
           <a:prstGeom prst="rect">
             <a:avLst/>
@@ -655,519 +682,31 @@
               </a:lnSpc>
             </a:pPr>
             <a:r>
+              <a:rPr lang="it-IT" sz="1350" b="0" dirty="0">
+                <a:solidFill>
+                  <a:srgbClr val="A8A29A"/>
+                </a:solidFill>
+                <a:latin typeface="Trebuchet MS"/>
+              </a:rPr>
+              <a:t>Same four sizes, same protocol. One difference stands out: </a:t>
+            </a:r>
+            <a:r>
               <a:rPr lang="it-IT" sz="1350" b="1" dirty="0">
                 <a:solidFill>
                   <a:srgbClr val="F2EFE9"/>
                 </a:solidFill>
                 <a:latin typeface="Trebuchet MS"/>
               </a:rPr>
-              <a:t>1. Loading the data, paid once per database</a:t>
-            </a:r>
-          </a:p>
-        </p:txBody>
-      </p:sp>
-      <p:sp>
-        <p:nvSpPr>
-          <p:cNvPr id="11" name="rc11"/>
-          <p:cNvSpPr/>
-          <p:nvPr/>
-        </p:nvSpPr>
-        <p:spPr>
-          <a:xfrm>
-            <a:off x="700000" y="2070000"/>
-            <a:ext cx="5250000" cy="1150000"/>
-          </a:xfrm>
-          <a:prstGeom prst="roundRect">
-            <a:avLst>
-              <a:gd name="adj" fmla="val 6000"/>
-            </a:avLst>
-          </a:prstGeom>
-          <a:solidFill>
-            <a:srgbClr val="D9A441">
-              <a:alpha val="10000"/>
-            </a:srgbClr>
-          </a:solidFill>
-          <a:ln w="12700">
-            <a:solidFill>
-              <a:srgbClr val="D9A441"/>
-            </a:solidFill>
-          </a:ln>
-        </p:spPr>
-        <p:txBody>
-          <a:bodyPr/>
-          <a:lstStyle/>
-          <a:p/>
-        </p:txBody>
-      </p:sp>
-      <p:sp>
-        <p:nvSpPr>
-          <p:cNvPr id="12" name="tb12"/>
-          <p:cNvSpPr txBox="1"/>
-          <p:nvPr/>
-        </p:nvSpPr>
-        <p:spPr>
-          <a:xfrm>
-            <a:off x="950000" y="2190000"/>
-            <a:ext cx="4750000" cy="300000"/>
-          </a:xfrm>
-          <a:prstGeom prst="rect">
-            <a:avLst/>
-          </a:prstGeom>
-        </p:spPr>
-        <p:txBody>
-          <a:bodyPr wrap="square" rtlCol="0" anchor="t">
-            <a:normAutofit/>
-          </a:bodyPr>
-          <a:lstStyle/>
-          <a:p>
-            <a:pPr algn="l">
-              <a:lnSpc>
-                <a:spcPct val="100000"/>
-              </a:lnSpc>
-            </a:pPr>
-            <a:r>
-              <a:rPr lang="it-IT" sz="1200" b="1" dirty="0">
-                <a:solidFill>
-                  <a:srgbClr val="D9A441"/>
-                </a:solidFill>
-                <a:latin typeface="Trebuchet MS"/>
-              </a:rPr>
-              <a:t>SQLite</a:t>
-            </a:r>
-          </a:p>
-        </p:txBody>
-      </p:sp>
-      <p:sp>
-        <p:nvSpPr>
-          <p:cNvPr id="13" name="tb13"/>
-          <p:cNvSpPr txBox="1"/>
-          <p:nvPr/>
-        </p:nvSpPr>
-        <p:spPr>
-          <a:xfrm>
-            <a:off x="950000" y="2510000"/>
-            <a:ext cx="4750000" cy="600000"/>
-          </a:xfrm>
-          <a:prstGeom prst="rect">
-            <a:avLst/>
-          </a:prstGeom>
-        </p:spPr>
-        <p:txBody>
-          <a:bodyPr wrap="square" rtlCol="0" anchor="t">
-            <a:normAutofit/>
-          </a:bodyPr>
-          <a:lstStyle/>
-          <a:p>
-            <a:pPr algn="l">
-              <a:lnSpc>
-                <a:spcPct val="100000"/>
-              </a:lnSpc>
-            </a:pPr>
-            <a:r>
-              <a:rPr lang="it-IT" sz="1200" b="0" dirty="0">
+              <a:t>Q4 never completes</a:t>
+            </a:r>
+            <a:r>
+              <a:rPr lang="it-IT" sz="1350" b="0" dirty="0">
                 <a:solidFill>
                   <a:srgbClr val="A8A29A"/>
                 </a:solidFill>
                 <a:latin typeface="Trebuchet MS"/>
               </a:rPr>
-              <a:t>9.4 min, 6.2 GB, no tuning at all</a:t>
-            </a:r>
-          </a:p>
-        </p:txBody>
-      </p:sp>
-      <p:sp>
-        <p:nvSpPr>
-          <p:cNvPr id="14" name="rc14"/>
-          <p:cNvSpPr/>
-          <p:nvPr/>
-        </p:nvSpPr>
-        <p:spPr>
-          <a:xfrm>
-            <a:off x="6250000" y="2070000"/>
-            <a:ext cx="5250000" cy="1150000"/>
-          </a:xfrm>
-          <a:prstGeom prst="roundRect">
-            <a:avLst>
-              <a:gd name="adj" fmla="val 6000"/>
-            </a:avLst>
-          </a:prstGeom>
-          <a:solidFill>
-            <a:srgbClr val="4FB59C">
-              <a:alpha val="10000"/>
-            </a:srgbClr>
-          </a:solidFill>
-          <a:ln w="12700">
-            <a:solidFill>
-              <a:srgbClr val="4FB59C"/>
-            </a:solidFill>
-          </a:ln>
-        </p:spPr>
-        <p:txBody>
-          <a:bodyPr/>
-          <a:lstStyle/>
-          <a:p/>
-        </p:txBody>
-      </p:sp>
-      <p:sp>
-        <p:nvSpPr>
-          <p:cNvPr id="15" name="tb15"/>
-          <p:cNvSpPr txBox="1"/>
-          <p:nvPr/>
-        </p:nvSpPr>
-        <p:spPr>
-          <a:xfrm>
-            <a:off x="6500000" y="2190000"/>
-            <a:ext cx="4750000" cy="300000"/>
-          </a:xfrm>
-          <a:prstGeom prst="rect">
-            <a:avLst/>
-          </a:prstGeom>
-        </p:spPr>
-        <p:txBody>
-          <a:bodyPr wrap="square" rtlCol="0" anchor="t">
-            <a:normAutofit/>
-          </a:bodyPr>
-          <a:lstStyle/>
-          <a:p>
-            <a:pPr algn="l">
-              <a:lnSpc>
-                <a:spcPct val="100000"/>
-              </a:lnSpc>
-            </a:pPr>
-            <a:r>
-              <a:rPr lang="it-IT" sz="1200" b="1" dirty="0">
-                <a:solidFill>
-                  <a:srgbClr val="4FB59C"/>
-                </a:solidFill>
-                <a:latin typeface="Trebuchet MS"/>
-              </a:rPr>
-              <a:t>Neo4j</a:t>
-            </a:r>
-          </a:p>
-        </p:txBody>
-      </p:sp>
-      <p:sp>
-        <p:nvSpPr>
-          <p:cNvPr id="16" name="tb16"/>
-          <p:cNvSpPr txBox="1"/>
-          <p:nvPr/>
-        </p:nvSpPr>
-        <p:spPr>
-          <a:xfrm>
-            <a:off x="6500000" y="2510000"/>
-            <a:ext cx="4750000" cy="600000"/>
-          </a:xfrm>
-          <a:prstGeom prst="rect">
-            <a:avLst/>
-          </a:prstGeom>
-        </p:spPr>
-        <p:txBody>
-          <a:bodyPr wrap="square" rtlCol="0" anchor="t">
-            <a:normAutofit/>
-          </a:bodyPr>
-          <a:lstStyle/>
-          <a:p>
-            <a:pPr algn="l">
-              <a:lnSpc>
-                <a:spcPct val="100000"/>
-              </a:lnSpc>
-            </a:pPr>
-            <a:r>
-              <a:rPr lang="it-IT" sz="1200" b="0" dirty="0">
-                <a:solidFill>
-                  <a:srgbClr val="A8A29A"/>
-                </a:solidFill>
-                <a:latin typeface="Trebuchet MS"/>
-              </a:rPr>
-              <a:t>40.2 min, 16.3 GB, 8 GB of heap required</a:t>
-            </a:r>
-          </a:p>
-        </p:txBody>
-      </p:sp>
-      <p:sp>
-        <p:nvSpPr>
-          <p:cNvPr id="17" name="tb17"/>
-          <p:cNvSpPr txBox="1"/>
-          <p:nvPr/>
-        </p:nvSpPr>
-        <p:spPr>
-          <a:xfrm>
-            <a:off x="700000" y="3270000"/>
-            <a:ext cx="10800000" cy="300000"/>
-          </a:xfrm>
-          <a:prstGeom prst="rect">
-            <a:avLst/>
-          </a:prstGeom>
-        </p:spPr>
-        <p:txBody>
-          <a:bodyPr wrap="square" rtlCol="0" anchor="t">
-            <a:normAutofit/>
-          </a:bodyPr>
-          <a:lstStyle/>
-          <a:p>
-            <a:pPr algn="l">
-              <a:lnSpc>
-                <a:spcPct val="100000"/>
-              </a:lnSpc>
-            </a:pPr>
-            <a:r>
-              <a:rPr lang="it-IT" sz="1150" b="0" dirty="0">
-                <a:solidFill>
-                  <a:srgbClr val="A8A29A"/>
-                </a:solidFill>
-                <a:latin typeface="Trebuchet MS"/>
-              </a:rPr>
-              <a:t>4.3x slower and 2.6x more disk, in exchange for the fast traversals seen earlier.</a:t>
-            </a:r>
-          </a:p>
-        </p:txBody>
-      </p:sp>
-      <p:sp>
-        <p:nvSpPr>
-          <p:cNvPr id="20" name="tb20"/>
-          <p:cNvSpPr txBox="1"/>
-          <p:nvPr/>
-        </p:nvSpPr>
-        <p:spPr>
-          <a:xfrm>
-            <a:off x="700000" y="3750000"/>
-            <a:ext cx="10800000" cy="330000"/>
-          </a:xfrm>
-          <a:prstGeom prst="rect">
-            <a:avLst/>
-          </a:prstGeom>
-        </p:spPr>
-        <p:txBody>
-          <a:bodyPr wrap="square" rtlCol="0" anchor="t">
-            <a:normAutofit/>
-          </a:bodyPr>
-          <a:lstStyle/>
-          <a:p>
-            <a:pPr algn="l">
-              <a:lnSpc>
-                <a:spcPct val="100000"/>
-              </a:lnSpc>
-            </a:pPr>
-            <a:r>
-              <a:rPr lang="it-IT" sz="1350" b="1" dirty="0">
-                <a:solidFill>
-                  <a:srgbClr val="F2EFE9"/>
-                </a:solidFill>
-                <a:latin typeface="Trebuchet MS"/>
-              </a:rPr>
-              <a:t>2. Q7 needs a step that comes before the query</a:t>
-            </a:r>
-          </a:p>
-        </p:txBody>
-      </p:sp>
-      <p:sp>
-        <p:nvSpPr>
-          <p:cNvPr id="21" name="rc21"/>
-          <p:cNvSpPr/>
-          <p:nvPr/>
-        </p:nvSpPr>
-        <p:spPr>
-          <a:xfrm>
-            <a:off x="700000" y="4120000"/>
-            <a:ext cx="10800000" cy="1420000"/>
-          </a:xfrm>
-          <a:prstGeom prst="roundRect">
-            <a:avLst>
-              <a:gd name="adj" fmla="val 6000"/>
-            </a:avLst>
-          </a:prstGeom>
-          <a:solidFill>
-            <a:srgbClr val="C85A4A">
-              <a:alpha val="12000"/>
-            </a:srgbClr>
-          </a:solidFill>
-          <a:ln w="12700">
-            <a:solidFill>
-              <a:srgbClr val="C85A4A"/>
-            </a:solidFill>
-          </a:ln>
-        </p:spPr>
-        <p:txBody>
-          <a:bodyPr/>
-          <a:lstStyle/>
-          <a:p/>
-        </p:txBody>
-      </p:sp>
-      <p:sp>
-        <p:nvSpPr>
-          <p:cNvPr id="22" name="tb22"/>
-          <p:cNvSpPr txBox="1"/>
-          <p:nvPr/>
-        </p:nvSpPr>
-        <p:spPr>
-          <a:xfrm>
-            <a:off x="950000" y="4230000"/>
-            <a:ext cx="10300000" cy="320000"/>
-          </a:xfrm>
-          <a:prstGeom prst="rect">
-            <a:avLst/>
-          </a:prstGeom>
-        </p:spPr>
-        <p:txBody>
-          <a:bodyPr wrap="square" rtlCol="0" anchor="t">
-            <a:normAutofit/>
-          </a:bodyPr>
-          <a:lstStyle/>
-          <a:p>
-            <a:pPr algn="l">
-              <a:lnSpc>
-                <a:spcPct val="100000"/>
-              </a:lnSpc>
-            </a:pPr>
-            <a:r>
-              <a:rPr lang="it-IT" sz="1150" b="0" dirty="0">
-                <a:solidFill>
-                  <a:srgbClr val="A8A29A"/>
-                </a:solidFill>
-                <a:latin typeface="Trebuchet MS"/>
-              </a:rPr>
-              <a:t>Wallets do not exist in the blockchain: they have to be inferred by grouping addresses, which is a connected components problem.</a:t>
-            </a:r>
-          </a:p>
-        </p:txBody>
-      </p:sp>
-      <p:sp>
-        <p:nvSpPr>
-          <p:cNvPr id="23" name="tb23"/>
-          <p:cNvSpPr txBox="1"/>
-          <p:nvPr/>
-        </p:nvSpPr>
-        <p:spPr>
-          <a:xfrm>
-            <a:off x="950000" y="4580000"/>
-            <a:ext cx="5000000" cy="300000"/>
-          </a:xfrm>
-          <a:prstGeom prst="rect">
-            <a:avLst/>
-          </a:prstGeom>
-        </p:spPr>
-        <p:txBody>
-          <a:bodyPr wrap="square" rtlCol="0" anchor="t">
-            <a:normAutofit/>
-          </a:bodyPr>
-          <a:lstStyle/>
-          <a:p>
-            <a:pPr algn="l">
-              <a:lnSpc>
-                <a:spcPct val="100000"/>
-              </a:lnSpc>
-            </a:pPr>
-            <a:r>
-              <a:rPr lang="it-IT" sz="1150" b="1" dirty="0">
-                <a:solidFill>
-                  <a:srgbClr val="4FB59C"/>
-                </a:solidFill>
-                <a:latin typeface="Trebuchet MS"/>
-              </a:rPr>
-              <a:t>Neo4j: </a:t>
-            </a:r>
-            <a:r>
-              <a:rPr lang="it-IT" sz="1150" b="0" dirty="0">
-                <a:solidFill>
-                  <a:srgbClr val="A8A29A"/>
-                </a:solidFill>
-                <a:latin typeface="Trebuchet MS"/>
-              </a:rPr>
-              <a:t>84 minutes with gds.wcc, then the query runs in 12.3 s</a:t>
-            </a:r>
-          </a:p>
-        </p:txBody>
-      </p:sp>
-      <p:sp>
-        <p:nvSpPr>
-          <p:cNvPr id="24" name="tb24"/>
-          <p:cNvSpPr txBox="1"/>
-          <p:nvPr/>
-        </p:nvSpPr>
-        <p:spPr>
-          <a:xfrm>
-            <a:off x="950000" y="4880000"/>
-            <a:ext cx="10300000" cy="620000"/>
-          </a:xfrm>
-          <a:prstGeom prst="rect">
-            <a:avLst/>
-          </a:prstGeom>
-        </p:spPr>
-        <p:txBody>
-          <a:bodyPr wrap="square" rtlCol="0" anchor="t">
-            <a:normAutofit/>
-          </a:bodyPr>
-          <a:lstStyle/>
-          <a:p>
-            <a:pPr algn="l">
-              <a:lnSpc>
-                <a:spcPct val="100000"/>
-              </a:lnSpc>
-            </a:pPr>
-            <a:r>
-              <a:rPr lang="it-IT" sz="1150" b="1" dirty="0">
-                <a:solidFill>
-                  <a:srgbClr val="D9A441"/>
-                </a:solidFill>
-                <a:latin typeface="Trebuchet MS"/>
-              </a:rPr>
-              <a:t>SQLite: </a:t>
-            </a:r>
-            <a:r>
-              <a:rPr lang="it-IT" sz="1150" b="0" dirty="0">
-                <a:solidFill>
-                  <a:srgbClr val="A8A29A"/>
-                </a:solidFill>
-                <a:latin typeface="Trebuchet MS"/>
-              </a:rPr>
-              <a:t>no time at all, because the grouping never finishes. It works in rounds, each one spreading a label to neighbouring addresses, and every round has to scan the entire co-ownership table again: 276 million rows, joined against itself. Neo4j loads that graph into memory once and walks it; SQLite rereads it from disk on every pass.</a:t>
-            </a:r>
-          </a:p>
-        </p:txBody>
-      </p:sp>
-      <p:sp>
-        <p:nvSpPr>
-          <p:cNvPr id="30" name="tb30"/>
-          <p:cNvSpPr txBox="1"/>
-          <p:nvPr/>
-        </p:nvSpPr>
-        <p:spPr>
-          <a:xfrm>
-            <a:off x="700000" y="5620000"/>
-            <a:ext cx="10800000" cy="600000"/>
-          </a:xfrm>
-          <a:prstGeom prst="rect">
-            <a:avLst/>
-          </a:prstGeom>
-        </p:spPr>
-        <p:txBody>
-          <a:bodyPr wrap="square" rtlCol="0" anchor="t">
-            <a:normAutofit/>
-          </a:bodyPr>
-          <a:lstStyle/>
-          <a:p>
-            <a:pPr algn="l">
-              <a:lnSpc>
-                <a:spcPct val="100000"/>
-              </a:lnSpc>
-            </a:pPr>
-            <a:r>
-              <a:rPr lang="it-IT" sz="1250" b="1" dirty="0">
-                <a:solidFill>
-                  <a:srgbClr val="F2EFE9"/>
-                </a:solidFill>
-                <a:latin typeface="Trebuchet MS"/>
-              </a:rPr>
-              <a:t>So Q7 is not a case of one engine being slower. </a:t>
-            </a:r>
-            <a:r>
-              <a:rPr lang="it-IT" sz="1250" b="0" dirty="0">
-                <a:solidFill>
-                  <a:srgbClr val="A8A29A"/>
-                </a:solidFill>
-                <a:latin typeface="Trebuchet MS"/>
-              </a:rPr>
-              <a:t>It is a query that only one of the two models can answer here, and only by paying 84 minutes up front, once, the way you would with a materialised view.</a:t>
+              <a:t>, not even on 50 blocks. It is not slow, it is the wrong shape of query for this model.</a:t>
             </a:r>
           </a:p>
         </p:txBody>
@@ -1282,462 +821,6 @@
                                         <p:cTn id="39" dur="400"/>
                                         <p:tgtEl>
                                           <p:spTgt spid="11"/>
-                                        </p:tgtEl>
-                                      </p:cBhvr>
-                                    </p:animEffect>
-                                  </p:childTnLst>
-                                </p:cTn>
-                              </p:par>
-                            </p:childTnLst>
-                          </p:cTn>
-                        </p:par>
-                      </p:childTnLst>
-                    </p:cTn>
-                  </p:par>
-                  <p:par>
-                    <p:cTn id="55" fill="hold">
-                      <p:stCondLst>
-                        <p:cond delay="indefinite"/>
-                      </p:stCondLst>
-                      <p:childTnLst>
-                        <p:par>
-                          <p:cTn id="56" fill="hold">
-                            <p:stCondLst>
-                              <p:cond delay="0"/>
-                            </p:stCondLst>
-                            <p:childTnLst>
-                              <p:par>
-                                <p:cTn id="52" presetID="10" presetClass="entr" presetSubtype="0" fill="hold" nodeType="clickEffect">
-                                  <p:stCondLst>
-                                    <p:cond delay="0"/>
-                                  </p:stCondLst>
-                                  <p:childTnLst>
-                                    <p:set>
-                                      <p:cBhvr>
-                                        <p:cTn id="53" dur="1" fill="hold">
-                                          <p:stCondLst>
-                                            <p:cond delay="0"/>
-                                          </p:stCondLst>
-                                        </p:cTn>
-                                        <p:tgtEl>
-                                          <p:spTgt spid="12"/>
-                                        </p:tgtEl>
-                                        <p:attrNameLst>
-                                          <p:attrName>style.visibility</p:attrName>
-                                        </p:attrNameLst>
-                                      </p:cBhvr>
-                                      <p:to>
-                                        <p:strVal val="visible"/>
-                                      </p:to>
-                                    </p:set>
-                                    <p:animEffect transition="in" filter="fade">
-                                      <p:cBhvr>
-                                        <p:cTn id="54" dur="400"/>
-                                        <p:tgtEl>
-                                          <p:spTgt spid="12"/>
-                                        </p:tgtEl>
-                                      </p:cBhvr>
-                                    </p:animEffect>
-                                  </p:childTnLst>
-                                </p:cTn>
-                              </p:par>
-                            </p:childTnLst>
-                          </p:cTn>
-                        </p:par>
-                      </p:childTnLst>
-                    </p:cTn>
-                  </p:par>
-                  <p:par>
-                    <p:cTn id="120" fill="hold">
-                      <p:stCondLst>
-                        <p:cond delay="indefinite"/>
-                      </p:stCondLst>
-                      <p:childTnLst>
-                        <p:par>
-                          <p:cTn id="121" fill="hold">
-                            <p:stCondLst>
-                              <p:cond delay="0"/>
-                            </p:stCondLst>
-                            <p:childTnLst>
-                              <p:par>
-                                <p:cTn id="67" presetID="10" presetClass="entr" presetSubtype="0" fill="hold" nodeType="clickEffect">
-                                  <p:stCondLst>
-                                    <p:cond delay="0"/>
-                                  </p:stCondLst>
-                                  <p:childTnLst>
-                                    <p:set>
-                                      <p:cBhvr>
-                                        <p:cTn id="68" dur="1" fill="hold">
-                                          <p:stCondLst>
-                                            <p:cond delay="0"/>
-                                          </p:stCondLst>
-                                        </p:cTn>
-                                        <p:tgtEl>
-                                          <p:spTgt spid="13"/>
-                                        </p:tgtEl>
-                                        <p:attrNameLst>
-                                          <p:attrName>style.visibility</p:attrName>
-                                        </p:attrNameLst>
-                                      </p:cBhvr>
-                                      <p:to>
-                                        <p:strVal val="visible"/>
-                                      </p:to>
-                                    </p:set>
-                                    <p:animEffect transition="in" filter="fade">
-                                      <p:cBhvr>
-                                        <p:cTn id="69" dur="400"/>
-                                        <p:tgtEl>
-                                          <p:spTgt spid="13"/>
-                                        </p:tgtEl>
-                                      </p:cBhvr>
-                                    </p:animEffect>
-                                  </p:childTnLst>
-                                </p:cTn>
-                              </p:par>
-                              <p:par>
-                                <p:cTn id="72" presetID="10" presetClass="entr" presetSubtype="0" fill="hold" nodeType="withEffect">
-                                  <p:stCondLst>
-                                    <p:cond delay="0"/>
-                                  </p:stCondLst>
-                                  <p:childTnLst>
-                                    <p:set>
-                                      <p:cBhvr>
-                                        <p:cTn id="73" dur="1" fill="hold">
-                                          <p:stCondLst>
-                                            <p:cond delay="0"/>
-                                          </p:stCondLst>
-                                        </p:cTn>
-                                        <p:tgtEl>
-                                          <p:spTgt spid="14"/>
-                                        </p:tgtEl>
-                                        <p:attrNameLst>
-                                          <p:attrName>style.visibility</p:attrName>
-                                        </p:attrNameLst>
-                                      </p:cBhvr>
-                                      <p:to>
-                                        <p:strVal val="visible"/>
-                                      </p:to>
-                                    </p:set>
-                                    <p:animEffect transition="in" filter="fade">
-                                      <p:cBhvr>
-                                        <p:cTn id="74" dur="400"/>
-                                        <p:tgtEl>
-                                          <p:spTgt spid="14"/>
-                                        </p:tgtEl>
-                                      </p:cBhvr>
-                                    </p:animEffect>
-                                  </p:childTnLst>
-                                </p:cTn>
-                              </p:par>
-                              <p:par>
-                                <p:cTn id="77" presetID="10" presetClass="entr" presetSubtype="0" fill="hold" nodeType="withEffect">
-                                  <p:stCondLst>
-                                    <p:cond delay="0"/>
-                                  </p:stCondLst>
-                                  <p:childTnLst>
-                                    <p:set>
-                                      <p:cBhvr>
-                                        <p:cTn id="78" dur="1" fill="hold">
-                                          <p:stCondLst>
-                                            <p:cond delay="0"/>
-                                          </p:stCondLst>
-                                        </p:cTn>
-                                        <p:tgtEl>
-                                          <p:spTgt spid="15"/>
-                                        </p:tgtEl>
-                                        <p:attrNameLst>
-                                          <p:attrName>style.visibility</p:attrName>
-                                        </p:attrNameLst>
-                                      </p:cBhvr>
-                                      <p:to>
-                                        <p:strVal val="visible"/>
-                                      </p:to>
-                                    </p:set>
-                                    <p:animEffect transition="in" filter="fade">
-                                      <p:cBhvr>
-                                        <p:cTn id="79" dur="400"/>
-                                        <p:tgtEl>
-                                          <p:spTgt spid="15"/>
-                                        </p:tgtEl>
-                                      </p:cBhvr>
-                                    </p:animEffect>
-                                  </p:childTnLst>
-                                </p:cTn>
-                              </p:par>
-                              <p:par>
-                                <p:cTn id="82" presetID="10" presetClass="entr" presetSubtype="0" fill="hold" nodeType="withEffect">
-                                  <p:stCondLst>
-                                    <p:cond delay="0"/>
-                                  </p:stCondLst>
-                                  <p:childTnLst>
-                                    <p:set>
-                                      <p:cBhvr>
-                                        <p:cTn id="83" dur="1" fill="hold">
-                                          <p:stCondLst>
-                                            <p:cond delay="0"/>
-                                          </p:stCondLst>
-                                        </p:cTn>
-                                        <p:tgtEl>
-                                          <p:spTgt spid="16"/>
-                                        </p:tgtEl>
-                                        <p:attrNameLst>
-                                          <p:attrName>style.visibility</p:attrName>
-                                        </p:attrNameLst>
-                                      </p:cBhvr>
-                                      <p:to>
-                                        <p:strVal val="visible"/>
-                                      </p:to>
-                                    </p:set>
-                                    <p:animEffect transition="in" filter="fade">
-                                      <p:cBhvr>
-                                        <p:cTn id="84" dur="400"/>
-                                        <p:tgtEl>
-                                          <p:spTgt spid="16"/>
-                                        </p:tgtEl>
-                                      </p:cBhvr>
-                                    </p:animEffect>
-                                  </p:childTnLst>
-                                </p:cTn>
-                              </p:par>
-                              <p:par>
-                                <p:cTn id="87" presetID="10" presetClass="entr" presetSubtype="0" fill="hold" nodeType="withEffect">
-                                  <p:stCondLst>
-                                    <p:cond delay="0"/>
-                                  </p:stCondLst>
-                                  <p:childTnLst>
-                                    <p:set>
-                                      <p:cBhvr>
-                                        <p:cTn id="88" dur="1" fill="hold">
-                                          <p:stCondLst>
-                                            <p:cond delay="0"/>
-                                          </p:stCondLst>
-                                        </p:cTn>
-                                        <p:tgtEl>
-                                          <p:spTgt spid="17"/>
-                                        </p:tgtEl>
-                                        <p:attrNameLst>
-                                          <p:attrName>style.visibility</p:attrName>
-                                        </p:attrNameLst>
-                                      </p:cBhvr>
-                                      <p:to>
-                                        <p:strVal val="visible"/>
-                                      </p:to>
-                                    </p:set>
-                                    <p:animEffect transition="in" filter="fade">
-                                      <p:cBhvr>
-                                        <p:cTn id="89" dur="400"/>
-                                        <p:tgtEl>
-                                          <p:spTgt spid="17"/>
-                                        </p:tgtEl>
-                                      </p:cBhvr>
-                                    </p:animEffect>
-                                  </p:childTnLst>
-                                </p:cTn>
-                              </p:par>
-                              <p:par>
-                                <p:cTn id="92" presetID="10" presetClass="entr" presetSubtype="0" fill="hold" nodeType="withEffect">
-                                  <p:stCondLst>
-                                    <p:cond delay="0"/>
-                                  </p:stCondLst>
-                                  <p:childTnLst>
-                                    <p:set>
-                                      <p:cBhvr>
-                                        <p:cTn id="93" dur="1" fill="hold">
-                                          <p:stCondLst>
-                                            <p:cond delay="0"/>
-                                          </p:stCondLst>
-                                        </p:cTn>
-                                        <p:tgtEl>
-                                          <p:spTgt spid="20"/>
-                                        </p:tgtEl>
-                                        <p:attrNameLst>
-                                          <p:attrName>style.visibility</p:attrName>
-                                        </p:attrNameLst>
-                                      </p:cBhvr>
-                                      <p:to>
-                                        <p:strVal val="visible"/>
-                                      </p:to>
-                                    </p:set>
-                                    <p:animEffect transition="in" filter="fade">
-                                      <p:cBhvr>
-                                        <p:cTn id="94" dur="400"/>
-                                        <p:tgtEl>
-                                          <p:spTgt spid="20"/>
-                                        </p:tgtEl>
-                                      </p:cBhvr>
-                                    </p:animEffect>
-                                  </p:childTnLst>
-                                </p:cTn>
-                              </p:par>
-                              <p:par>
-                                <p:cTn id="97" presetID="10" presetClass="entr" presetSubtype="0" fill="hold" nodeType="withEffect">
-                                  <p:stCondLst>
-                                    <p:cond delay="0"/>
-                                  </p:stCondLst>
-                                  <p:childTnLst>
-                                    <p:set>
-                                      <p:cBhvr>
-                                        <p:cTn id="98" dur="1" fill="hold">
-                                          <p:stCondLst>
-                                            <p:cond delay="0"/>
-                                          </p:stCondLst>
-                                        </p:cTn>
-                                        <p:tgtEl>
-                                          <p:spTgt spid="21"/>
-                                        </p:tgtEl>
-                                        <p:attrNameLst>
-                                          <p:attrName>style.visibility</p:attrName>
-                                        </p:attrNameLst>
-                                      </p:cBhvr>
-                                      <p:to>
-                                        <p:strVal val="visible"/>
-                                      </p:to>
-                                    </p:set>
-                                    <p:animEffect transition="in" filter="fade">
-                                      <p:cBhvr>
-                                        <p:cTn id="99" dur="400"/>
-                                        <p:tgtEl>
-                                          <p:spTgt spid="21"/>
-                                        </p:tgtEl>
-                                      </p:cBhvr>
-                                    </p:animEffect>
-                                  </p:childTnLst>
-                                </p:cTn>
-                              </p:par>
-                              <p:par>
-                                <p:cTn id="102" presetID="10" presetClass="entr" presetSubtype="0" fill="hold" nodeType="withEffect">
-                                  <p:stCondLst>
-                                    <p:cond delay="0"/>
-                                  </p:stCondLst>
-                                  <p:childTnLst>
-                                    <p:set>
-                                      <p:cBhvr>
-                                        <p:cTn id="103" dur="1" fill="hold">
-                                          <p:stCondLst>
-                                            <p:cond delay="0"/>
-                                          </p:stCondLst>
-                                        </p:cTn>
-                                        <p:tgtEl>
-                                          <p:spTgt spid="22"/>
-                                        </p:tgtEl>
-                                        <p:attrNameLst>
-                                          <p:attrName>style.visibility</p:attrName>
-                                        </p:attrNameLst>
-                                      </p:cBhvr>
-                                      <p:to>
-                                        <p:strVal val="visible"/>
-                                      </p:to>
-                                    </p:set>
-                                    <p:animEffect transition="in" filter="fade">
-                                      <p:cBhvr>
-                                        <p:cTn id="104" dur="400"/>
-                                        <p:tgtEl>
-                                          <p:spTgt spid="22"/>
-                                        </p:tgtEl>
-                                      </p:cBhvr>
-                                    </p:animEffect>
-                                  </p:childTnLst>
-                                </p:cTn>
-                              </p:par>
-                              <p:par>
-                                <p:cTn id="107" presetID="10" presetClass="entr" presetSubtype="0" fill="hold" nodeType="withEffect">
-                                  <p:stCondLst>
-                                    <p:cond delay="0"/>
-                                  </p:stCondLst>
-                                  <p:childTnLst>
-                                    <p:set>
-                                      <p:cBhvr>
-                                        <p:cTn id="108" dur="1" fill="hold">
-                                          <p:stCondLst>
-                                            <p:cond delay="0"/>
-                                          </p:stCondLst>
-                                        </p:cTn>
-                                        <p:tgtEl>
-                                          <p:spTgt spid="23"/>
-                                        </p:tgtEl>
-                                        <p:attrNameLst>
-                                          <p:attrName>style.visibility</p:attrName>
-                                        </p:attrNameLst>
-                                      </p:cBhvr>
-                                      <p:to>
-                                        <p:strVal val="visible"/>
-                                      </p:to>
-                                    </p:set>
-                                    <p:animEffect transition="in" filter="fade">
-                                      <p:cBhvr>
-                                        <p:cTn id="109" dur="400"/>
-                                        <p:tgtEl>
-                                          <p:spTgt spid="23"/>
-                                        </p:tgtEl>
-                                      </p:cBhvr>
-                                    </p:animEffect>
-                                  </p:childTnLst>
-                                </p:cTn>
-                              </p:par>
-                              <p:par>
-                                <p:cTn id="112" presetID="10" presetClass="entr" presetSubtype="0" fill="hold" nodeType="withEffect">
-                                  <p:stCondLst>
-                                    <p:cond delay="0"/>
-                                  </p:stCondLst>
-                                  <p:childTnLst>
-                                    <p:set>
-                                      <p:cBhvr>
-                                        <p:cTn id="113" dur="1" fill="hold">
-                                          <p:stCondLst>
-                                            <p:cond delay="0"/>
-                                          </p:stCondLst>
-                                        </p:cTn>
-                                        <p:tgtEl>
-                                          <p:spTgt spid="24"/>
-                                        </p:tgtEl>
-                                        <p:attrNameLst>
-                                          <p:attrName>style.visibility</p:attrName>
-                                        </p:attrNameLst>
-                                      </p:cBhvr>
-                                      <p:to>
-                                        <p:strVal val="visible"/>
-                                      </p:to>
-                                    </p:set>
-                                    <p:animEffect transition="in" filter="fade">
-                                      <p:cBhvr>
-                                        <p:cTn id="114" dur="400"/>
-                                        <p:tgtEl>
-                                          <p:spTgt spid="24"/>
-                                        </p:tgtEl>
-                                      </p:cBhvr>
-                                    </p:animEffect>
-                                  </p:childTnLst>
-                                </p:cTn>
-                              </p:par>
-                              <p:par>
-                                <p:cTn id="117" presetID="10" presetClass="entr" presetSubtype="0" fill="hold" nodeType="withEffect">
-                                  <p:stCondLst>
-                                    <p:cond delay="0"/>
-                                  </p:stCondLst>
-                                  <p:childTnLst>
-                                    <p:set>
-                                      <p:cBhvr>
-                                        <p:cTn id="118" dur="1" fill="hold">
-                                          <p:stCondLst>
-                                            <p:cond delay="0"/>
-                                          </p:stCondLst>
-                                        </p:cTn>
-                                        <p:tgtEl>
-                                          <p:spTgt spid="30"/>
-                                        </p:tgtEl>
-                                        <p:attrNameLst>
-                                          <p:attrName>style.visibility</p:attrName>
-                                        </p:attrNameLst>
-                                      </p:cBhvr>
-                                      <p:to>
-                                        <p:strVal val="visible"/>
-                                      </p:to>
-                                    </p:set>
-                                    <p:animEffect transition="in" filter="fade">
-                                      <p:cBhvr>
-                                        <p:cTn id="119" dur="400"/>
-                                        <p:tgtEl>
-                                          <p:spTgt spid="30"/>
                                         </p:tgtEl>
                                       </p:cBhvr>
                                     </p:animEffect>
@@ -1862,7 +945,7 @@
                 </a:solidFill>
                 <a:latin typeface="Trebuchet MS"/>
               </a:rPr>
-              <a:t>CONCLUSIONS</a:t>
+              <a:t>SCALING</a:t>
             </a:r>
           </a:p>
         </p:txBody>
@@ -1900,7 +983,7 @@
                 </a:solidFill>
                 <a:latin typeface="Georgia"/>
               </a:rPr>
-              <a:t>What I take away from this</a:t>
+              <a:t>Queries: the two engines together</a:t>
             </a:r>
           </a:p>
         </p:txBody>
@@ -1943,95 +1026,39 @@
           </a:p>
         </p:txBody>
       </p:sp>
-      <p:sp>
-        <p:nvSpPr>
-          <p:cNvPr id="10" name="bl10"/>
+      <p:pic>
+        <p:nvPicPr>
+          <p:cNvPr id="10" name="pic10"/>
+          <p:cNvPicPr>
+            <a:picLocks noChangeAspect="1"/>
+          </p:cNvPicPr>
+          <p:nvPr/>
+        </p:nvPicPr>
+        <p:blipFill>
+          <a:blip r:embed="rId2"/>
+          <a:stretch>
+            <a:fillRect/>
+          </a:stretch>
+        </p:blipFill>
+        <p:spPr>
+          <a:xfrm>
+            <a:off x="1000000" y="1560000"/>
+            <a:ext cx="10200000" cy="4020000"/>
+          </a:xfrm>
+          <a:prstGeom prst="rect">
+            <a:avLst/>
+          </a:prstGeom>
+        </p:spPr>
+      </p:pic>
+      <p:sp>
+        <p:nvSpPr>
+          <p:cNvPr id="11" name="tb11"/>
           <p:cNvSpPr txBox="1"/>
           <p:nvPr/>
         </p:nvSpPr>
         <p:spPr>
           <a:xfrm>
-            <a:off x="700000" y="1850000"/>
-            <a:ext cx="10800000" cy="3400000"/>
-          </a:xfrm>
-          <a:prstGeom prst="rect">
-            <a:avLst/>
-          </a:prstGeom>
-        </p:spPr>
-        <p:txBody>
-          <a:bodyPr wrap="square" rtlCol="0">
-            <a:normAutofit/>
-          </a:bodyPr>
-          <a:lstStyle/>
-          <a:p>
-            <a:pPr marL="285750" indent="-285750">
-              <a:lnSpc>
-                <a:spcPct val="150000"/>
-              </a:lnSpc>
-              <a:spcBef>
-                <a:spcPts val="600"/>
-              </a:spcBef>
-              <a:buChar char="–"/>
-            </a:pPr>
-            <a:r>
-              <a:rPr lang="it-IT" sz="1400" b="1" dirty="0">
-                <a:solidFill>
-                  <a:srgbClr val="F2EFE9"/>
-                </a:solidFill>
-                <a:latin typeface="Trebuchet MS"/>
-              </a:rPr>
-              <a:t>You pay either up front or at query time.</a:t>
-            </a:r>
-            <a:r>
-              <a:rPr lang="it-IT" sz="1400" b="0" dirty="0">
-                <a:solidFill>
-                  <a:srgbClr val="A8A29A"/>
-                </a:solidFill>
-                <a:latin typeface="Trebuchet MS"/>
-              </a:rPr>
-              <a:t> The graph materialises relationships while loading and sells them back as speed when you query. Whether that trade is worth it depends on how often you query.</a:t>
-            </a:r>
-          </a:p>
-          <a:p>
-            <a:pPr marL="285750" indent="-285750">
-              <a:lnSpc>
-                <a:spcPct val="150000"/>
-              </a:lnSpc>
-              <a:spcBef>
-                <a:spcPts val="600"/>
-              </a:spcBef>
-              <a:buChar char="–"/>
-            </a:pPr>
-            <a:r>
-              <a:rPr lang="it-IT" sz="1400" b="1" dirty="0">
-                <a:solidFill>
-                  <a:srgbClr val="F2EFE9"/>
-                </a:solidFill>
-                <a:latin typeface="Trebuchet MS"/>
-              </a:rPr>
-              <a:t>Measuring changed my conclusions.</a:t>
-            </a:r>
-            <a:r>
-              <a:rPr lang="it-IT" sz="1400" b="0" dirty="0">
-                <a:solidFill>
-                  <a:srgbClr val="A8A29A"/>
-                </a:solidFill>
-                <a:latin typeface="Trebuchet MS"/>
-              </a:rPr>
-              <a:t> I had assumed the graph would win everywhere. It does not, and the exceptions turned out to be the interesting part.</a:t>
-            </a:r>
-          </a:p>
-        </p:txBody>
-      </p:sp>
-      <p:sp>
-        <p:nvSpPr>
-          <p:cNvPr id="20" name="tb20"/>
-          <p:cNvSpPr txBox="1"/>
-          <p:nvPr/>
-        </p:nvSpPr>
-        <p:spPr>
-          <a:xfrm>
-            <a:off x="700000" y="5420000"/>
+            <a:off x="700000" y="5700000"/>
             <a:ext cx="10800000" cy="600000"/>
           </a:xfrm>
           <a:prstGeom prst="rect">
@@ -2050,22 +1077,49 @@
               </a:lnSpc>
             </a:pPr>
             <a:r>
-              <a:rPr lang="it-IT" sz="1250" b="0" dirty="0">
-                <a:solidFill>
-                  <a:srgbClr val="6E6862"/>
-                </a:solidFill>
-                <a:latin typeface="Trebuchet MS"/>
-              </a:rPr>
-              <a:t>Stated limits: </a:t>
-            </a:r>
-            <a:r>
-              <a:rPr lang="it-IT" sz="1250" b="0" dirty="0">
+              <a:rPr lang="it-IT" sz="1350" b="0" dirty="0">
                 <a:solidFill>
                   <a:srgbClr val="A8A29A"/>
                 </a:solidFill>
                 <a:latin typeface="Trebuchet MS"/>
               </a:rPr>
-              <a:t>one machine, a 977-block window chosen for practicality, and clustering is a heuristic, not a certainty.</a:t>
+              <a:t>Not the times but the </a:t>
+            </a:r>
+            <a:r>
+              <a:rPr lang="it-IT" sz="1350" b="1" dirty="0">
+                <a:solidFill>
+                  <a:srgbClr val="F2EFE9"/>
+                </a:solidFill>
+                <a:latin typeface="Trebuchet MS"/>
+              </a:rPr>
+              <a:t>ratio between the two</a:t>
+            </a:r>
+            <a:r>
+              <a:rPr lang="it-IT" sz="1350" b="0" dirty="0">
+                <a:solidFill>
+                  <a:srgbClr val="A8A29A"/>
+                </a:solidFill>
+                <a:latin typeface="Trebuchet MS"/>
+              </a:rPr>
+              <a:t>: above the line Neo4j is faster, below it SQLite is. The lines are nearly flat, so </a:t>
+            </a:r>
+            <a:r>
+              <a:rPr lang="it-IT" sz="1350" b="1" dirty="0">
+                <a:solidFill>
+                  <a:srgbClr val="F2EFE9"/>
+                </a:solidFill>
+                <a:latin typeface="Trebuchet MS"/>
+              </a:rPr>
+              <a:t>who wins is decided by the query, not by the size</a:t>
+            </a:r>
+            <a:r>
+              <a:rPr lang="it-IT" sz="1350" b="0" dirty="0">
+                <a:solidFill>
+                  <a:srgbClr val="A8A29A"/>
+                </a:solidFill>
+                <a:latin typeface="Trebuchet MS"/>
+              </a:rPr>
+              <a:t>.</a:t>
             </a:r>
           </a:p>
         </p:txBody>
@@ -2165,7 +1219,7 @@
                                           </p:stCondLst>
                                         </p:cTn>
                                         <p:tgtEl>
-                                          <p:spTgt spid="20"/>
+                                          <p:spTgt spid="11"/>
                                         </p:tgtEl>
                                         <p:attrNameLst>
                                           <p:attrName>style.visibility</p:attrName>
@@ -2179,7 +1233,7 @@
                                       <p:cBhvr>
                                         <p:cTn id="39" dur="400"/>
                                         <p:tgtEl>
-                                          <p:spTgt spid="20"/>
+                                          <p:spTgt spid="11"/>
                                         </p:tgtEl>
                                       </p:cBhvr>
                                     </p:animEffect>
@@ -2304,7 +1358,7 @@
                 </a:solidFill>
                 <a:latin typeface="Trebuchet MS"/>
               </a:rPr>
-              <a:t>5 MINUTES</a:t>
+              <a:t>TRADE-OFFS</a:t>
             </a:r>
           </a:p>
         </p:txBody>
@@ -2342,7 +1396,7 @@
                 </a:solidFill>
                 <a:latin typeface="Georgia"/>
               </a:rPr>
-              <a:t>Live demo</a:t>
+              <a:t>The cost you don't see in query timings</a:t>
             </a:r>
           </a:p>
         </p:txBody>
@@ -2393,8 +1447,8 @@
         </p:nvSpPr>
         <p:spPr>
           <a:xfrm>
-            <a:off x="700000" y="1760000"/>
-            <a:ext cx="10800000" cy="450000"/>
+            <a:off x="700000" y="1700000"/>
+            <a:ext cx="10800000" cy="330000"/>
           </a:xfrm>
           <a:prstGeom prst="rect">
             <a:avLst/>
@@ -2412,27 +1466,27 @@
               </a:lnSpc>
             </a:pPr>
             <a:r>
-              <a:rPr lang="it-IT" sz="1350" b="0" dirty="0">
-                <a:solidFill>
-                  <a:srgbClr val="A8A29A"/>
-                </a:solidFill>
-                <a:latin typeface="Trebuchet MS"/>
-              </a:rPr>
-              <a:t>A 50-transaction slice of the same data, small enough to read on screen. It loads into Neo4j in 2 seconds instead of 40 minutes.</a:t>
-            </a:r>
-          </a:p>
-        </p:txBody>
-      </p:sp>
-      <p:sp>
-        <p:nvSpPr>
-          <p:cNvPr id="20" name="rc20"/>
+              <a:rPr lang="it-IT" sz="1350" b="1" dirty="0">
+                <a:solidFill>
+                  <a:srgbClr val="F2EFE9"/>
+                </a:solidFill>
+                <a:latin typeface="Trebuchet MS"/>
+              </a:rPr>
+              <a:t>1. Loading the data, paid once per database</a:t>
+            </a:r>
+          </a:p>
+        </p:txBody>
+      </p:sp>
+      <p:sp>
+        <p:nvSpPr>
+          <p:cNvPr id="11" name="rc11"/>
           <p:cNvSpPr/>
           <p:nvPr/>
         </p:nvSpPr>
         <p:spPr>
           <a:xfrm>
-            <a:off x="700000" y="2320000"/>
-            <a:ext cx="5250000" cy="2400000"/>
+            <a:off x="700000" y="2070000"/>
+            <a:ext cx="5250000" cy="1150000"/>
           </a:xfrm>
           <a:prstGeom prst="roundRect">
             <a:avLst>
@@ -2458,14 +1512,14 @@
       </p:sp>
       <p:sp>
         <p:nvSpPr>
-          <p:cNvPr id="21" name="tb21"/>
+          <p:cNvPr id="12" name="tb12"/>
           <p:cNvSpPr txBox="1"/>
           <p:nvPr/>
         </p:nvSpPr>
         <p:spPr>
           <a:xfrm>
-            <a:off x="950000" y="2460000"/>
-            <a:ext cx="4750000" cy="400000"/>
+            <a:off x="950000" y="2190000"/>
+            <a:ext cx="4750000" cy="300000"/>
           </a:xfrm>
           <a:prstGeom prst="rect">
             <a:avLst/>
@@ -2483,7 +1537,7 @@
               </a:lnSpc>
             </a:pPr>
             <a:r>
-              <a:rPr lang="it-IT" sz="1450" b="1" dirty="0">
+              <a:rPr lang="it-IT" sz="1200" b="1" dirty="0">
                 <a:solidFill>
                   <a:srgbClr val="D9A441"/>
                 </a:solidFill>
@@ -2496,14 +1550,14 @@
       </p:sp>
       <p:sp>
         <p:nvSpPr>
-          <p:cNvPr id="22" name="tb22"/>
+          <p:cNvPr id="13" name="tb13"/>
           <p:cNvSpPr txBox="1"/>
           <p:nvPr/>
         </p:nvSpPr>
         <p:spPr>
           <a:xfrm>
-            <a:off x="950000" y="2880000"/>
-            <a:ext cx="4750000" cy="300000"/>
+            <a:off x="950000" y="2510000"/>
+            <a:ext cx="4750000" cy="600000"/>
           </a:xfrm>
           <a:prstGeom prst="rect">
             <a:avLst/>
@@ -2521,147 +1575,27 @@
               </a:lnSpc>
             </a:pPr>
             <a:r>
-              <a:rPr lang="it-IT" sz="1050" b="0" dirty="0">
-                <a:solidFill>
-                  <a:srgbClr val="F2EFE9"/>
-                </a:solidFill>
-                <a:latin typeface="Consolas"/>
-              </a:rPr>
-              <a:t>python3 demo/serve_sqlite.py</a:t>
-            </a:r>
-          </a:p>
-        </p:txBody>
-      </p:sp>
-      <p:sp>
-        <p:nvSpPr>
-          <p:cNvPr id="23" name="tb23"/>
-          <p:cNvSpPr txBox="1"/>
-          <p:nvPr/>
-        </p:nvSpPr>
-        <p:spPr>
-          <a:xfrm>
-            <a:off x="950000" y="3170000"/>
-            <a:ext cx="4750000" cy="300000"/>
-          </a:xfrm>
-          <a:prstGeom prst="rect">
-            <a:avLst/>
-          </a:prstGeom>
-        </p:spPr>
-        <p:txBody>
-          <a:bodyPr wrap="square" rtlCol="0" anchor="t">
-            <a:normAutofit/>
-          </a:bodyPr>
-          <a:lstStyle/>
-          <a:p>
-            <a:pPr algn="l">
-              <a:lnSpc>
-                <a:spcPct val="100000"/>
-              </a:lnSpc>
-            </a:pPr>
-            <a:r>
-              <a:rPr lang="it-IT" sz="1050" b="0" dirty="0">
-                <a:solidFill>
-                  <a:srgbClr val="6E6862"/>
-                </a:solidFill>
-                <a:latin typeface="Consolas"/>
-              </a:rPr>
-              <a:t>127.0.0.1:8000</a:t>
-            </a:r>
-          </a:p>
-        </p:txBody>
-      </p:sp>
-      <p:sp>
-        <p:nvSpPr>
-          <p:cNvPr id="24" name="bl24"/>
-          <p:cNvSpPr txBox="1"/>
-          <p:nvPr/>
-        </p:nvSpPr>
-        <p:spPr>
-          <a:xfrm>
-            <a:off x="950000" y="3500000"/>
-            <a:ext cx="4750000" cy="1200000"/>
-          </a:xfrm>
-          <a:prstGeom prst="rect">
-            <a:avLst/>
-          </a:prstGeom>
-        </p:spPr>
-        <p:txBody>
-          <a:bodyPr wrap="square" rtlCol="0">
-            <a:normAutofit/>
-          </a:bodyPr>
-          <a:lstStyle/>
-          <a:p>
-            <a:pPr marL="285750" indent="-285750">
-              <a:lnSpc>
-                <a:spcPct val="150000"/>
-              </a:lnSpc>
-              <a:spcBef>
-                <a:spcPts val="600"/>
-              </a:spcBef>
-              <a:buChar char="–"/>
-            </a:pPr>
-            <a:r>
               <a:rPr lang="it-IT" sz="1200" b="0" dirty="0">
                 <a:solidFill>
                   <a:srgbClr val="A8A29A"/>
                 </a:solidFill>
                 <a:latin typeface="Trebuchet MS"/>
               </a:rPr>
-              <a:t>Browse the tables with real rows in them</a:t>
-            </a:r>
-          </a:p>
-          <a:p>
-            <a:pPr marL="285750" indent="-285750">
-              <a:lnSpc>
-                <a:spcPct val="150000"/>
-              </a:lnSpc>
-              <a:spcBef>
-                <a:spcPts val="600"/>
-              </a:spcBef>
-              <a:buChar char="–"/>
-            </a:pPr>
-            <a:r>
-              <a:rPr lang="it-IT" sz="1200" b="0" dirty="0">
-                <a:solidFill>
-                  <a:srgbClr val="A8A29A"/>
-                </a:solidFill>
-                <a:latin typeface="Trebuchet MS"/>
-              </a:rPr>
-              <a:t>Run Q1 to Q8 with one click</a:t>
-            </a:r>
-          </a:p>
-          <a:p>
-            <a:pPr marL="285750" indent="-285750">
-              <a:lnSpc>
-                <a:spcPct val="150000"/>
-              </a:lnSpc>
-              <a:spcBef>
-                <a:spcPts val="600"/>
-              </a:spcBef>
-              <a:buChar char="–"/>
-            </a:pPr>
-            <a:r>
-              <a:rPr lang="it-IT" sz="1200" b="0" dirty="0">
-                <a:solidFill>
-                  <a:srgbClr val="A8A29A"/>
-                </a:solidFill>
-                <a:latin typeface="Trebuchet MS"/>
-              </a:rPr>
-              <a:t>Free SQL editor for questions on the spot</a:t>
-            </a:r>
-          </a:p>
-        </p:txBody>
-      </p:sp>
-      <p:sp>
-        <p:nvSpPr>
-          <p:cNvPr id="30" name="rc30"/>
+              <a:t>9.4 min, 6.2 GB, no tuning at all</a:t>
+            </a:r>
+          </a:p>
+        </p:txBody>
+      </p:sp>
+      <p:sp>
+        <p:nvSpPr>
+          <p:cNvPr id="14" name="rc14"/>
           <p:cNvSpPr/>
           <p:nvPr/>
         </p:nvSpPr>
         <p:spPr>
           <a:xfrm>
-            <a:off x="6250000" y="2320000"/>
-            <a:ext cx="5250000" cy="2400000"/>
+            <a:off x="6250000" y="2070000"/>
+            <a:ext cx="5250000" cy="1150000"/>
           </a:xfrm>
           <a:prstGeom prst="roundRect">
             <a:avLst>
@@ -2687,14 +1621,14 @@
       </p:sp>
       <p:sp>
         <p:nvSpPr>
-          <p:cNvPr id="31" name="tb31"/>
+          <p:cNvPr id="15" name="tb15"/>
           <p:cNvSpPr txBox="1"/>
           <p:nvPr/>
         </p:nvSpPr>
         <p:spPr>
           <a:xfrm>
-            <a:off x="6500000" y="2460000"/>
-            <a:ext cx="4750000" cy="400000"/>
+            <a:off x="6500000" y="2190000"/>
+            <a:ext cx="4750000" cy="300000"/>
           </a:xfrm>
           <a:prstGeom prst="rect">
             <a:avLst/>
@@ -2712,27 +1646,27 @@
               </a:lnSpc>
             </a:pPr>
             <a:r>
-              <a:rPr lang="it-IT" sz="1450" b="1" dirty="0">
+              <a:rPr lang="it-IT" sz="1200" b="1" dirty="0">
                 <a:solidFill>
                   <a:srgbClr val="4FB59C"/>
                 </a:solidFill>
                 <a:latin typeface="Trebuchet MS"/>
               </a:rPr>
-              <a:t>Neo4j Browser</a:t>
-            </a:r>
-          </a:p>
-        </p:txBody>
-      </p:sp>
-      <p:sp>
-        <p:nvSpPr>
-          <p:cNvPr id="32" name="tb32"/>
+              <a:t>Neo4j</a:t>
+            </a:r>
+          </a:p>
+        </p:txBody>
+      </p:sp>
+      <p:sp>
+        <p:nvSpPr>
+          <p:cNvPr id="16" name="tb16"/>
           <p:cNvSpPr txBox="1"/>
           <p:nvPr/>
         </p:nvSpPr>
         <p:spPr>
           <a:xfrm>
-            <a:off x="6500000" y="2880000"/>
-            <a:ext cx="4750000" cy="300000"/>
+            <a:off x="6500000" y="2510000"/>
+            <a:ext cx="4750000" cy="600000"/>
           </a:xfrm>
           <a:prstGeom prst="rect">
             <a:avLst/>
@@ -2750,27 +1684,27 @@
               </a:lnSpc>
             </a:pPr>
             <a:r>
-              <a:rPr lang="it-IT" sz="1050" b="0" dirty="0">
-                <a:solidFill>
-                  <a:srgbClr val="F2EFE9"/>
-                </a:solidFill>
-                <a:latin typeface="Consolas"/>
-              </a:rPr>
-              <a:t>docker start nodecoin-neo4j</a:t>
-            </a:r>
-          </a:p>
-        </p:txBody>
-      </p:sp>
-      <p:sp>
-        <p:nvSpPr>
-          <p:cNvPr id="33" name="tb33"/>
+              <a:rPr lang="it-IT" sz="1200" b="0" dirty="0">
+                <a:solidFill>
+                  <a:srgbClr val="A8A29A"/>
+                </a:solidFill>
+                <a:latin typeface="Trebuchet MS"/>
+              </a:rPr>
+              <a:t>40.2 min, 16.3 GB, 8 GB of heap required</a:t>
+            </a:r>
+          </a:p>
+        </p:txBody>
+      </p:sp>
+      <p:sp>
+        <p:nvSpPr>
+          <p:cNvPr id="17" name="tb17"/>
           <p:cNvSpPr txBox="1"/>
           <p:nvPr/>
         </p:nvSpPr>
         <p:spPr>
           <a:xfrm>
-            <a:off x="6500000" y="3170000"/>
-            <a:ext cx="4750000" cy="300000"/>
+            <a:off x="700000" y="3270000"/>
+            <a:ext cx="10800000" cy="300000"/>
           </a:xfrm>
           <a:prstGeom prst="rect">
             <a:avLst/>
@@ -2788,109 +1722,65 @@
               </a:lnSpc>
             </a:pPr>
             <a:r>
-              <a:rPr lang="it-IT" sz="1050" b="0" dirty="0">
-                <a:solidFill>
-                  <a:srgbClr val="6E6862"/>
-                </a:solidFill>
-                <a:latin typeface="Consolas"/>
-              </a:rPr>
-              <a:t>localhost:7474</a:t>
-            </a:r>
-          </a:p>
-        </p:txBody>
-      </p:sp>
-      <p:sp>
-        <p:nvSpPr>
-          <p:cNvPr id="34" name="bl34"/>
+              <a:rPr lang="it-IT" sz="1150" b="0" dirty="0">
+                <a:solidFill>
+                  <a:srgbClr val="A8A29A"/>
+                </a:solidFill>
+                <a:latin typeface="Trebuchet MS"/>
+              </a:rPr>
+              <a:t>4.3x slower and 2.6x more disk, in exchange for the fast traversals seen earlier.</a:t>
+            </a:r>
+          </a:p>
+        </p:txBody>
+      </p:sp>
+      <p:sp>
+        <p:nvSpPr>
+          <p:cNvPr id="20" name="tb20"/>
           <p:cNvSpPr txBox="1"/>
           <p:nvPr/>
         </p:nvSpPr>
         <p:spPr>
           <a:xfrm>
-            <a:off x="6500000" y="3500000"/>
-            <a:ext cx="4750000" cy="1200000"/>
-          </a:xfrm>
-          <a:prstGeom prst="rect">
-            <a:avLst/>
-          </a:prstGeom>
-        </p:spPr>
-        <p:txBody>
-          <a:bodyPr wrap="square" rtlCol="0">
+            <a:off x="700000" y="3750000"/>
+            <a:ext cx="10800000" cy="330000"/>
+          </a:xfrm>
+          <a:prstGeom prst="rect">
+            <a:avLst/>
+          </a:prstGeom>
+        </p:spPr>
+        <p:txBody>
+          <a:bodyPr wrap="square" rtlCol="0" anchor="t">
             <a:normAutofit/>
           </a:bodyPr>
           <a:lstStyle/>
           <a:p>
-            <a:pPr marL="285750" indent="-285750">
-              <a:lnSpc>
-                <a:spcPct val="150000"/>
-              </a:lnSpc>
-              <a:spcBef>
-                <a:spcPts val="600"/>
-              </a:spcBef>
-              <a:buChar char="–"/>
-            </a:pPr>
-            <a:r>
-              <a:rPr lang="it-IT" sz="1200" b="0" dirty="0">
-                <a:solidFill>
-                  <a:srgbClr val="A8A29A"/>
-                </a:solidFill>
-                <a:latin typeface="Trebuchet MS"/>
-              </a:rPr>
-              <a:t>The graph itself, visual and clickable</a:t>
-            </a:r>
-          </a:p>
-          <a:p>
-            <a:pPr marL="285750" indent="-285750">
-              <a:lnSpc>
-                <a:spcPct val="150000"/>
-              </a:lnSpc>
-              <a:spcBef>
-                <a:spcPts val="600"/>
-              </a:spcBef>
-              <a:buChar char="–"/>
-            </a:pPr>
-            <a:r>
-              <a:rPr lang="it-IT" sz="1200" b="0" dirty="0">
-                <a:solidFill>
-                  <a:srgbClr val="A8A29A"/>
-                </a:solidFill>
-                <a:latin typeface="Trebuchet MS"/>
-              </a:rPr>
-              <a:t>Fund tracing as an actual traversal</a:t>
-            </a:r>
-          </a:p>
-          <a:p>
-            <a:pPr marL="285750" indent="-285750">
-              <a:lnSpc>
-                <a:spcPct val="150000"/>
-              </a:lnSpc>
-              <a:spcBef>
-                <a:spcPts val="600"/>
-              </a:spcBef>
-              <a:buChar char="–"/>
-            </a:pPr>
-            <a:r>
-              <a:rPr lang="it-IT" sz="1200" b="0" dirty="0">
-                <a:solidFill>
-                  <a:srgbClr val="A8A29A"/>
-                </a:solidFill>
-                <a:latin typeface="Trebuchet MS"/>
-              </a:rPr>
-              <a:t>The clustering result on the graph</a:t>
-            </a:r>
-          </a:p>
-        </p:txBody>
-      </p:sp>
-      <p:sp>
-        <p:nvSpPr>
-          <p:cNvPr id="40" name="rc40"/>
+            <a:pPr algn="l">
+              <a:lnSpc>
+                <a:spcPct val="100000"/>
+              </a:lnSpc>
+            </a:pPr>
+            <a:r>
+              <a:rPr lang="it-IT" sz="1350" b="1" dirty="0">
+                <a:solidFill>
+                  <a:srgbClr val="F2EFE9"/>
+                </a:solidFill>
+                <a:latin typeface="Trebuchet MS"/>
+              </a:rPr>
+              <a:t>2. Q7 needs a step that comes before the query</a:t>
+            </a:r>
+          </a:p>
+        </p:txBody>
+      </p:sp>
+      <p:sp>
+        <p:nvSpPr>
+          <p:cNvPr id="21" name="rc21"/>
           <p:cNvSpPr/>
           <p:nvPr/>
         </p:nvSpPr>
         <p:spPr>
           <a:xfrm>
-            <a:off x="700000" y="4950000"/>
-            <a:ext cx="10800000" cy="900000"/>
+            <a:off x="700000" y="4120000"/>
+            <a:ext cx="10800000" cy="1420000"/>
           </a:xfrm>
           <a:prstGeom prst="roundRect">
             <a:avLst>
@@ -2898,13 +1788,13 @@
             </a:avLst>
           </a:prstGeom>
           <a:solidFill>
-            <a:srgbClr val="4FB59C">
-              <a:alpha val="10000"/>
+            <a:srgbClr val="C85A4A">
+              <a:alpha val="12000"/>
             </a:srgbClr>
           </a:solidFill>
           <a:ln w="12700">
             <a:solidFill>
-              <a:srgbClr val="4FB59C"/>
+              <a:srgbClr val="C85A4A"/>
             </a:solidFill>
           </a:ln>
         </p:spPr>
@@ -2916,14 +1806,14 @@
       </p:sp>
       <p:sp>
         <p:nvSpPr>
-          <p:cNvPr id="41" name="tb41"/>
+          <p:cNvPr id="22" name="tb22"/>
           <p:cNvSpPr txBox="1"/>
           <p:nvPr/>
         </p:nvSpPr>
         <p:spPr>
           <a:xfrm>
-            <a:off x="950000" y="5080000"/>
-            <a:ext cx="10300000" cy="700000"/>
+            <a:off x="950000" y="4230000"/>
+            <a:ext cx="10300000" cy="320000"/>
           </a:xfrm>
           <a:prstGeom prst="rect">
             <a:avLst/>
@@ -2941,31 +1831,154 @@
               </a:lnSpc>
             </a:pPr>
             <a:r>
-              <a:rPr lang="it-IT" sz="1300" b="0" dirty="0">
+              <a:rPr lang="it-IT" sz="1150" b="0" dirty="0">
                 <a:solidFill>
                   <a:srgbClr val="A8A29A"/>
                 </a:solidFill>
                 <a:latin typeface="Trebuchet MS"/>
               </a:rPr>
-              <a:t>I also have an </a:t>
-            </a:r>
-            <a:r>
-              <a:rPr lang="it-IT" sz="1300" b="1" dirty="0">
+              <a:t>Wallets do not exist in the blockchain: they have to be inferred by grouping addresses, which is a connected components problem.</a:t>
+            </a:r>
+          </a:p>
+        </p:txBody>
+      </p:sp>
+      <p:sp>
+        <p:nvSpPr>
+          <p:cNvPr id="23" name="tb23"/>
+          <p:cNvSpPr txBox="1"/>
+          <p:nvPr/>
+        </p:nvSpPr>
+        <p:spPr>
+          <a:xfrm>
+            <a:off x="950000" y="4580000"/>
+            <a:ext cx="5000000" cy="300000"/>
+          </a:xfrm>
+          <a:prstGeom prst="rect">
+            <a:avLst/>
+          </a:prstGeom>
+        </p:spPr>
+        <p:txBody>
+          <a:bodyPr wrap="square" rtlCol="0" anchor="t">
+            <a:normAutofit/>
+          </a:bodyPr>
+          <a:lstStyle/>
+          <a:p>
+            <a:pPr algn="l">
+              <a:lnSpc>
+                <a:spcPct val="100000"/>
+              </a:lnSpc>
+            </a:pPr>
+            <a:r>
+              <a:rPr lang="it-IT" sz="1150" b="1" dirty="0">
+                <a:solidFill>
+                  <a:srgbClr val="4FB59C"/>
+                </a:solidFill>
+                <a:latin typeface="Trebuchet MS"/>
+              </a:rPr>
+              <a:t>Neo4j: </a:t>
+            </a:r>
+            <a:r>
+              <a:rPr lang="it-IT" sz="1150" b="0" dirty="0">
+                <a:solidFill>
+                  <a:srgbClr val="A8A29A"/>
+                </a:solidFill>
+                <a:latin typeface="Trebuchet MS"/>
+              </a:rPr>
+              <a:t>84 minutes with gds.wcc, then the query runs in 12.3 s</a:t>
+            </a:r>
+          </a:p>
+        </p:txBody>
+      </p:sp>
+      <p:sp>
+        <p:nvSpPr>
+          <p:cNvPr id="24" name="tb24"/>
+          <p:cNvSpPr txBox="1"/>
+          <p:nvPr/>
+        </p:nvSpPr>
+        <p:spPr>
+          <a:xfrm>
+            <a:off x="950000" y="4880000"/>
+            <a:ext cx="10300000" cy="620000"/>
+          </a:xfrm>
+          <a:prstGeom prst="rect">
+            <a:avLst/>
+          </a:prstGeom>
+        </p:spPr>
+        <p:txBody>
+          <a:bodyPr wrap="square" rtlCol="0" anchor="t">
+            <a:normAutofit/>
+          </a:bodyPr>
+          <a:lstStyle/>
+          <a:p>
+            <a:pPr algn="l">
+              <a:lnSpc>
+                <a:spcPct val="100000"/>
+              </a:lnSpc>
+            </a:pPr>
+            <a:r>
+              <a:rPr lang="it-IT" sz="1150" b="1" dirty="0">
+                <a:solidFill>
+                  <a:srgbClr val="D9A441"/>
+                </a:solidFill>
+                <a:latin typeface="Trebuchet MS"/>
+              </a:rPr>
+              <a:t>SQLite: </a:t>
+            </a:r>
+            <a:r>
+              <a:rPr lang="it-IT" sz="1150" b="0" dirty="0">
+                <a:solidFill>
+                  <a:srgbClr val="A8A29A"/>
+                </a:solidFill>
+                <a:latin typeface="Trebuchet MS"/>
+              </a:rPr>
+              <a:t>no time at all, because the grouping never finishes. It works in rounds, each one spreading a label to neighbouring addresses, and every round has to scan the entire co-ownership table again: 276 million rows, joined against itself. Neo4j loads that graph into memory once and walks it; SQLite rereads it from disk on every pass.</a:t>
+            </a:r>
+          </a:p>
+        </p:txBody>
+      </p:sp>
+      <p:sp>
+        <p:nvSpPr>
+          <p:cNvPr id="30" name="tb30"/>
+          <p:cNvSpPr txBox="1"/>
+          <p:nvPr/>
+        </p:nvSpPr>
+        <p:spPr>
+          <a:xfrm>
+            <a:off x="700000" y="5620000"/>
+            <a:ext cx="10800000" cy="600000"/>
+          </a:xfrm>
+          <a:prstGeom prst="rect">
+            <a:avLst/>
+          </a:prstGeom>
+        </p:spPr>
+        <p:txBody>
+          <a:bodyPr wrap="square" rtlCol="0" anchor="t">
+            <a:normAutofit/>
+          </a:bodyPr>
+          <a:lstStyle/>
+          <a:p>
+            <a:pPr algn="l">
+              <a:lnSpc>
+                <a:spcPct val="100000"/>
+              </a:lnSpc>
+            </a:pPr>
+            <a:r>
+              <a:rPr lang="it-IT" sz="1250" b="1" dirty="0">
                 <a:solidFill>
                   <a:srgbClr val="F2EFE9"/>
                 </a:solidFill>
                 <a:latin typeface="Trebuchet MS"/>
               </a:rPr>
-              <a:t>interactive HTML page</a:t>
-            </a:r>
-            <a:r>
-              <a:rPr lang="it-IT" sz="1300" b="0" dirty="0">
+              <a:t>So Q7 is not a case of one engine being slower. </a:t>
+            </a:r>
+            <a:r>
+              <a:rPr lang="it-IT" sz="1250" b="0" dirty="0">
                 <a:solidFill>
                   <a:srgbClr val="A8A29A"/>
                 </a:solidFill>
                 <a:latin typeface="Trebuchet MS"/>
               </a:rPr>
-              <a:t> open locally: every query has a button that animates how each engine reaches the result.</a:t>
+              <a:t>It is a query that only one of the two models can answer here, and only by paying 84 minutes up front, once, the way you would with a materialised view.</a:t>
             </a:r>
           </a:p>
         </p:txBody>
@@ -3065,7 +2078,7 @@
                                           </p:stCondLst>
                                         </p:cTn>
                                         <p:tgtEl>
-                                          <p:spTgt spid="20"/>
+                                          <p:spTgt spid="11"/>
                                         </p:tgtEl>
                                         <p:attrNameLst>
                                           <p:attrName>style.visibility</p:attrName>
@@ -3079,7 +2092,7 @@
                                       <p:cBhvr>
                                         <p:cTn id="39" dur="400"/>
                                         <p:tgtEl>
-                                          <p:spTgt spid="20"/>
+                                          <p:spTgt spid="11"/>
                                         </p:tgtEl>
                                       </p:cBhvr>
                                     </p:animEffect>
@@ -3093,13 +2106,13 @@
                     </p:cTn>
                   </p:par>
                   <p:par>
-                    <p:cTn id="105" fill="hold">
+                    <p:cTn id="55" fill="hold">
                       <p:stCondLst>
                         <p:cond delay="indefinite"/>
                       </p:stCondLst>
                       <p:childTnLst>
                         <p:par>
-                          <p:cTn id="106" fill="hold">
+                          <p:cTn id="56" fill="hold">
                             <p:stCondLst>
                               <p:cond delay="0"/>
                             </p:stCondLst>
@@ -3118,6 +2131,269 @@
                                           </p:stCondLst>
                                         </p:cTn>
                                         <p:tgtEl>
+                                          <p:spTgt spid="12"/>
+                                        </p:tgtEl>
+                                        <p:attrNameLst>
+                                          <p:attrName>style.visibility</p:attrName>
+                                        </p:attrNameLst>
+                                      </p:cBhvr>
+                                      <p:to>
+                                        <p:strVal val="visible"/>
+                                      </p:to>
+                                    </p:set>
+                                    <p:animEffect transition="in" filter="fade">
+                                      <p:cBhvr>
+                                        <p:cTn id="54" dur="400"/>
+                                        <p:tgtEl>
+                                          <p:spTgt spid="12"/>
+                                        </p:tgtEl>
+                                      </p:cBhvr>
+                                    </p:animEffect>
+                                  </p:childTnLst>
+                                </p:cTn>
+                              </p:par>
+                            </p:childTnLst>
+                          </p:cTn>
+                        </p:par>
+                      </p:childTnLst>
+                    </p:cTn>
+                  </p:par>
+                  <p:par>
+                    <p:cTn id="120" fill="hold">
+                      <p:stCondLst>
+                        <p:cond delay="indefinite"/>
+                      </p:stCondLst>
+                      <p:childTnLst>
+                        <p:par>
+                          <p:cTn id="121" fill="hold">
+                            <p:stCondLst>
+                              <p:cond delay="0"/>
+                            </p:stCondLst>
+                            <p:childTnLst>
+                              <p:par>
+                                <p:cTn id="67" presetID="10" presetClass="entr" presetSubtype="0" fill="hold" nodeType="clickEffect">
+                                  <p:stCondLst>
+                                    <p:cond delay="0"/>
+                                  </p:stCondLst>
+                                  <p:childTnLst>
+                                    <p:set>
+                                      <p:cBhvr>
+                                        <p:cTn id="68" dur="1" fill="hold">
+                                          <p:stCondLst>
+                                            <p:cond delay="0"/>
+                                          </p:stCondLst>
+                                        </p:cTn>
+                                        <p:tgtEl>
+                                          <p:spTgt spid="13"/>
+                                        </p:tgtEl>
+                                        <p:attrNameLst>
+                                          <p:attrName>style.visibility</p:attrName>
+                                        </p:attrNameLst>
+                                      </p:cBhvr>
+                                      <p:to>
+                                        <p:strVal val="visible"/>
+                                      </p:to>
+                                    </p:set>
+                                    <p:animEffect transition="in" filter="fade">
+                                      <p:cBhvr>
+                                        <p:cTn id="69" dur="400"/>
+                                        <p:tgtEl>
+                                          <p:spTgt spid="13"/>
+                                        </p:tgtEl>
+                                      </p:cBhvr>
+                                    </p:animEffect>
+                                  </p:childTnLst>
+                                </p:cTn>
+                              </p:par>
+                              <p:par>
+                                <p:cTn id="72" presetID="10" presetClass="entr" presetSubtype="0" fill="hold" nodeType="withEffect">
+                                  <p:stCondLst>
+                                    <p:cond delay="0"/>
+                                  </p:stCondLst>
+                                  <p:childTnLst>
+                                    <p:set>
+                                      <p:cBhvr>
+                                        <p:cTn id="73" dur="1" fill="hold">
+                                          <p:stCondLst>
+                                            <p:cond delay="0"/>
+                                          </p:stCondLst>
+                                        </p:cTn>
+                                        <p:tgtEl>
+                                          <p:spTgt spid="14"/>
+                                        </p:tgtEl>
+                                        <p:attrNameLst>
+                                          <p:attrName>style.visibility</p:attrName>
+                                        </p:attrNameLst>
+                                      </p:cBhvr>
+                                      <p:to>
+                                        <p:strVal val="visible"/>
+                                      </p:to>
+                                    </p:set>
+                                    <p:animEffect transition="in" filter="fade">
+                                      <p:cBhvr>
+                                        <p:cTn id="74" dur="400"/>
+                                        <p:tgtEl>
+                                          <p:spTgt spid="14"/>
+                                        </p:tgtEl>
+                                      </p:cBhvr>
+                                    </p:animEffect>
+                                  </p:childTnLst>
+                                </p:cTn>
+                              </p:par>
+                              <p:par>
+                                <p:cTn id="77" presetID="10" presetClass="entr" presetSubtype="0" fill="hold" nodeType="withEffect">
+                                  <p:stCondLst>
+                                    <p:cond delay="0"/>
+                                  </p:stCondLst>
+                                  <p:childTnLst>
+                                    <p:set>
+                                      <p:cBhvr>
+                                        <p:cTn id="78" dur="1" fill="hold">
+                                          <p:stCondLst>
+                                            <p:cond delay="0"/>
+                                          </p:stCondLst>
+                                        </p:cTn>
+                                        <p:tgtEl>
+                                          <p:spTgt spid="15"/>
+                                        </p:tgtEl>
+                                        <p:attrNameLst>
+                                          <p:attrName>style.visibility</p:attrName>
+                                        </p:attrNameLst>
+                                      </p:cBhvr>
+                                      <p:to>
+                                        <p:strVal val="visible"/>
+                                      </p:to>
+                                    </p:set>
+                                    <p:animEffect transition="in" filter="fade">
+                                      <p:cBhvr>
+                                        <p:cTn id="79" dur="400"/>
+                                        <p:tgtEl>
+                                          <p:spTgt spid="15"/>
+                                        </p:tgtEl>
+                                      </p:cBhvr>
+                                    </p:animEffect>
+                                  </p:childTnLst>
+                                </p:cTn>
+                              </p:par>
+                              <p:par>
+                                <p:cTn id="82" presetID="10" presetClass="entr" presetSubtype="0" fill="hold" nodeType="withEffect">
+                                  <p:stCondLst>
+                                    <p:cond delay="0"/>
+                                  </p:stCondLst>
+                                  <p:childTnLst>
+                                    <p:set>
+                                      <p:cBhvr>
+                                        <p:cTn id="83" dur="1" fill="hold">
+                                          <p:stCondLst>
+                                            <p:cond delay="0"/>
+                                          </p:stCondLst>
+                                        </p:cTn>
+                                        <p:tgtEl>
+                                          <p:spTgt spid="16"/>
+                                        </p:tgtEl>
+                                        <p:attrNameLst>
+                                          <p:attrName>style.visibility</p:attrName>
+                                        </p:attrNameLst>
+                                      </p:cBhvr>
+                                      <p:to>
+                                        <p:strVal val="visible"/>
+                                      </p:to>
+                                    </p:set>
+                                    <p:animEffect transition="in" filter="fade">
+                                      <p:cBhvr>
+                                        <p:cTn id="84" dur="400"/>
+                                        <p:tgtEl>
+                                          <p:spTgt spid="16"/>
+                                        </p:tgtEl>
+                                      </p:cBhvr>
+                                    </p:animEffect>
+                                  </p:childTnLst>
+                                </p:cTn>
+                              </p:par>
+                              <p:par>
+                                <p:cTn id="87" presetID="10" presetClass="entr" presetSubtype="0" fill="hold" nodeType="withEffect">
+                                  <p:stCondLst>
+                                    <p:cond delay="0"/>
+                                  </p:stCondLst>
+                                  <p:childTnLst>
+                                    <p:set>
+                                      <p:cBhvr>
+                                        <p:cTn id="88" dur="1" fill="hold">
+                                          <p:stCondLst>
+                                            <p:cond delay="0"/>
+                                          </p:stCondLst>
+                                        </p:cTn>
+                                        <p:tgtEl>
+                                          <p:spTgt spid="17"/>
+                                        </p:tgtEl>
+                                        <p:attrNameLst>
+                                          <p:attrName>style.visibility</p:attrName>
+                                        </p:attrNameLst>
+                                      </p:cBhvr>
+                                      <p:to>
+                                        <p:strVal val="visible"/>
+                                      </p:to>
+                                    </p:set>
+                                    <p:animEffect transition="in" filter="fade">
+                                      <p:cBhvr>
+                                        <p:cTn id="89" dur="400"/>
+                                        <p:tgtEl>
+                                          <p:spTgt spid="17"/>
+                                        </p:tgtEl>
+                                      </p:cBhvr>
+                                    </p:animEffect>
+                                  </p:childTnLst>
+                                </p:cTn>
+                              </p:par>
+                              <p:par>
+                                <p:cTn id="92" presetID="10" presetClass="entr" presetSubtype="0" fill="hold" nodeType="withEffect">
+                                  <p:stCondLst>
+                                    <p:cond delay="0"/>
+                                  </p:stCondLst>
+                                  <p:childTnLst>
+                                    <p:set>
+                                      <p:cBhvr>
+                                        <p:cTn id="93" dur="1" fill="hold">
+                                          <p:stCondLst>
+                                            <p:cond delay="0"/>
+                                          </p:stCondLst>
+                                        </p:cTn>
+                                        <p:tgtEl>
+                                          <p:spTgt spid="20"/>
+                                        </p:tgtEl>
+                                        <p:attrNameLst>
+                                          <p:attrName>style.visibility</p:attrName>
+                                        </p:attrNameLst>
+                                      </p:cBhvr>
+                                      <p:to>
+                                        <p:strVal val="visible"/>
+                                      </p:to>
+                                    </p:set>
+                                    <p:animEffect transition="in" filter="fade">
+                                      <p:cBhvr>
+                                        <p:cTn id="94" dur="400"/>
+                                        <p:tgtEl>
+                                          <p:spTgt spid="20"/>
+                                        </p:tgtEl>
+                                      </p:cBhvr>
+                                    </p:animEffect>
+                                  </p:childTnLst>
+                                </p:cTn>
+                              </p:par>
+                              <p:par>
+                                <p:cTn id="97" presetID="10" presetClass="entr" presetSubtype="0" fill="hold" nodeType="withEffect">
+                                  <p:stCondLst>
+                                    <p:cond delay="0"/>
+                                  </p:stCondLst>
+                                  <p:childTnLst>
+                                    <p:set>
+                                      <p:cBhvr>
+                                        <p:cTn id="98" dur="1" fill="hold">
+                                          <p:stCondLst>
+                                            <p:cond delay="0"/>
+                                          </p:stCondLst>
+                                        </p:cTn>
+                                        <p:tgtEl>
                                           <p:spTgt spid="21"/>
                                         </p:tgtEl>
                                         <p:attrNameLst>
@@ -3130,6 +2406,1713 @@
                                     </p:set>
                                     <p:animEffect transition="in" filter="fade">
                                       <p:cBhvr>
+                                        <p:cTn id="99" dur="400"/>
+                                        <p:tgtEl>
+                                          <p:spTgt spid="21"/>
+                                        </p:tgtEl>
+                                      </p:cBhvr>
+                                    </p:animEffect>
+                                  </p:childTnLst>
+                                </p:cTn>
+                              </p:par>
+                              <p:par>
+                                <p:cTn id="102" presetID="10" presetClass="entr" presetSubtype="0" fill="hold" nodeType="withEffect">
+                                  <p:stCondLst>
+                                    <p:cond delay="0"/>
+                                  </p:stCondLst>
+                                  <p:childTnLst>
+                                    <p:set>
+                                      <p:cBhvr>
+                                        <p:cTn id="103" dur="1" fill="hold">
+                                          <p:stCondLst>
+                                            <p:cond delay="0"/>
+                                          </p:stCondLst>
+                                        </p:cTn>
+                                        <p:tgtEl>
+                                          <p:spTgt spid="22"/>
+                                        </p:tgtEl>
+                                        <p:attrNameLst>
+                                          <p:attrName>style.visibility</p:attrName>
+                                        </p:attrNameLst>
+                                      </p:cBhvr>
+                                      <p:to>
+                                        <p:strVal val="visible"/>
+                                      </p:to>
+                                    </p:set>
+                                    <p:animEffect transition="in" filter="fade">
+                                      <p:cBhvr>
+                                        <p:cTn id="104" dur="400"/>
+                                        <p:tgtEl>
+                                          <p:spTgt spid="22"/>
+                                        </p:tgtEl>
+                                      </p:cBhvr>
+                                    </p:animEffect>
+                                  </p:childTnLst>
+                                </p:cTn>
+                              </p:par>
+                              <p:par>
+                                <p:cTn id="107" presetID="10" presetClass="entr" presetSubtype="0" fill="hold" nodeType="withEffect">
+                                  <p:stCondLst>
+                                    <p:cond delay="0"/>
+                                  </p:stCondLst>
+                                  <p:childTnLst>
+                                    <p:set>
+                                      <p:cBhvr>
+                                        <p:cTn id="108" dur="1" fill="hold">
+                                          <p:stCondLst>
+                                            <p:cond delay="0"/>
+                                          </p:stCondLst>
+                                        </p:cTn>
+                                        <p:tgtEl>
+                                          <p:spTgt spid="23"/>
+                                        </p:tgtEl>
+                                        <p:attrNameLst>
+                                          <p:attrName>style.visibility</p:attrName>
+                                        </p:attrNameLst>
+                                      </p:cBhvr>
+                                      <p:to>
+                                        <p:strVal val="visible"/>
+                                      </p:to>
+                                    </p:set>
+                                    <p:animEffect transition="in" filter="fade">
+                                      <p:cBhvr>
+                                        <p:cTn id="109" dur="400"/>
+                                        <p:tgtEl>
+                                          <p:spTgt spid="23"/>
+                                        </p:tgtEl>
+                                      </p:cBhvr>
+                                    </p:animEffect>
+                                  </p:childTnLst>
+                                </p:cTn>
+                              </p:par>
+                              <p:par>
+                                <p:cTn id="112" presetID="10" presetClass="entr" presetSubtype="0" fill="hold" nodeType="withEffect">
+                                  <p:stCondLst>
+                                    <p:cond delay="0"/>
+                                  </p:stCondLst>
+                                  <p:childTnLst>
+                                    <p:set>
+                                      <p:cBhvr>
+                                        <p:cTn id="113" dur="1" fill="hold">
+                                          <p:stCondLst>
+                                            <p:cond delay="0"/>
+                                          </p:stCondLst>
+                                        </p:cTn>
+                                        <p:tgtEl>
+                                          <p:spTgt spid="24"/>
+                                        </p:tgtEl>
+                                        <p:attrNameLst>
+                                          <p:attrName>style.visibility</p:attrName>
+                                        </p:attrNameLst>
+                                      </p:cBhvr>
+                                      <p:to>
+                                        <p:strVal val="visible"/>
+                                      </p:to>
+                                    </p:set>
+                                    <p:animEffect transition="in" filter="fade">
+                                      <p:cBhvr>
+                                        <p:cTn id="114" dur="400"/>
+                                        <p:tgtEl>
+                                          <p:spTgt spid="24"/>
+                                        </p:tgtEl>
+                                      </p:cBhvr>
+                                    </p:animEffect>
+                                  </p:childTnLst>
+                                </p:cTn>
+                              </p:par>
+                              <p:par>
+                                <p:cTn id="117" presetID="10" presetClass="entr" presetSubtype="0" fill="hold" nodeType="withEffect">
+                                  <p:stCondLst>
+                                    <p:cond delay="0"/>
+                                  </p:stCondLst>
+                                  <p:childTnLst>
+                                    <p:set>
+                                      <p:cBhvr>
+                                        <p:cTn id="118" dur="1" fill="hold">
+                                          <p:stCondLst>
+                                            <p:cond delay="0"/>
+                                          </p:stCondLst>
+                                        </p:cTn>
+                                        <p:tgtEl>
+                                          <p:spTgt spid="30"/>
+                                        </p:tgtEl>
+                                        <p:attrNameLst>
+                                          <p:attrName>style.visibility</p:attrName>
+                                        </p:attrNameLst>
+                                      </p:cBhvr>
+                                      <p:to>
+                                        <p:strVal val="visible"/>
+                                      </p:to>
+                                    </p:set>
+                                    <p:animEffect transition="in" filter="fade">
+                                      <p:cBhvr>
+                                        <p:cTn id="119" dur="400"/>
+                                        <p:tgtEl>
+                                          <p:spTgt spid="30"/>
+                                        </p:tgtEl>
+                                      </p:cBhvr>
+                                    </p:animEffect>
+                                  </p:childTnLst>
+                                </p:cTn>
+                              </p:par>
+                            </p:childTnLst>
+                          </p:cTn>
+                        </p:par>
+                      </p:childTnLst>
+                    </p:cTn>
+                  </p:par>
+                </p:childTnLst>
+              </p:cTn>
+              <p:prevCondLst>
+                <p:cond evt="onPrev" delay="0">
+                  <p:tgtEl>
+                    <p:sldTgt/>
+                  </p:tgtEl>
+                </p:cond>
+              </p:prevCondLst>
+              <p:nextCondLst>
+                <p:cond evt="onNext" delay="0">
+                  <p:tgtEl>
+                    <p:sldTgt/>
+                  </p:tgtEl>
+                </p:cond>
+              </p:nextCondLst>
+            </p:seq>
+          </p:childTnLst>
+        </p:cTn>
+      </p:par>
+    </p:tnLst>
+  </p:timing>
+</p:sld>
+</file>
+
+<file path=ppt/slides/slide13.xml><?xml version="1.0" encoding="utf-8"?>
+<p:sld xmlns:a="http://schemas.openxmlformats.org/drawingml/2006/main" xmlns:r="http://schemas.openxmlformats.org/officeDocument/2006/relationships" xmlns:p="http://schemas.openxmlformats.org/presentationml/2006/main">
+  <p:cSld>
+    <p:bg>
+      <p:bgPr>
+        <a:solidFill>
+          <a:srgbClr val="12100E"/>
+        </a:solidFill>
+        <a:effectLst/>
+      </p:bgPr>
+    </p:bg>
+    <p:spTree>
+      <p:nvGrpSpPr>
+        <p:cNvPr id="1" name=""/>
+        <p:cNvGrpSpPr/>
+        <p:nvPr/>
+      </p:nvGrpSpPr>
+      <p:grpSpPr>
+        <a:xfrm>
+          <a:off x="0" y="0"/>
+          <a:ext cx="0" cy="0"/>
+          <a:chOff x="0" y="0"/>
+          <a:chExt cx="0" cy="0"/>
+        </a:xfrm>
+      </p:grpSpPr>
+      <p:sp>
+        <p:nvSpPr>
+          <p:cNvPr id="2" name="rc2"/>
+          <p:cNvSpPr/>
+          <p:nvPr/>
+        </p:nvSpPr>
+        <p:spPr>
+          <a:xfrm>
+            <a:off x="700000" y="620000"/>
+            <a:ext cx="46000" cy="620000"/>
+          </a:xfrm>
+          <a:prstGeom prst="roundRect">
+            <a:avLst>
+              <a:gd name="adj" fmla="val 6000"/>
+            </a:avLst>
+          </a:prstGeom>
+          <a:solidFill>
+            <a:srgbClr val="D9A441"/>
+          </a:solidFill>
+          <a:ln>
+            <a:noFill/>
+          </a:ln>
+        </p:spPr>
+        <p:txBody>
+          <a:bodyPr/>
+          <a:lstStyle/>
+          <a:p/>
+        </p:txBody>
+      </p:sp>
+      <p:sp>
+        <p:nvSpPr>
+          <p:cNvPr id="3" name="tb3"/>
+          <p:cNvSpPr txBox="1"/>
+          <p:nvPr/>
+        </p:nvSpPr>
+        <p:spPr>
+          <a:xfrm>
+            <a:off x="880000" y="600000"/>
+            <a:ext cx="9000000" cy="300000"/>
+          </a:xfrm>
+          <a:prstGeom prst="rect">
+            <a:avLst/>
+          </a:prstGeom>
+        </p:spPr>
+        <p:txBody>
+          <a:bodyPr wrap="square" rtlCol="0" anchor="t">
+            <a:normAutofit/>
+          </a:bodyPr>
+          <a:lstStyle/>
+          <a:p>
+            <a:pPr algn="l">
+              <a:lnSpc>
+                <a:spcPct val="100000"/>
+              </a:lnSpc>
+            </a:pPr>
+            <a:r>
+              <a:rPr lang="it-IT" sz="1050" b="0" dirty="0">
+                <a:solidFill>
+                  <a:srgbClr val="6E6862"/>
+                </a:solidFill>
+                <a:latin typeface="Trebuchet MS"/>
+              </a:rPr>
+              <a:t>TRADE-OFFS</a:t>
+            </a:r>
+          </a:p>
+        </p:txBody>
+      </p:sp>
+      <p:sp>
+        <p:nvSpPr>
+          <p:cNvPr id="4" name="tb4"/>
+          <p:cNvSpPr txBox="1"/>
+          <p:nvPr/>
+        </p:nvSpPr>
+        <p:spPr>
+          <a:xfrm>
+            <a:off x="860000" y="880000"/>
+            <a:ext cx="10500000" cy="800000"/>
+          </a:xfrm>
+          <a:prstGeom prst="rect">
+            <a:avLst/>
+          </a:prstGeom>
+        </p:spPr>
+        <p:txBody>
+          <a:bodyPr wrap="square" rtlCol="0" anchor="t">
+            <a:normAutofit/>
+          </a:bodyPr>
+          <a:lstStyle/>
+          <a:p>
+            <a:pPr algn="l">
+              <a:lnSpc>
+                <a:spcPct val="100000"/>
+              </a:lnSpc>
+            </a:pPr>
+            <a:r>
+              <a:rPr lang="it-IT" sz="2700" b="1" dirty="0">
+                <a:solidFill>
+                  <a:srgbClr val="F2EFE9"/>
+                </a:solidFill>
+                <a:latin typeface="Georgia"/>
+              </a:rPr>
+              <a:t>The same cost, as the data grows</a:t>
+            </a:r>
+          </a:p>
+        </p:txBody>
+      </p:sp>
+      <p:sp>
+        <p:nvSpPr>
+          <p:cNvPr id="5" name="tb5"/>
+          <p:cNvSpPr txBox="1"/>
+          <p:nvPr/>
+        </p:nvSpPr>
+        <p:spPr>
+          <a:xfrm>
+            <a:off x="11000000" y="6280000"/>
+            <a:ext cx="800000" cy="300000"/>
+          </a:xfrm>
+          <a:prstGeom prst="rect">
+            <a:avLst/>
+          </a:prstGeom>
+        </p:spPr>
+        <p:txBody>
+          <a:bodyPr wrap="square" rtlCol="0" anchor="t">
+            <a:normAutofit/>
+          </a:bodyPr>
+          <a:lstStyle/>
+          <a:p>
+            <a:pPr algn="r">
+              <a:lnSpc>
+                <a:spcPct val="100000"/>
+              </a:lnSpc>
+            </a:pPr>
+            <a:r>
+              <a:rPr lang="it-IT" sz="1000" b="0" dirty="0">
+                <a:solidFill>
+                  <a:srgbClr val="6E6862"/>
+                </a:solidFill>
+                <a:latin typeface="Trebuchet MS"/>
+              </a:rPr>
+              <a:t>13</a:t>
+            </a:r>
+          </a:p>
+        </p:txBody>
+      </p:sp>
+      <p:pic>
+        <p:nvPicPr>
+          <p:cNvPr id="10" name="pic10"/>
+          <p:cNvPicPr>
+            <a:picLocks noChangeAspect="1"/>
+          </p:cNvPicPr>
+          <p:nvPr/>
+        </p:nvPicPr>
+        <p:blipFill>
+          <a:blip r:embed="rId2"/>
+          <a:stretch>
+            <a:fillRect/>
+          </a:stretch>
+        </p:blipFill>
+        <p:spPr>
+          <a:xfrm>
+            <a:off x="1000000" y="1560000"/>
+            <a:ext cx="10200000" cy="4020000"/>
+          </a:xfrm>
+          <a:prstGeom prst="rect">
+            <a:avLst/>
+          </a:prstGeom>
+        </p:spPr>
+      </p:pic>
+      <p:sp>
+        <p:nvSpPr>
+          <p:cNvPr id="11" name="tb11"/>
+          <p:cNvSpPr txBox="1"/>
+          <p:nvPr/>
+        </p:nvSpPr>
+        <p:spPr>
+          <a:xfrm>
+            <a:off x="700000" y="5700000"/>
+            <a:ext cx="10800000" cy="600000"/>
+          </a:xfrm>
+          <a:prstGeom prst="rect">
+            <a:avLst/>
+          </a:prstGeom>
+        </p:spPr>
+        <p:txBody>
+          <a:bodyPr wrap="square" rtlCol="0" anchor="t">
+            <a:normAutofit/>
+          </a:bodyPr>
+          <a:lstStyle/>
+          <a:p>
+            <a:pPr algn="l">
+              <a:lnSpc>
+                <a:spcPct val="100000"/>
+              </a:lnSpc>
+            </a:pPr>
+            <a:r>
+              <a:rPr lang="it-IT" sz="1350" b="0" dirty="0">
+                <a:solidFill>
+                  <a:srgbClr val="A8A29A"/>
+                </a:solidFill>
+                <a:latin typeface="Trebuchet MS"/>
+              </a:rPr>
+              <a:t>The gap on loading holds at </a:t>
+            </a:r>
+            <a:r>
+              <a:rPr lang="it-IT" sz="1350" b="1" dirty="0">
+                <a:solidFill>
+                  <a:srgbClr val="F2EFE9"/>
+                </a:solidFill>
+                <a:latin typeface="Trebuchet MS"/>
+              </a:rPr>
+              <a:t>around 4x at every size</a:t>
+            </a:r>
+            <a:r>
+              <a:rPr lang="it-IT" sz="1350" b="0" dirty="0">
+                <a:solidFill>
+                  <a:srgbClr val="A8A29A"/>
+                </a:solidFill>
+                <a:latin typeface="Trebuchet MS"/>
+              </a:rPr>
+              <a:t>. The clustering is the steeper curve of the two, and beyond 200 blocks it is </a:t>
+            </a:r>
+            <a:r>
+              <a:rPr lang="it-IT" sz="1350" b="1" dirty="0">
+                <a:solidFill>
+                  <a:srgbClr val="F2EFE9"/>
+                </a:solidFill>
+                <a:latin typeface="Trebuchet MS"/>
+              </a:rPr>
+              <a:t>projected, not measured</a:t>
+            </a:r>
+            <a:r>
+              <a:rPr lang="it-IT" sz="1350" b="0" dirty="0">
+                <a:solidFill>
+                  <a:srgbClr val="A8A29A"/>
+                </a:solidFill>
+                <a:latin typeface="Trebuchet MS"/>
+              </a:rPr>
+              <a:t>: too expensive to run.</a:t>
+            </a:r>
+          </a:p>
+        </p:txBody>
+      </p:sp>
+    </p:spTree>
+  </p:cSld>
+  <p:clrMapOvr>
+    <a:overrideClrMapping bg1="lt1" tx1="dk1" bg2="lt2" tx2="dk2" accent1="accent1" accent2="accent2" accent3="accent3" accent4="accent4" accent5="accent5" accent6="accent6" hlink="hlink" folHlink="folHlink"/>
+  </p:clrMapOvr>
+  <p:transition spd="med">
+    <p:fade/>
+  </p:transition>
+  <p:timing>
+    <p:tnLst>
+      <p:par>
+        <p:cTn id="1" dur="indefinite" restart="never" nodeType="tmRoot">
+          <p:childTnLst>
+            <p:seq concurrent="1" nextAc="seek">
+              <p:cTn id="2" dur="indefinite" nodeType="mainSeq">
+                <p:childTnLst>
+                  <p:par>
+                    <p:cTn id="25" fill="hold">
+                      <p:stCondLst>
+                        <p:cond delay="indefinite"/>
+                      </p:stCondLst>
+                      <p:childTnLst>
+                        <p:par>
+                          <p:cTn id="26" fill="hold">
+                            <p:stCondLst>
+                              <p:cond delay="0"/>
+                            </p:stCondLst>
+                            <p:childTnLst>
+                              <p:par>
+                                <p:cTn id="22" presetID="10" presetClass="entr" presetSubtype="0" fill="hold" nodeType="clickEffect">
+                                  <p:stCondLst>
+                                    <p:cond delay="0"/>
+                                  </p:stCondLst>
+                                  <p:childTnLst>
+                                    <p:set>
+                                      <p:cBhvr>
+                                        <p:cTn id="23" dur="1" fill="hold">
+                                          <p:stCondLst>
+                                            <p:cond delay="0"/>
+                                          </p:stCondLst>
+                                        </p:cTn>
+                                        <p:tgtEl>
+                                          <p:spTgt spid="10"/>
+                                        </p:tgtEl>
+                                        <p:attrNameLst>
+                                          <p:attrName>style.visibility</p:attrName>
+                                        </p:attrNameLst>
+                                      </p:cBhvr>
+                                      <p:to>
+                                        <p:strVal val="visible"/>
+                                      </p:to>
+                                    </p:set>
+                                    <p:animEffect transition="in" filter="fade">
+                                      <p:cBhvr>
+                                        <p:cTn id="24" dur="400"/>
+                                        <p:tgtEl>
+                                          <p:spTgt spid="10"/>
+                                        </p:tgtEl>
+                                      </p:cBhvr>
+                                    </p:animEffect>
+                                  </p:childTnLst>
+                                </p:cTn>
+                              </p:par>
+                            </p:childTnLst>
+                          </p:cTn>
+                        </p:par>
+                      </p:childTnLst>
+                    </p:cTn>
+                  </p:par>
+                  <p:par>
+                    <p:cTn id="40" fill="hold">
+                      <p:stCondLst>
+                        <p:cond delay="indefinite"/>
+                      </p:stCondLst>
+                      <p:childTnLst>
+                        <p:par>
+                          <p:cTn id="41" fill="hold">
+                            <p:stCondLst>
+                              <p:cond delay="0"/>
+                            </p:stCondLst>
+                            <p:childTnLst>
+                              <p:par>
+                                <p:cTn id="37" presetID="10" presetClass="entr" presetSubtype="0" fill="hold" nodeType="clickEffect">
+                                  <p:stCondLst>
+                                    <p:cond delay="0"/>
+                                  </p:stCondLst>
+                                  <p:childTnLst>
+                                    <p:set>
+                                      <p:cBhvr>
+                                        <p:cTn id="38" dur="1" fill="hold">
+                                          <p:stCondLst>
+                                            <p:cond delay="0"/>
+                                          </p:stCondLst>
+                                        </p:cTn>
+                                        <p:tgtEl>
+                                          <p:spTgt spid="11"/>
+                                        </p:tgtEl>
+                                        <p:attrNameLst>
+                                          <p:attrName>style.visibility</p:attrName>
+                                        </p:attrNameLst>
+                                      </p:cBhvr>
+                                      <p:to>
+                                        <p:strVal val="visible"/>
+                                      </p:to>
+                                    </p:set>
+                                    <p:animEffect transition="in" filter="fade">
+                                      <p:cBhvr>
+                                        <p:cTn id="39" dur="400"/>
+                                        <p:tgtEl>
+                                          <p:spTgt spid="11"/>
+                                        </p:tgtEl>
+                                      </p:cBhvr>
+                                    </p:animEffect>
+                                  </p:childTnLst>
+                                </p:cTn>
+                              </p:par>
+                            </p:childTnLst>
+                          </p:cTn>
+                        </p:par>
+                      </p:childTnLst>
+                    </p:cTn>
+                  </p:par>
+                </p:childTnLst>
+              </p:cTn>
+              <p:prevCondLst>
+                <p:cond evt="onPrev" delay="0">
+                  <p:tgtEl>
+                    <p:sldTgt/>
+                  </p:tgtEl>
+                </p:cond>
+              </p:prevCondLst>
+              <p:nextCondLst>
+                <p:cond evt="onNext" delay="0">
+                  <p:tgtEl>
+                    <p:sldTgt/>
+                  </p:tgtEl>
+                </p:cond>
+              </p:nextCondLst>
+            </p:seq>
+          </p:childTnLst>
+        </p:cTn>
+      </p:par>
+    </p:tnLst>
+  </p:timing>
+</p:sld>
+</file>
+
+<file path=ppt/slides/slide14.xml><?xml version="1.0" encoding="utf-8"?>
+<p:sld xmlns:a="http://schemas.openxmlformats.org/drawingml/2006/main" xmlns:r="http://schemas.openxmlformats.org/officeDocument/2006/relationships" xmlns:p="http://schemas.openxmlformats.org/presentationml/2006/main">
+  <p:cSld>
+    <p:bg>
+      <p:bgPr>
+        <a:solidFill>
+          <a:srgbClr val="12100E"/>
+        </a:solidFill>
+        <a:effectLst/>
+      </p:bgPr>
+    </p:bg>
+    <p:spTree>
+      <p:nvGrpSpPr>
+        <p:cNvPr id="1" name=""/>
+        <p:cNvGrpSpPr/>
+        <p:nvPr/>
+      </p:nvGrpSpPr>
+      <p:grpSpPr>
+        <a:xfrm>
+          <a:off x="0" y="0"/>
+          <a:ext cx="0" cy="0"/>
+          <a:chOff x="0" y="0"/>
+          <a:chExt cx="0" cy="0"/>
+        </a:xfrm>
+      </p:grpSpPr>
+      <p:sp>
+        <p:nvSpPr>
+          <p:cNvPr id="2" name="rc2"/>
+          <p:cNvSpPr/>
+          <p:nvPr/>
+        </p:nvSpPr>
+        <p:spPr>
+          <a:xfrm>
+            <a:off x="700000" y="620000"/>
+            <a:ext cx="46000" cy="620000"/>
+          </a:xfrm>
+          <a:prstGeom prst="roundRect">
+            <a:avLst>
+              <a:gd name="adj" fmla="val 6000"/>
+            </a:avLst>
+          </a:prstGeom>
+          <a:solidFill>
+            <a:srgbClr val="D9A441"/>
+          </a:solidFill>
+          <a:ln>
+            <a:noFill/>
+          </a:ln>
+        </p:spPr>
+        <p:txBody>
+          <a:bodyPr/>
+          <a:lstStyle/>
+          <a:p/>
+        </p:txBody>
+      </p:sp>
+      <p:sp>
+        <p:nvSpPr>
+          <p:cNvPr id="3" name="tb3"/>
+          <p:cNvSpPr txBox="1"/>
+          <p:nvPr/>
+        </p:nvSpPr>
+        <p:spPr>
+          <a:xfrm>
+            <a:off x="880000" y="600000"/>
+            <a:ext cx="9000000" cy="300000"/>
+          </a:xfrm>
+          <a:prstGeom prst="rect">
+            <a:avLst/>
+          </a:prstGeom>
+        </p:spPr>
+        <p:txBody>
+          <a:bodyPr wrap="square" rtlCol="0" anchor="t">
+            <a:normAutofit/>
+          </a:bodyPr>
+          <a:lstStyle/>
+          <a:p>
+            <a:pPr algn="l">
+              <a:lnSpc>
+                <a:spcPct val="100000"/>
+              </a:lnSpc>
+            </a:pPr>
+            <a:r>
+              <a:rPr lang="it-IT" sz="1050" b="0" dirty="0">
+                <a:solidFill>
+                  <a:srgbClr val="6E6862"/>
+                </a:solidFill>
+                <a:latin typeface="Trebuchet MS"/>
+              </a:rPr>
+              <a:t>CONCLUSIONS</a:t>
+            </a:r>
+          </a:p>
+        </p:txBody>
+      </p:sp>
+      <p:sp>
+        <p:nvSpPr>
+          <p:cNvPr id="4" name="tb4"/>
+          <p:cNvSpPr txBox="1"/>
+          <p:nvPr/>
+        </p:nvSpPr>
+        <p:spPr>
+          <a:xfrm>
+            <a:off x="860000" y="880000"/>
+            <a:ext cx="10500000" cy="800000"/>
+          </a:xfrm>
+          <a:prstGeom prst="rect">
+            <a:avLst/>
+          </a:prstGeom>
+        </p:spPr>
+        <p:txBody>
+          <a:bodyPr wrap="square" rtlCol="0" anchor="t">
+            <a:normAutofit/>
+          </a:bodyPr>
+          <a:lstStyle/>
+          <a:p>
+            <a:pPr algn="l">
+              <a:lnSpc>
+                <a:spcPct val="100000"/>
+              </a:lnSpc>
+            </a:pPr>
+            <a:r>
+              <a:rPr lang="it-IT" sz="2700" b="1" dirty="0">
+                <a:solidFill>
+                  <a:srgbClr val="F2EFE9"/>
+                </a:solidFill>
+                <a:latin typeface="Georgia"/>
+              </a:rPr>
+              <a:t>What I take away from this</a:t>
+            </a:r>
+          </a:p>
+        </p:txBody>
+      </p:sp>
+      <p:sp>
+        <p:nvSpPr>
+          <p:cNvPr id="5" name="tb5"/>
+          <p:cNvSpPr txBox="1"/>
+          <p:nvPr/>
+        </p:nvSpPr>
+        <p:spPr>
+          <a:xfrm>
+            <a:off x="11000000" y="6280000"/>
+            <a:ext cx="800000" cy="300000"/>
+          </a:xfrm>
+          <a:prstGeom prst="rect">
+            <a:avLst/>
+          </a:prstGeom>
+        </p:spPr>
+        <p:txBody>
+          <a:bodyPr wrap="square" rtlCol="0" anchor="t">
+            <a:normAutofit/>
+          </a:bodyPr>
+          <a:lstStyle/>
+          <a:p>
+            <a:pPr algn="r">
+              <a:lnSpc>
+                <a:spcPct val="100000"/>
+              </a:lnSpc>
+            </a:pPr>
+            <a:r>
+              <a:rPr lang="it-IT" sz="1000" b="0" dirty="0">
+                <a:solidFill>
+                  <a:srgbClr val="6E6862"/>
+                </a:solidFill>
+                <a:latin typeface="Trebuchet MS"/>
+              </a:rPr>
+              <a:t>14</a:t>
+            </a:r>
+          </a:p>
+        </p:txBody>
+      </p:sp>
+      <p:sp>
+        <p:nvSpPr>
+          <p:cNvPr id="10" name="bl10"/>
+          <p:cNvSpPr txBox="1"/>
+          <p:nvPr/>
+        </p:nvSpPr>
+        <p:spPr>
+          <a:xfrm>
+            <a:off x="700000" y="1850000"/>
+            <a:ext cx="10800000" cy="3400000"/>
+          </a:xfrm>
+          <a:prstGeom prst="rect">
+            <a:avLst/>
+          </a:prstGeom>
+        </p:spPr>
+        <p:txBody>
+          <a:bodyPr wrap="square" rtlCol="0">
+            <a:normAutofit/>
+          </a:bodyPr>
+          <a:lstStyle/>
+          <a:p>
+            <a:pPr marL="285750" indent="-285750">
+              <a:lnSpc>
+                <a:spcPct val="150000"/>
+              </a:lnSpc>
+              <a:spcBef>
+                <a:spcPts val="600"/>
+              </a:spcBef>
+              <a:buChar char="–"/>
+            </a:pPr>
+            <a:r>
+              <a:rPr lang="it-IT" sz="1400" b="1" dirty="0">
+                <a:solidFill>
+                  <a:srgbClr val="F2EFE9"/>
+                </a:solidFill>
+                <a:latin typeface="Trebuchet MS"/>
+              </a:rPr>
+              <a:t>You pay either up front or at query time.</a:t>
+            </a:r>
+            <a:r>
+              <a:rPr lang="it-IT" sz="1400" b="0" dirty="0">
+                <a:solidFill>
+                  <a:srgbClr val="A8A29A"/>
+                </a:solidFill>
+                <a:latin typeface="Trebuchet MS"/>
+              </a:rPr>
+              <a:t> The graph materialises relationships while loading and sells them back as speed when you query. Whether that trade is worth it depends on how often you query.</a:t>
+            </a:r>
+          </a:p>
+          <a:p>
+            <a:pPr marL="285750" indent="-285750">
+              <a:lnSpc>
+                <a:spcPct val="150000"/>
+              </a:lnSpc>
+              <a:spcBef>
+                <a:spcPts val="600"/>
+              </a:spcBef>
+              <a:buChar char="–"/>
+            </a:pPr>
+            <a:r>
+              <a:rPr lang="it-IT" sz="1400" b="1" dirty="0">
+                <a:solidFill>
+                  <a:srgbClr val="F2EFE9"/>
+                </a:solidFill>
+                <a:latin typeface="Trebuchet MS"/>
+              </a:rPr>
+              <a:t>Measuring changed my conclusions.</a:t>
+            </a:r>
+            <a:r>
+              <a:rPr lang="it-IT" sz="1400" b="0" dirty="0">
+                <a:solidFill>
+                  <a:srgbClr val="A8A29A"/>
+                </a:solidFill>
+                <a:latin typeface="Trebuchet MS"/>
+              </a:rPr>
+              <a:t> I had assumed the graph would win everywhere. It does not, and the exceptions turned out to be the interesting part.</a:t>
+            </a:r>
+          </a:p>
+        </p:txBody>
+      </p:sp>
+      <p:sp>
+        <p:nvSpPr>
+          <p:cNvPr id="20" name="tb20"/>
+          <p:cNvSpPr txBox="1"/>
+          <p:nvPr/>
+        </p:nvSpPr>
+        <p:spPr>
+          <a:xfrm>
+            <a:off x="700000" y="5420000"/>
+            <a:ext cx="10800000" cy="600000"/>
+          </a:xfrm>
+          <a:prstGeom prst="rect">
+            <a:avLst/>
+          </a:prstGeom>
+        </p:spPr>
+        <p:txBody>
+          <a:bodyPr wrap="square" rtlCol="0" anchor="t">
+            <a:normAutofit/>
+          </a:bodyPr>
+          <a:lstStyle/>
+          <a:p>
+            <a:pPr algn="l">
+              <a:lnSpc>
+                <a:spcPct val="100000"/>
+              </a:lnSpc>
+            </a:pPr>
+            <a:r>
+              <a:rPr lang="it-IT" sz="1250" b="0" dirty="0">
+                <a:solidFill>
+                  <a:srgbClr val="6E6862"/>
+                </a:solidFill>
+                <a:latin typeface="Trebuchet MS"/>
+              </a:rPr>
+              <a:t>Stated limits: </a:t>
+            </a:r>
+            <a:r>
+              <a:rPr lang="it-IT" sz="1250" b="0" dirty="0">
+                <a:solidFill>
+                  <a:srgbClr val="A8A29A"/>
+                </a:solidFill>
+                <a:latin typeface="Trebuchet MS"/>
+              </a:rPr>
+              <a:t>one machine, a 977-block window chosen for practicality, and clustering is a heuristic, not a certainty.</a:t>
+            </a:r>
+          </a:p>
+        </p:txBody>
+      </p:sp>
+    </p:spTree>
+  </p:cSld>
+  <p:clrMapOvr>
+    <a:overrideClrMapping bg1="lt1" tx1="dk1" bg2="lt2" tx2="dk2" accent1="accent1" accent2="accent2" accent3="accent3" accent4="accent4" accent5="accent5" accent6="accent6" hlink="hlink" folHlink="folHlink"/>
+  </p:clrMapOvr>
+  <p:transition spd="med">
+    <p:fade/>
+  </p:transition>
+  <p:timing>
+    <p:tnLst>
+      <p:par>
+        <p:cTn id="1" dur="indefinite" restart="never" nodeType="tmRoot">
+          <p:childTnLst>
+            <p:seq concurrent="1" nextAc="seek">
+              <p:cTn id="2" dur="indefinite" nodeType="mainSeq">
+                <p:childTnLst>
+                  <p:par>
+                    <p:cTn id="25" fill="hold">
+                      <p:stCondLst>
+                        <p:cond delay="indefinite"/>
+                      </p:stCondLst>
+                      <p:childTnLst>
+                        <p:par>
+                          <p:cTn id="26" fill="hold">
+                            <p:stCondLst>
+                              <p:cond delay="0"/>
+                            </p:stCondLst>
+                            <p:childTnLst>
+                              <p:par>
+                                <p:cTn id="22" presetID="10" presetClass="entr" presetSubtype="0" fill="hold" nodeType="clickEffect">
+                                  <p:stCondLst>
+                                    <p:cond delay="0"/>
+                                  </p:stCondLst>
+                                  <p:childTnLst>
+                                    <p:set>
+                                      <p:cBhvr>
+                                        <p:cTn id="23" dur="1" fill="hold">
+                                          <p:stCondLst>
+                                            <p:cond delay="0"/>
+                                          </p:stCondLst>
+                                        </p:cTn>
+                                        <p:tgtEl>
+                                          <p:spTgt spid="10"/>
+                                        </p:tgtEl>
+                                        <p:attrNameLst>
+                                          <p:attrName>style.visibility</p:attrName>
+                                        </p:attrNameLst>
+                                      </p:cBhvr>
+                                      <p:to>
+                                        <p:strVal val="visible"/>
+                                      </p:to>
+                                    </p:set>
+                                    <p:animEffect transition="in" filter="fade">
+                                      <p:cBhvr>
+                                        <p:cTn id="24" dur="400"/>
+                                        <p:tgtEl>
+                                          <p:spTgt spid="10"/>
+                                        </p:tgtEl>
+                                      </p:cBhvr>
+                                    </p:animEffect>
+                                  </p:childTnLst>
+                                </p:cTn>
+                              </p:par>
+                            </p:childTnLst>
+                          </p:cTn>
+                        </p:par>
+                      </p:childTnLst>
+                    </p:cTn>
+                  </p:par>
+                  <p:par>
+                    <p:cTn id="40" fill="hold">
+                      <p:stCondLst>
+                        <p:cond delay="indefinite"/>
+                      </p:stCondLst>
+                      <p:childTnLst>
+                        <p:par>
+                          <p:cTn id="41" fill="hold">
+                            <p:stCondLst>
+                              <p:cond delay="0"/>
+                            </p:stCondLst>
+                            <p:childTnLst>
+                              <p:par>
+                                <p:cTn id="37" presetID="10" presetClass="entr" presetSubtype="0" fill="hold" nodeType="clickEffect">
+                                  <p:stCondLst>
+                                    <p:cond delay="0"/>
+                                  </p:stCondLst>
+                                  <p:childTnLst>
+                                    <p:set>
+                                      <p:cBhvr>
+                                        <p:cTn id="38" dur="1" fill="hold">
+                                          <p:stCondLst>
+                                            <p:cond delay="0"/>
+                                          </p:stCondLst>
+                                        </p:cTn>
+                                        <p:tgtEl>
+                                          <p:spTgt spid="20"/>
+                                        </p:tgtEl>
+                                        <p:attrNameLst>
+                                          <p:attrName>style.visibility</p:attrName>
+                                        </p:attrNameLst>
+                                      </p:cBhvr>
+                                      <p:to>
+                                        <p:strVal val="visible"/>
+                                      </p:to>
+                                    </p:set>
+                                    <p:animEffect transition="in" filter="fade">
+                                      <p:cBhvr>
+                                        <p:cTn id="39" dur="400"/>
+                                        <p:tgtEl>
+                                          <p:spTgt spid="20"/>
+                                        </p:tgtEl>
+                                      </p:cBhvr>
+                                    </p:animEffect>
+                                  </p:childTnLst>
+                                </p:cTn>
+                              </p:par>
+                            </p:childTnLst>
+                          </p:cTn>
+                        </p:par>
+                      </p:childTnLst>
+                    </p:cTn>
+                  </p:par>
+                </p:childTnLst>
+              </p:cTn>
+              <p:prevCondLst>
+                <p:cond evt="onPrev" delay="0">
+                  <p:tgtEl>
+                    <p:sldTgt/>
+                  </p:tgtEl>
+                </p:cond>
+              </p:prevCondLst>
+              <p:nextCondLst>
+                <p:cond evt="onNext" delay="0">
+                  <p:tgtEl>
+                    <p:sldTgt/>
+                  </p:tgtEl>
+                </p:cond>
+              </p:nextCondLst>
+            </p:seq>
+          </p:childTnLst>
+        </p:cTn>
+      </p:par>
+    </p:tnLst>
+  </p:timing>
+</p:sld>
+</file>
+
+<file path=ppt/slides/slide15.xml><?xml version="1.0" encoding="utf-8"?>
+<p:sld xmlns:a="http://schemas.openxmlformats.org/drawingml/2006/main" xmlns:r="http://schemas.openxmlformats.org/officeDocument/2006/relationships" xmlns:p="http://schemas.openxmlformats.org/presentationml/2006/main">
+  <p:cSld>
+    <p:bg>
+      <p:bgPr>
+        <a:solidFill>
+          <a:srgbClr val="12100E"/>
+        </a:solidFill>
+        <a:effectLst/>
+      </p:bgPr>
+    </p:bg>
+    <p:spTree>
+      <p:nvGrpSpPr>
+        <p:cNvPr id="1" name=""/>
+        <p:cNvGrpSpPr/>
+        <p:nvPr/>
+      </p:nvGrpSpPr>
+      <p:grpSpPr>
+        <a:xfrm>
+          <a:off x="0" y="0"/>
+          <a:ext cx="0" cy="0"/>
+          <a:chOff x="0" y="0"/>
+          <a:chExt cx="0" cy="0"/>
+        </a:xfrm>
+      </p:grpSpPr>
+      <p:sp>
+        <p:nvSpPr>
+          <p:cNvPr id="2" name="rc2"/>
+          <p:cNvSpPr/>
+          <p:nvPr/>
+        </p:nvSpPr>
+        <p:spPr>
+          <a:xfrm>
+            <a:off x="700000" y="620000"/>
+            <a:ext cx="46000" cy="620000"/>
+          </a:xfrm>
+          <a:prstGeom prst="roundRect">
+            <a:avLst>
+              <a:gd name="adj" fmla="val 6000"/>
+            </a:avLst>
+          </a:prstGeom>
+          <a:solidFill>
+            <a:srgbClr val="D9A441"/>
+          </a:solidFill>
+          <a:ln>
+            <a:noFill/>
+          </a:ln>
+        </p:spPr>
+        <p:txBody>
+          <a:bodyPr/>
+          <a:lstStyle/>
+          <a:p/>
+        </p:txBody>
+      </p:sp>
+      <p:sp>
+        <p:nvSpPr>
+          <p:cNvPr id="3" name="tb3"/>
+          <p:cNvSpPr txBox="1"/>
+          <p:nvPr/>
+        </p:nvSpPr>
+        <p:spPr>
+          <a:xfrm>
+            <a:off x="880000" y="600000"/>
+            <a:ext cx="9000000" cy="300000"/>
+          </a:xfrm>
+          <a:prstGeom prst="rect">
+            <a:avLst/>
+          </a:prstGeom>
+        </p:spPr>
+        <p:txBody>
+          <a:bodyPr wrap="square" rtlCol="0" anchor="t">
+            <a:normAutofit/>
+          </a:bodyPr>
+          <a:lstStyle/>
+          <a:p>
+            <a:pPr algn="l">
+              <a:lnSpc>
+                <a:spcPct val="100000"/>
+              </a:lnSpc>
+            </a:pPr>
+            <a:r>
+              <a:rPr lang="it-IT" sz="1050" b="0" dirty="0">
+                <a:solidFill>
+                  <a:srgbClr val="6E6862"/>
+                </a:solidFill>
+                <a:latin typeface="Trebuchet MS"/>
+              </a:rPr>
+              <a:t>5 MINUTES</a:t>
+            </a:r>
+          </a:p>
+        </p:txBody>
+      </p:sp>
+      <p:sp>
+        <p:nvSpPr>
+          <p:cNvPr id="4" name="tb4"/>
+          <p:cNvSpPr txBox="1"/>
+          <p:nvPr/>
+        </p:nvSpPr>
+        <p:spPr>
+          <a:xfrm>
+            <a:off x="860000" y="880000"/>
+            <a:ext cx="10500000" cy="800000"/>
+          </a:xfrm>
+          <a:prstGeom prst="rect">
+            <a:avLst/>
+          </a:prstGeom>
+        </p:spPr>
+        <p:txBody>
+          <a:bodyPr wrap="square" rtlCol="0" anchor="t">
+            <a:normAutofit/>
+          </a:bodyPr>
+          <a:lstStyle/>
+          <a:p>
+            <a:pPr algn="l">
+              <a:lnSpc>
+                <a:spcPct val="100000"/>
+              </a:lnSpc>
+            </a:pPr>
+            <a:r>
+              <a:rPr lang="it-IT" sz="2700" b="1" dirty="0">
+                <a:solidFill>
+                  <a:srgbClr val="F2EFE9"/>
+                </a:solidFill>
+                <a:latin typeface="Georgia"/>
+              </a:rPr>
+              <a:t>Live demo</a:t>
+            </a:r>
+          </a:p>
+        </p:txBody>
+      </p:sp>
+      <p:sp>
+        <p:nvSpPr>
+          <p:cNvPr id="5" name="tb5"/>
+          <p:cNvSpPr txBox="1"/>
+          <p:nvPr/>
+        </p:nvSpPr>
+        <p:spPr>
+          <a:xfrm>
+            <a:off x="11000000" y="6280000"/>
+            <a:ext cx="800000" cy="300000"/>
+          </a:xfrm>
+          <a:prstGeom prst="rect">
+            <a:avLst/>
+          </a:prstGeom>
+        </p:spPr>
+        <p:txBody>
+          <a:bodyPr wrap="square" rtlCol="0" anchor="t">
+            <a:normAutofit/>
+          </a:bodyPr>
+          <a:lstStyle/>
+          <a:p>
+            <a:pPr algn="r">
+              <a:lnSpc>
+                <a:spcPct val="100000"/>
+              </a:lnSpc>
+            </a:pPr>
+            <a:r>
+              <a:rPr lang="it-IT" sz="1000" b="0" dirty="0">
+                <a:solidFill>
+                  <a:srgbClr val="6E6862"/>
+                </a:solidFill>
+                <a:latin typeface="Trebuchet MS"/>
+              </a:rPr>
+              <a:t>15</a:t>
+            </a:r>
+          </a:p>
+        </p:txBody>
+      </p:sp>
+      <p:sp>
+        <p:nvSpPr>
+          <p:cNvPr id="10" name="tb10"/>
+          <p:cNvSpPr txBox="1"/>
+          <p:nvPr/>
+        </p:nvSpPr>
+        <p:spPr>
+          <a:xfrm>
+            <a:off x="700000" y="1760000"/>
+            <a:ext cx="10800000" cy="450000"/>
+          </a:xfrm>
+          <a:prstGeom prst="rect">
+            <a:avLst/>
+          </a:prstGeom>
+        </p:spPr>
+        <p:txBody>
+          <a:bodyPr wrap="square" rtlCol="0" anchor="t">
+            <a:normAutofit/>
+          </a:bodyPr>
+          <a:lstStyle/>
+          <a:p>
+            <a:pPr algn="l">
+              <a:lnSpc>
+                <a:spcPct val="100000"/>
+              </a:lnSpc>
+            </a:pPr>
+            <a:r>
+              <a:rPr lang="it-IT" sz="1350" b="0" dirty="0">
+                <a:solidFill>
+                  <a:srgbClr val="A8A29A"/>
+                </a:solidFill>
+                <a:latin typeface="Trebuchet MS"/>
+              </a:rPr>
+              <a:t>A 50-transaction slice of the same data, small enough to read on screen. It loads into Neo4j in 2 seconds instead of 40 minutes.</a:t>
+            </a:r>
+          </a:p>
+        </p:txBody>
+      </p:sp>
+      <p:sp>
+        <p:nvSpPr>
+          <p:cNvPr id="20" name="rc20"/>
+          <p:cNvSpPr/>
+          <p:nvPr/>
+        </p:nvSpPr>
+        <p:spPr>
+          <a:xfrm>
+            <a:off x="700000" y="2320000"/>
+            <a:ext cx="5250000" cy="2400000"/>
+          </a:xfrm>
+          <a:prstGeom prst="roundRect">
+            <a:avLst>
+              <a:gd name="adj" fmla="val 6000"/>
+            </a:avLst>
+          </a:prstGeom>
+          <a:solidFill>
+            <a:srgbClr val="D9A441">
+              <a:alpha val="10000"/>
+            </a:srgbClr>
+          </a:solidFill>
+          <a:ln w="12700">
+            <a:solidFill>
+              <a:srgbClr val="D9A441"/>
+            </a:solidFill>
+          </a:ln>
+        </p:spPr>
+        <p:txBody>
+          <a:bodyPr/>
+          <a:lstStyle/>
+          <a:p/>
+        </p:txBody>
+      </p:sp>
+      <p:sp>
+        <p:nvSpPr>
+          <p:cNvPr id="21" name="tb21"/>
+          <p:cNvSpPr txBox="1"/>
+          <p:nvPr/>
+        </p:nvSpPr>
+        <p:spPr>
+          <a:xfrm>
+            <a:off x="950000" y="2520000"/>
+            <a:ext cx="4750000" cy="400000"/>
+          </a:xfrm>
+          <a:prstGeom prst="rect">
+            <a:avLst/>
+          </a:prstGeom>
+        </p:spPr>
+        <p:txBody>
+          <a:bodyPr wrap="square" rtlCol="0" anchor="t">
+            <a:normAutofit/>
+          </a:bodyPr>
+          <a:lstStyle/>
+          <a:p>
+            <a:pPr algn="l">
+              <a:lnSpc>
+                <a:spcPct val="100000"/>
+              </a:lnSpc>
+            </a:pPr>
+            <a:r>
+              <a:rPr lang="it-IT" sz="1450" b="1" dirty="0">
+                <a:solidFill>
+                  <a:srgbClr val="D9A441"/>
+                </a:solidFill>
+                <a:latin typeface="Trebuchet MS"/>
+              </a:rPr>
+              <a:t>SQLite</a:t>
+            </a:r>
+          </a:p>
+        </p:txBody>
+      </p:sp>
+      <p:sp>
+        <p:nvSpPr>
+          <p:cNvPr id="24" name="bl24"/>
+          <p:cNvSpPr txBox="1"/>
+          <p:nvPr/>
+        </p:nvSpPr>
+        <p:spPr>
+          <a:xfrm>
+            <a:off x="950000" y="3060000"/>
+            <a:ext cx="4750000" cy="1500000"/>
+          </a:xfrm>
+          <a:prstGeom prst="rect">
+            <a:avLst/>
+          </a:prstGeom>
+        </p:spPr>
+        <p:txBody>
+          <a:bodyPr wrap="square" rtlCol="0">
+            <a:normAutofit/>
+          </a:bodyPr>
+          <a:lstStyle/>
+          <a:p>
+            <a:pPr marL="285750" indent="-285750">
+              <a:lnSpc>
+                <a:spcPct val="150000"/>
+              </a:lnSpc>
+              <a:spcBef>
+                <a:spcPts val="600"/>
+              </a:spcBef>
+              <a:buChar char="–"/>
+            </a:pPr>
+            <a:r>
+              <a:rPr lang="it-IT" sz="1200" b="0" dirty="0">
+                <a:solidFill>
+                  <a:srgbClr val="A8A29A"/>
+                </a:solidFill>
+                <a:latin typeface="Trebuchet MS"/>
+              </a:rPr>
+              <a:t>Browse the tables with real rows in them</a:t>
+            </a:r>
+          </a:p>
+          <a:p>
+            <a:pPr marL="285750" indent="-285750">
+              <a:lnSpc>
+                <a:spcPct val="150000"/>
+              </a:lnSpc>
+              <a:spcBef>
+                <a:spcPts val="600"/>
+              </a:spcBef>
+              <a:buChar char="–"/>
+            </a:pPr>
+            <a:r>
+              <a:rPr lang="it-IT" sz="1200" b="0" dirty="0">
+                <a:solidFill>
+                  <a:srgbClr val="A8A29A"/>
+                </a:solidFill>
+                <a:latin typeface="Trebuchet MS"/>
+              </a:rPr>
+              <a:t>Run Q1 to Q8 with one click</a:t>
+            </a:r>
+          </a:p>
+          <a:p>
+            <a:pPr marL="285750" indent="-285750">
+              <a:lnSpc>
+                <a:spcPct val="150000"/>
+              </a:lnSpc>
+              <a:spcBef>
+                <a:spcPts val="600"/>
+              </a:spcBef>
+              <a:buChar char="–"/>
+            </a:pPr>
+            <a:r>
+              <a:rPr lang="it-IT" sz="1200" b="0" dirty="0">
+                <a:solidFill>
+                  <a:srgbClr val="A8A29A"/>
+                </a:solidFill>
+                <a:latin typeface="Trebuchet MS"/>
+              </a:rPr>
+              <a:t>Free SQL editor for questions on the spot</a:t>
+            </a:r>
+          </a:p>
+        </p:txBody>
+      </p:sp>
+      <p:sp>
+        <p:nvSpPr>
+          <p:cNvPr id="30" name="rc30"/>
+          <p:cNvSpPr/>
+          <p:nvPr/>
+        </p:nvSpPr>
+        <p:spPr>
+          <a:xfrm>
+            <a:off x="6250000" y="2320000"/>
+            <a:ext cx="5250000" cy="2400000"/>
+          </a:xfrm>
+          <a:prstGeom prst="roundRect">
+            <a:avLst>
+              <a:gd name="adj" fmla="val 6000"/>
+            </a:avLst>
+          </a:prstGeom>
+          <a:solidFill>
+            <a:srgbClr val="4FB59C">
+              <a:alpha val="10000"/>
+            </a:srgbClr>
+          </a:solidFill>
+          <a:ln w="12700">
+            <a:solidFill>
+              <a:srgbClr val="4FB59C"/>
+            </a:solidFill>
+          </a:ln>
+        </p:spPr>
+        <p:txBody>
+          <a:bodyPr/>
+          <a:lstStyle/>
+          <a:p/>
+        </p:txBody>
+      </p:sp>
+      <p:sp>
+        <p:nvSpPr>
+          <p:cNvPr id="31" name="tb31"/>
+          <p:cNvSpPr txBox="1"/>
+          <p:nvPr/>
+        </p:nvSpPr>
+        <p:spPr>
+          <a:xfrm>
+            <a:off x="6500000" y="2520000"/>
+            <a:ext cx="4750000" cy="400000"/>
+          </a:xfrm>
+          <a:prstGeom prst="rect">
+            <a:avLst/>
+          </a:prstGeom>
+        </p:spPr>
+        <p:txBody>
+          <a:bodyPr wrap="square" rtlCol="0" anchor="t">
+            <a:normAutofit/>
+          </a:bodyPr>
+          <a:lstStyle/>
+          <a:p>
+            <a:pPr algn="l">
+              <a:lnSpc>
+                <a:spcPct val="100000"/>
+              </a:lnSpc>
+            </a:pPr>
+            <a:r>
+              <a:rPr lang="it-IT" sz="1450" b="1" dirty="0">
+                <a:solidFill>
+                  <a:srgbClr val="4FB59C"/>
+                </a:solidFill>
+                <a:latin typeface="Trebuchet MS"/>
+              </a:rPr>
+              <a:t>Neo4j Browser</a:t>
+            </a:r>
+          </a:p>
+        </p:txBody>
+      </p:sp>
+      <p:sp>
+        <p:nvSpPr>
+          <p:cNvPr id="34" name="bl34"/>
+          <p:cNvSpPr txBox="1"/>
+          <p:nvPr/>
+        </p:nvSpPr>
+        <p:spPr>
+          <a:xfrm>
+            <a:off x="6500000" y="3060000"/>
+            <a:ext cx="4750000" cy="1500000"/>
+          </a:xfrm>
+          <a:prstGeom prst="rect">
+            <a:avLst/>
+          </a:prstGeom>
+        </p:spPr>
+        <p:txBody>
+          <a:bodyPr wrap="square" rtlCol="0">
+            <a:normAutofit/>
+          </a:bodyPr>
+          <a:lstStyle/>
+          <a:p>
+            <a:pPr marL="285750" indent="-285750">
+              <a:lnSpc>
+                <a:spcPct val="150000"/>
+              </a:lnSpc>
+              <a:spcBef>
+                <a:spcPts val="600"/>
+              </a:spcBef>
+              <a:buChar char="–"/>
+            </a:pPr>
+            <a:r>
+              <a:rPr lang="it-IT" sz="1200" b="0" dirty="0">
+                <a:solidFill>
+                  <a:srgbClr val="A8A29A"/>
+                </a:solidFill>
+                <a:latin typeface="Trebuchet MS"/>
+              </a:rPr>
+              <a:t>The graph itself, visual and clickable</a:t>
+            </a:r>
+          </a:p>
+          <a:p>
+            <a:pPr marL="285750" indent="-285750">
+              <a:lnSpc>
+                <a:spcPct val="150000"/>
+              </a:lnSpc>
+              <a:spcBef>
+                <a:spcPts val="600"/>
+              </a:spcBef>
+              <a:buChar char="–"/>
+            </a:pPr>
+            <a:r>
+              <a:rPr lang="it-IT" sz="1200" b="0" dirty="0">
+                <a:solidFill>
+                  <a:srgbClr val="A8A29A"/>
+                </a:solidFill>
+                <a:latin typeface="Trebuchet MS"/>
+              </a:rPr>
+              <a:t>Fund tracing as an actual traversal</a:t>
+            </a:r>
+          </a:p>
+          <a:p>
+            <a:pPr marL="285750" indent="-285750">
+              <a:lnSpc>
+                <a:spcPct val="150000"/>
+              </a:lnSpc>
+              <a:spcBef>
+                <a:spcPts val="600"/>
+              </a:spcBef>
+              <a:buChar char="–"/>
+            </a:pPr>
+            <a:r>
+              <a:rPr lang="it-IT" sz="1200" b="0" dirty="0">
+                <a:solidFill>
+                  <a:srgbClr val="A8A29A"/>
+                </a:solidFill>
+                <a:latin typeface="Trebuchet MS"/>
+              </a:rPr>
+              <a:t>The clustering result on the graph</a:t>
+            </a:r>
+          </a:p>
+        </p:txBody>
+      </p:sp>
+    </p:spTree>
+  </p:cSld>
+  <p:clrMapOvr>
+    <a:overrideClrMapping bg1="lt1" tx1="dk1" bg2="lt2" tx2="dk2" accent1="accent1" accent2="accent2" accent3="accent3" accent4="accent4" accent5="accent5" accent6="accent6" hlink="hlink" folHlink="folHlink"/>
+  </p:clrMapOvr>
+  <p:transition spd="med">
+    <p:fade/>
+  </p:transition>
+  <p:timing>
+    <p:tnLst>
+      <p:par>
+        <p:cTn id="1" dur="indefinite" restart="never" nodeType="tmRoot">
+          <p:childTnLst>
+            <p:seq concurrent="1" nextAc="seek">
+              <p:cTn id="2" dur="indefinite" nodeType="mainSeq">
+                <p:childTnLst>
+                  <p:par>
+                    <p:cTn id="25" fill="hold">
+                      <p:stCondLst>
+                        <p:cond delay="indefinite"/>
+                      </p:stCondLst>
+                      <p:childTnLst>
+                        <p:par>
+                          <p:cTn id="26" fill="hold">
+                            <p:stCondLst>
+                              <p:cond delay="0"/>
+                            </p:stCondLst>
+                            <p:childTnLst>
+                              <p:par>
+                                <p:cTn id="22" presetID="10" presetClass="entr" presetSubtype="0" fill="hold" nodeType="clickEffect">
+                                  <p:stCondLst>
+                                    <p:cond delay="0"/>
+                                  </p:stCondLst>
+                                  <p:childTnLst>
+                                    <p:set>
+                                      <p:cBhvr>
+                                        <p:cTn id="23" dur="1" fill="hold">
+                                          <p:stCondLst>
+                                            <p:cond delay="0"/>
+                                          </p:stCondLst>
+                                        </p:cTn>
+                                        <p:tgtEl>
+                                          <p:spTgt spid="10"/>
+                                        </p:tgtEl>
+                                        <p:attrNameLst>
+                                          <p:attrName>style.visibility</p:attrName>
+                                        </p:attrNameLst>
+                                      </p:cBhvr>
+                                      <p:to>
+                                        <p:strVal val="visible"/>
+                                      </p:to>
+                                    </p:set>
+                                    <p:animEffect transition="in" filter="fade">
+                                      <p:cBhvr>
+                                        <p:cTn id="24" dur="400"/>
+                                        <p:tgtEl>
+                                          <p:spTgt spid="10"/>
+                                        </p:tgtEl>
+                                      </p:cBhvr>
+                                    </p:animEffect>
+                                  </p:childTnLst>
+                                </p:cTn>
+                              </p:par>
+                            </p:childTnLst>
+                          </p:cTn>
+                        </p:par>
+                      </p:childTnLst>
+                    </p:cTn>
+                  </p:par>
+                  <p:par>
+                    <p:cTn id="40" fill="hold">
+                      <p:stCondLst>
+                        <p:cond delay="indefinite"/>
+                      </p:stCondLst>
+                      <p:childTnLst>
+                        <p:par>
+                          <p:cTn id="41" fill="hold">
+                            <p:stCondLst>
+                              <p:cond delay="0"/>
+                            </p:stCondLst>
+                            <p:childTnLst>
+                              <p:par>
+                                <p:cTn id="37" presetID="10" presetClass="entr" presetSubtype="0" fill="hold" nodeType="clickEffect">
+                                  <p:stCondLst>
+                                    <p:cond delay="0"/>
+                                  </p:stCondLst>
+                                  <p:childTnLst>
+                                    <p:set>
+                                      <p:cBhvr>
+                                        <p:cTn id="38" dur="1" fill="hold">
+                                          <p:stCondLst>
+                                            <p:cond delay="0"/>
+                                          </p:stCondLst>
+                                        </p:cTn>
+                                        <p:tgtEl>
+                                          <p:spTgt spid="20"/>
+                                        </p:tgtEl>
+                                        <p:attrNameLst>
+                                          <p:attrName>style.visibility</p:attrName>
+                                        </p:attrNameLst>
+                                      </p:cBhvr>
+                                      <p:to>
+                                        <p:strVal val="visible"/>
+                                      </p:to>
+                                    </p:set>
+                                    <p:animEffect transition="in" filter="fade">
+                                      <p:cBhvr>
+                                        <p:cTn id="39" dur="400"/>
+                                        <p:tgtEl>
+                                          <p:spTgt spid="20"/>
+                                        </p:tgtEl>
+                                      </p:cBhvr>
+                                    </p:animEffect>
+                                  </p:childTnLst>
+                                </p:cTn>
+                              </p:par>
+                            </p:childTnLst>
+                          </p:cTn>
+                        </p:par>
+                      </p:childTnLst>
+                    </p:cTn>
+                  </p:par>
+                  <p:par>
+                    <p:cTn id="75" fill="hold">
+                      <p:stCondLst>
+                        <p:cond delay="indefinite"/>
+                      </p:stCondLst>
+                      <p:childTnLst>
+                        <p:par>
+                          <p:cTn id="76" fill="hold">
+                            <p:stCondLst>
+                              <p:cond delay="0"/>
+                            </p:stCondLst>
+                            <p:childTnLst>
+                              <p:par>
+                                <p:cTn id="52" presetID="10" presetClass="entr" presetSubtype="0" fill="hold" nodeType="clickEffect">
+                                  <p:stCondLst>
+                                    <p:cond delay="0"/>
+                                  </p:stCondLst>
+                                  <p:childTnLst>
+                                    <p:set>
+                                      <p:cBhvr>
+                                        <p:cTn id="53" dur="1" fill="hold">
+                                          <p:stCondLst>
+                                            <p:cond delay="0"/>
+                                          </p:stCondLst>
+                                        </p:cTn>
+                                        <p:tgtEl>
+                                          <p:spTgt spid="21"/>
+                                        </p:tgtEl>
+                                        <p:attrNameLst>
+                                          <p:attrName>style.visibility</p:attrName>
+                                        </p:attrNameLst>
+                                      </p:cBhvr>
+                                      <p:to>
+                                        <p:strVal val="visible"/>
+                                      </p:to>
+                                    </p:set>
+                                    <p:animEffect transition="in" filter="fade">
+                                      <p:cBhvr>
                                         <p:cTn id="54" dur="400"/>
                                         <p:tgtEl>
                                           <p:spTgt spid="21"/>
@@ -3153,7 +4136,7 @@
                                           </p:stCondLst>
                                         </p:cTn>
                                         <p:tgtEl>
-                                          <p:spTgt spid="22"/>
+                                          <p:spTgt spid="24"/>
                                         </p:tgtEl>
                                         <p:attrNameLst>
                                           <p:attrName>style.visibility</p:attrName>
@@ -3167,7 +4150,7 @@
                                       <p:cBhvr>
                                         <p:cTn id="59" dur="400"/>
                                         <p:tgtEl>
-                                          <p:spTgt spid="22"/>
+                                          <p:spTgt spid="24"/>
                                         </p:tgtEl>
                                       </p:cBhvr>
                                     </p:animEffect>
@@ -3188,7 +4171,7 @@
                                           </p:stCondLst>
                                         </p:cTn>
                                         <p:tgtEl>
-                                          <p:spTgt spid="23"/>
+                                          <p:spTgt spid="30"/>
                                         </p:tgtEl>
                                         <p:attrNameLst>
                                           <p:attrName>style.visibility</p:attrName>
@@ -3202,7 +4185,7 @@
                                       <p:cBhvr>
                                         <p:cTn id="64" dur="400"/>
                                         <p:tgtEl>
-                                          <p:spTgt spid="23"/>
+                                          <p:spTgt spid="30"/>
                                         </p:tgtEl>
                                       </p:cBhvr>
                                     </p:animEffect>
@@ -3223,7 +4206,7 @@
                                           </p:stCondLst>
                                         </p:cTn>
                                         <p:tgtEl>
-                                          <p:spTgt spid="24"/>
+                                          <p:spTgt spid="31"/>
                                         </p:tgtEl>
                                         <p:attrNameLst>
                                           <p:attrName>style.visibility</p:attrName>
@@ -3237,7 +4220,7 @@
                                       <p:cBhvr>
                                         <p:cTn id="69" dur="400"/>
                                         <p:tgtEl>
-                                          <p:spTgt spid="24"/>
+                                          <p:spTgt spid="31"/>
                                         </p:tgtEl>
                                       </p:cBhvr>
                                     </p:animEffect>
@@ -3258,7 +4241,7 @@
                                           </p:stCondLst>
                                         </p:cTn>
                                         <p:tgtEl>
-                                          <p:spTgt spid="30"/>
+                                          <p:spTgt spid="34"/>
                                         </p:tgtEl>
                                         <p:attrNameLst>
                                           <p:attrName>style.visibility</p:attrName>
@@ -3272,217 +4255,7 @@
                                       <p:cBhvr>
                                         <p:cTn id="74" dur="400"/>
                                         <p:tgtEl>
-                                          <p:spTgt spid="30"/>
-                                        </p:tgtEl>
-                                      </p:cBhvr>
-                                    </p:animEffect>
-                                  </p:childTnLst>
-                                </p:cTn>
-                              </p:par>
-                              <p:par>
-                                <p:cTn id="77" presetID="10" presetClass="entr" presetSubtype="0" fill="hold" nodeType="withEffect">
-                                  <p:stCondLst>
-                                    <p:cond delay="0"/>
-                                  </p:stCondLst>
-                                  <p:childTnLst>
-                                    <p:set>
-                                      <p:cBhvr>
-                                        <p:cTn id="78" dur="1" fill="hold">
-                                          <p:stCondLst>
-                                            <p:cond delay="0"/>
-                                          </p:stCondLst>
-                                        </p:cTn>
-                                        <p:tgtEl>
-                                          <p:spTgt spid="31"/>
-                                        </p:tgtEl>
-                                        <p:attrNameLst>
-                                          <p:attrName>style.visibility</p:attrName>
-                                        </p:attrNameLst>
-                                      </p:cBhvr>
-                                      <p:to>
-                                        <p:strVal val="visible"/>
-                                      </p:to>
-                                    </p:set>
-                                    <p:animEffect transition="in" filter="fade">
-                                      <p:cBhvr>
-                                        <p:cTn id="79" dur="400"/>
-                                        <p:tgtEl>
-                                          <p:spTgt spid="31"/>
-                                        </p:tgtEl>
-                                      </p:cBhvr>
-                                    </p:animEffect>
-                                  </p:childTnLst>
-                                </p:cTn>
-                              </p:par>
-                              <p:par>
-                                <p:cTn id="82" presetID="10" presetClass="entr" presetSubtype="0" fill="hold" nodeType="withEffect">
-                                  <p:stCondLst>
-                                    <p:cond delay="0"/>
-                                  </p:stCondLst>
-                                  <p:childTnLst>
-                                    <p:set>
-                                      <p:cBhvr>
-                                        <p:cTn id="83" dur="1" fill="hold">
-                                          <p:stCondLst>
-                                            <p:cond delay="0"/>
-                                          </p:stCondLst>
-                                        </p:cTn>
-                                        <p:tgtEl>
-                                          <p:spTgt spid="32"/>
-                                        </p:tgtEl>
-                                        <p:attrNameLst>
-                                          <p:attrName>style.visibility</p:attrName>
-                                        </p:attrNameLst>
-                                      </p:cBhvr>
-                                      <p:to>
-                                        <p:strVal val="visible"/>
-                                      </p:to>
-                                    </p:set>
-                                    <p:animEffect transition="in" filter="fade">
-                                      <p:cBhvr>
-                                        <p:cTn id="84" dur="400"/>
-                                        <p:tgtEl>
-                                          <p:spTgt spid="32"/>
-                                        </p:tgtEl>
-                                      </p:cBhvr>
-                                    </p:animEffect>
-                                  </p:childTnLst>
-                                </p:cTn>
-                              </p:par>
-                              <p:par>
-                                <p:cTn id="87" presetID="10" presetClass="entr" presetSubtype="0" fill="hold" nodeType="withEffect">
-                                  <p:stCondLst>
-                                    <p:cond delay="0"/>
-                                  </p:stCondLst>
-                                  <p:childTnLst>
-                                    <p:set>
-                                      <p:cBhvr>
-                                        <p:cTn id="88" dur="1" fill="hold">
-                                          <p:stCondLst>
-                                            <p:cond delay="0"/>
-                                          </p:stCondLst>
-                                        </p:cTn>
-                                        <p:tgtEl>
-                                          <p:spTgt spid="33"/>
-                                        </p:tgtEl>
-                                        <p:attrNameLst>
-                                          <p:attrName>style.visibility</p:attrName>
-                                        </p:attrNameLst>
-                                      </p:cBhvr>
-                                      <p:to>
-                                        <p:strVal val="visible"/>
-                                      </p:to>
-                                    </p:set>
-                                    <p:animEffect transition="in" filter="fade">
-                                      <p:cBhvr>
-                                        <p:cTn id="89" dur="400"/>
-                                        <p:tgtEl>
-                                          <p:spTgt spid="33"/>
-                                        </p:tgtEl>
-                                      </p:cBhvr>
-                                    </p:animEffect>
-                                  </p:childTnLst>
-                                </p:cTn>
-                              </p:par>
-                              <p:par>
-                                <p:cTn id="92" presetID="10" presetClass="entr" presetSubtype="0" fill="hold" nodeType="withEffect">
-                                  <p:stCondLst>
-                                    <p:cond delay="0"/>
-                                  </p:stCondLst>
-                                  <p:childTnLst>
-                                    <p:set>
-                                      <p:cBhvr>
-                                        <p:cTn id="93" dur="1" fill="hold">
-                                          <p:stCondLst>
-                                            <p:cond delay="0"/>
-                                          </p:stCondLst>
-                                        </p:cTn>
-                                        <p:tgtEl>
                                           <p:spTgt spid="34"/>
-                                        </p:tgtEl>
-                                        <p:attrNameLst>
-                                          <p:attrName>style.visibility</p:attrName>
-                                        </p:attrNameLst>
-                                      </p:cBhvr>
-                                      <p:to>
-                                        <p:strVal val="visible"/>
-                                      </p:to>
-                                    </p:set>
-                                    <p:animEffect transition="in" filter="fade">
-                                      <p:cBhvr>
-                                        <p:cTn id="94" dur="400"/>
-                                        <p:tgtEl>
-                                          <p:spTgt spid="34"/>
-                                        </p:tgtEl>
-                                      </p:cBhvr>
-                                    </p:animEffect>
-                                  </p:childTnLst>
-                                </p:cTn>
-                              </p:par>
-                              <p:par>
-                                <p:cTn id="97" presetID="10" presetClass="entr" presetSubtype="0" fill="hold" nodeType="withEffect">
-                                  <p:stCondLst>
-                                    <p:cond delay="0"/>
-                                  </p:stCondLst>
-                                  <p:childTnLst>
-                                    <p:set>
-                                      <p:cBhvr>
-                                        <p:cTn id="98" dur="1" fill="hold">
-                                          <p:stCondLst>
-                                            <p:cond delay="0"/>
-                                          </p:stCondLst>
-                                        </p:cTn>
-                                        <p:tgtEl>
-                                          <p:spTgt spid="40"/>
-                                        </p:tgtEl>
-                                        <p:attrNameLst>
-                                          <p:attrName>style.visibility</p:attrName>
-                                        </p:attrNameLst>
-                                      </p:cBhvr>
-                                      <p:to>
-                                        <p:strVal val="visible"/>
-                                      </p:to>
-                                    </p:set>
-                                    <p:animEffect transition="in" filter="fade">
-                                      <p:cBhvr>
-                                        <p:cTn id="99" dur="400"/>
-                                        <p:tgtEl>
-                                          <p:spTgt spid="40"/>
-                                        </p:tgtEl>
-                                      </p:cBhvr>
-                                    </p:animEffect>
-                                  </p:childTnLst>
-                                </p:cTn>
-                              </p:par>
-                              <p:par>
-                                <p:cTn id="102" presetID="10" presetClass="entr" presetSubtype="0" fill="hold" nodeType="withEffect">
-                                  <p:stCondLst>
-                                    <p:cond delay="0"/>
-                                  </p:stCondLst>
-                                  <p:childTnLst>
-                                    <p:set>
-                                      <p:cBhvr>
-                                        <p:cTn id="103" dur="1" fill="hold">
-                                          <p:stCondLst>
-                                            <p:cond delay="0"/>
-                                          </p:stCondLst>
-                                        </p:cTn>
-                                        <p:tgtEl>
-                                          <p:spTgt spid="41"/>
-                                        </p:tgtEl>
-                                        <p:attrNameLst>
-                                          <p:attrName>style.visibility</p:attrName>
-                                        </p:attrNameLst>
-                                      </p:cBhvr>
-                                      <p:to>
-                                        <p:strVal val="visible"/>
-                                      </p:to>
-                                    </p:set>
-                                    <p:animEffect transition="in" filter="fade">
-                                      <p:cBhvr>
-                                        <p:cTn id="104" dur="400"/>
-                                        <p:tgtEl>
-                                          <p:spTgt spid="41"/>
                                         </p:tgtEl>
                                       </p:cBhvr>
                                     </p:animEffect>
@@ -18062,7 +18835,7 @@
                 </a:solidFill>
                 <a:latin typeface="Trebuchet MS"/>
               </a:rPr>
-              <a:t>SQLite timings across the four sizes. The useful question is not «which is faster» but </a:t>
+              <a:t>SQLite across the four sizes. The useful question is not «which is faster» but </a:t>
             </a:r>
             <a:r>
               <a:rPr lang="it-IT" sz="1350" b="1" dirty="0">
@@ -18080,7 +18853,7 @@
                 </a:solidFill>
                 <a:latin typeface="Trebuchet MS"/>
               </a:rPr>
-              <a:t>.</a:t>
+              <a:t>. Both engines side by side on the next slide.</a:t>
             </a:r>
           </a:p>
         </p:txBody>

</xml_diff>

<commit_message>
Update benchmark results and demo queries for Q4 fund tracing performance
</commit_message>
<xml_diff>
--- a/presentation/NodeCoin - Damiano Spadaccini.pptx
+++ b/presentation/NodeCoin - Damiano Spadaccini.pptx
@@ -2067,7 +2067,7 @@
                 </a:solidFill>
                 <a:latin typeface="Arial"/>
               </a:rPr>
-              <a:t>Q4 · timeout at every size</a:t>
+              <a:t>Q4 · follows the start address</a:t>
             </a:r>
           </a:p>
         </p:txBody>
@@ -2105,7 +2105,7 @@
                 </a:solidFill>
                 <a:latin typeface="Arial"/>
               </a:rPr>
-              <a:t>Cypher lists every path, up to 8 hops</a:t>
+              <a:t>0.14 s → 13.8 s</a:t>
             </a:r>
           </a:p>
           <a:p>
@@ -2121,7 +2121,7 @@
                 </a:solidFill>
                 <a:latin typeface="Arial"/>
               </a:rPr>
-              <a:t>paths multiply at each hop</a:t>
+              <a:t>start address 2.5k → 56k outputs</a:t>
             </a:r>
           </a:p>
           <a:p>
@@ -2137,7 +2137,7 @@
                 </a:solidFill>
                 <a:latin typeface="Arial"/>
               </a:rPr>
-              <a:t>too many already at 50 blocks</a:t>
+              <a:t>the same walk as the SQL query</a:t>
             </a:r>
           </a:p>
         </p:txBody>
@@ -2429,7 +2429,7 @@
                 </a:solidFill>
                 <a:latin typeface="Arial"/>
               </a:rPr>
-              <a:t>Same shape as SQLite, except Q4</a:t>
+              <a:t>Same shape as SQLite</a:t>
             </a:r>
           </a:p>
         </p:txBody>
@@ -3404,6 +3404,125 @@
             <a:avLst/>
           </a:prstGeom>
           <a:solidFill>
+            <a:srgbClr val="B3261E"/>
+          </a:solidFill>
+          <a:ln>
+            <a:noFill/>
+          </a:ln>
+        </p:spPr>
+        <p:txBody>
+          <a:bodyPr/>
+          <a:lstStyle/>
+          <a:p/>
+        </p:txBody>
+      </p:sp>
+      <p:sp>
+        <p:nvSpPr>
+          <p:cNvPr id="27" name="tb27"/>
+          <p:cNvSpPr txBox="1"/>
+          <p:nvPr/>
+        </p:nvSpPr>
+        <p:spPr>
+          <a:xfrm>
+            <a:off x="8640000" y="2800000"/>
+            <a:ext cx="2792000" cy="300000"/>
+          </a:xfrm>
+          <a:prstGeom prst="rect">
+            <a:avLst/>
+          </a:prstGeom>
+        </p:spPr>
+        <p:txBody>
+          <a:bodyPr wrap="square" rtlCol="0" anchor="t">
+            <a:normAutofit/>
+          </a:bodyPr>
+          <a:lstStyle/>
+          <a:p>
+            <a:pPr algn="l">
+              <a:lnSpc>
+                <a:spcPct val="100000"/>
+              </a:lnSpc>
+            </a:pPr>
+            <a:r>
+              <a:rPr lang="it-IT" sz="1150" b="1" dirty="0">
+                <a:solidFill>
+                  <a:srgbClr val="B3261E"/>
+                </a:solidFill>
+                <a:latin typeface="Arial"/>
+              </a:rPr>
+              <a:t>SQLite side · Q4</a:t>
+            </a:r>
+          </a:p>
+        </p:txBody>
+      </p:sp>
+      <p:sp>
+        <p:nvSpPr>
+          <p:cNvPr id="28" name="tb28"/>
+          <p:cNvSpPr txBox="1"/>
+          <p:nvPr/>
+        </p:nvSpPr>
+        <p:spPr>
+          <a:xfrm>
+            <a:off x="8640000" y="3070000"/>
+            <a:ext cx="2792000" cy="440000"/>
+          </a:xfrm>
+          <a:prstGeom prst="rect">
+            <a:avLst/>
+          </a:prstGeom>
+        </p:spPr>
+        <p:txBody>
+          <a:bodyPr wrap="square" rtlCol="0" anchor="t">
+            <a:normAutofit/>
+          </a:bodyPr>
+          <a:lstStyle/>
+          <a:p>
+            <a:pPr algn="l">
+              <a:lnSpc>
+                <a:spcPct val="110000"/>
+              </a:lnSpc>
+            </a:pPr>
+            <a:r>
+              <a:rPr lang="it-IT" sz="1000" b="0" dirty="0">
+                <a:solidFill>
+                  <a:srgbClr val="4A4A4A"/>
+                </a:solidFill>
+                <a:latin typeface="Arial"/>
+              </a:rPr>
+              <a:t>1.2x → 1.5x, equal at 500</a:t>
+            </a:r>
+          </a:p>
+          <a:p>
+            <a:pPr algn="l">
+              <a:lnSpc>
+                <a:spcPct val="110000"/>
+              </a:lnSpc>
+            </a:pPr>
+            <a:r>
+              <a:rPr lang="it-IT" sz="1000" b="0" dirty="0">
+                <a:solidFill>
+                  <a:srgbClr val="4A4A4A"/>
+                </a:solidFill>
+                <a:latin typeface="Arial"/>
+              </a:rPr>
+              <a:t>same walk, SQLite a bit faster</a:t>
+            </a:r>
+          </a:p>
+        </p:txBody>
+      </p:sp>
+      <p:sp>
+        <p:nvSpPr>
+          <p:cNvPr id="29" name="sr29"/>
+          <p:cNvSpPr/>
+          <p:nvPr/>
+        </p:nvSpPr>
+        <p:spPr>
+          <a:xfrm>
+            <a:off x="8510000" y="3580000"/>
+            <a:ext cx="45000" cy="580000"/>
+          </a:xfrm>
+          <a:prstGeom prst="rect">
+            <a:avLst/>
+          </a:prstGeom>
+          <a:solidFill>
             <a:srgbClr val="C98A00"/>
           </a:solidFill>
           <a:ln>
@@ -3418,13 +3537,13 @@
       </p:sp>
       <p:sp>
         <p:nvSpPr>
-          <p:cNvPr id="27" name="tb27"/>
+          <p:cNvPr id="30" name="tb30"/>
           <p:cNvSpPr txBox="1"/>
           <p:nvPr/>
         </p:nvSpPr>
         <p:spPr>
           <a:xfrm>
-            <a:off x="8640000" y="2800000"/>
+            <a:off x="8640000" y="3560000"/>
             <a:ext cx="2792000" cy="300000"/>
           </a:xfrm>
           <a:prstGeom prst="rect">
@@ -3456,13 +3575,13 @@
       </p:sp>
       <p:sp>
         <p:nvSpPr>
-          <p:cNvPr id="28" name="tb28"/>
+          <p:cNvPr id="31" name="tb31"/>
           <p:cNvSpPr txBox="1"/>
           <p:nvPr/>
         </p:nvSpPr>
         <p:spPr>
           <a:xfrm>
-            <a:off x="8640000" y="3070000"/>
+            <a:off x="8640000" y="3830000"/>
             <a:ext cx="2792000" cy="440000"/>
           </a:xfrm>
           <a:prstGeom prst="rect">
@@ -3510,13 +3629,13 @@
       </p:sp>
       <p:sp>
         <p:nvSpPr>
-          <p:cNvPr id="29" name="sr29"/>
+          <p:cNvPr id="32" name="sr32"/>
           <p:cNvSpPr/>
           <p:nvPr/>
         </p:nvSpPr>
         <p:spPr>
           <a:xfrm>
-            <a:off x="8510000" y="3580000"/>
+            <a:off x="8510000" y="4340000"/>
             <a:ext cx="45000" cy="580000"/>
           </a:xfrm>
           <a:prstGeom prst="rect">
@@ -3537,13 +3656,13 @@
       </p:sp>
       <p:sp>
         <p:nvSpPr>
-          <p:cNvPr id="30" name="tb30"/>
+          <p:cNvPr id="33" name="tb33"/>
           <p:cNvSpPr txBox="1"/>
           <p:nvPr/>
         </p:nvSpPr>
         <p:spPr>
           <a:xfrm>
-            <a:off x="8640000" y="3560000"/>
+            <a:off x="8640000" y="4320000"/>
             <a:ext cx="2792000" cy="300000"/>
           </a:xfrm>
           <a:prstGeom prst="rect">
@@ -3575,13 +3694,13 @@
       </p:sp>
       <p:sp>
         <p:nvSpPr>
-          <p:cNvPr id="31" name="tb31"/>
+          <p:cNvPr id="34" name="tb34"/>
           <p:cNvSpPr txBox="1"/>
           <p:nvPr/>
         </p:nvSpPr>
         <p:spPr>
           <a:xfrm>
-            <a:off x="8640000" y="3830000"/>
+            <a:off x="8640000" y="4590000"/>
             <a:ext cx="2792000" cy="440000"/>
           </a:xfrm>
           <a:prstGeom prst="rect">
@@ -3623,109 +3742,6 @@
                 <a:latin typeface="Arial"/>
               </a:rPr>
               <a:t>Neo4j fixed cost per query</a:t>
-            </a:r>
-          </a:p>
-        </p:txBody>
-      </p:sp>
-      <p:sp>
-        <p:nvSpPr>
-          <p:cNvPr id="32" name="sr32"/>
-          <p:cNvSpPr/>
-          <p:nvPr/>
-        </p:nvSpPr>
-        <p:spPr>
-          <a:xfrm>
-            <a:off x="8510000" y="4340000"/>
-            <a:ext cx="45000" cy="390000"/>
-          </a:xfrm>
-          <a:prstGeom prst="rect">
-            <a:avLst/>
-          </a:prstGeom>
-          <a:solidFill>
-            <a:srgbClr val="B3261E"/>
-          </a:solidFill>
-          <a:ln>
-            <a:noFill/>
-          </a:ln>
-        </p:spPr>
-        <p:txBody>
-          <a:bodyPr/>
-          <a:lstStyle/>
-          <a:p/>
-        </p:txBody>
-      </p:sp>
-      <p:sp>
-        <p:nvSpPr>
-          <p:cNvPr id="33" name="tb33"/>
-          <p:cNvSpPr txBox="1"/>
-          <p:nvPr/>
-        </p:nvSpPr>
-        <p:spPr>
-          <a:xfrm>
-            <a:off x="8640000" y="4320000"/>
-            <a:ext cx="2792000" cy="300000"/>
-          </a:xfrm>
-          <a:prstGeom prst="rect">
-            <a:avLst/>
-          </a:prstGeom>
-        </p:spPr>
-        <p:txBody>
-          <a:bodyPr wrap="square" rtlCol="0" anchor="t">
-            <a:normAutofit/>
-          </a:bodyPr>
-          <a:lstStyle/>
-          <a:p>
-            <a:pPr algn="l">
-              <a:lnSpc>
-                <a:spcPct val="100000"/>
-              </a:lnSpc>
-            </a:pPr>
-            <a:r>
-              <a:rPr lang="it-IT" sz="1150" b="1" dirty="0">
-                <a:solidFill>
-                  <a:srgbClr val="B3261E"/>
-                </a:solidFill>
-                <a:latin typeface="Arial"/>
-              </a:rPr>
-              <a:t>Q4 · no ratio</a:t>
-            </a:r>
-          </a:p>
-        </p:txBody>
-      </p:sp>
-      <p:sp>
-        <p:nvSpPr>
-          <p:cNvPr id="34" name="tb34"/>
-          <p:cNvSpPr txBox="1"/>
-          <p:nvPr/>
-        </p:nvSpPr>
-        <p:spPr>
-          <a:xfrm>
-            <a:off x="8640000" y="4590000"/>
-            <a:ext cx="2792000" cy="250000"/>
-          </a:xfrm>
-          <a:prstGeom prst="rect">
-            <a:avLst/>
-          </a:prstGeom>
-        </p:spPr>
-        <p:txBody>
-          <a:bodyPr wrap="square" rtlCol="0" anchor="t">
-            <a:normAutofit/>
-          </a:bodyPr>
-          <a:lstStyle/>
-          <a:p>
-            <a:pPr algn="l">
-              <a:lnSpc>
-                <a:spcPct val="110000"/>
-              </a:lnSpc>
-            </a:pPr>
-            <a:r>
-              <a:rPr lang="it-IT" sz="1000" b="0" dirty="0">
-                <a:solidFill>
-                  <a:srgbClr val="4A4A4A"/>
-                </a:solidFill>
-                <a:latin typeface="Arial"/>
-              </a:rPr>
-              <a:t>Neo4j times out at every size</a:t>
             </a:r>
           </a:p>
         </p:txBody>
@@ -18127,11 +18143,11 @@
             <a:r>
               <a:rPr lang="it-IT" sz="1250" b="0" dirty="0">
                 <a:solidFill>
-                  <a:srgbClr val="B3261E"/>
-                </a:solidFill>
-                <a:latin typeface="Arial"/>
-              </a:rPr>
-              <a:t>timeout</a:t>
+                  <a:srgbClr val="1F1F1F"/>
+                </a:solidFill>
+                <a:latin typeface="Arial"/>
+              </a:rPr>
+              <a:t>13.8 s</a:t>
             </a:r>
           </a:p>
         </p:txBody>
@@ -18169,7 +18185,7 @@
                 </a:solidFill>
                 <a:latin typeface="Arial"/>
               </a:rPr>
-              <a:t>SQLite only</a:t>
+              <a:t>SQLite 1.4x</a:t>
             </a:r>
           </a:p>
         </p:txBody>
@@ -18996,7 +19012,7 @@
         </p:nvSpPr>
         <p:spPr>
           <a:xfrm>
-            <a:off x="1146000" y="5300000"/>
+            <a:off x="1646000" y="5300000"/>
             <a:ext cx="2000000" cy="460000"/>
           </a:xfrm>
           <a:prstGeom prst="roundRect">
@@ -19029,7 +19045,7 @@
         </p:nvSpPr>
         <p:spPr>
           <a:xfrm>
-            <a:off x="1146000" y="5380000"/>
+            <a:off x="1646000" y="5380000"/>
             <a:ext cx="2000000" cy="320000"/>
           </a:xfrm>
           <a:prstGeom prst="rect">
@@ -19067,7 +19083,7 @@
         </p:nvSpPr>
         <p:spPr>
           <a:xfrm>
-            <a:off x="3346000" y="5300000"/>
+            <a:off x="3846000" y="5300000"/>
             <a:ext cx="2000000" cy="460000"/>
           </a:xfrm>
           <a:prstGeom prst="roundRect">
@@ -19100,7 +19116,7 @@
         </p:nvSpPr>
         <p:spPr>
           <a:xfrm>
-            <a:off x="3346000" y="5380000"/>
+            <a:off x="3846000" y="5380000"/>
             <a:ext cx="2000000" cy="320000"/>
           </a:xfrm>
           <a:prstGeom prst="rect">
@@ -19138,7 +19154,7 @@
         </p:nvSpPr>
         <p:spPr>
           <a:xfrm>
-            <a:off x="5546000" y="5300000"/>
+            <a:off x="6046000" y="5300000"/>
             <a:ext cx="1300000" cy="460000"/>
           </a:xfrm>
           <a:prstGeom prst="roundRect">
@@ -19171,7 +19187,7 @@
         </p:nvSpPr>
         <p:spPr>
           <a:xfrm>
-            <a:off x="5546000" y="5380000"/>
+            <a:off x="6046000" y="5380000"/>
             <a:ext cx="1300000" cy="320000"/>
           </a:xfrm>
           <a:prstGeom prst="rect">
@@ -19209,8 +19225,8 @@
         </p:nvSpPr>
         <p:spPr>
           <a:xfrm>
-            <a:off x="7046000" y="5300000"/>
-            <a:ext cx="4000000" cy="460000"/>
+            <a:off x="7546000" y="5300000"/>
+            <a:ext cx="3000000" cy="460000"/>
           </a:xfrm>
           <a:prstGeom prst="roundRect">
             <a:avLst>
@@ -19242,8 +19258,8 @@
         </p:nvSpPr>
         <p:spPr>
           <a:xfrm>
-            <a:off x="7046000" y="5380000"/>
-            <a:ext cx="4000000" cy="320000"/>
+            <a:off x="7546000" y="5380000"/>
+            <a:ext cx="3000000" cy="320000"/>
           </a:xfrm>
           <a:prstGeom prst="rect">
             <a:avLst/>
@@ -19267,7 +19283,7 @@
                 </a:solidFill>
                 <a:latin typeface="Arial"/>
               </a:rPr>
-              <a:t>1 fail each   Q4 on Neo4j  ·  Q7 on SQLite</a:t>
+              <a:t>only Neo4j answers Q7</a:t>
             </a:r>
           </a:p>
         </p:txBody>
@@ -28528,7 +28544,7 @@
             <a:avLst/>
           </a:prstGeom>
           <a:solidFill>
-            <a:srgbClr val="B3261E"/>
+            <a:srgbClr val="E07B00"/>
           </a:solidFill>
           <a:ln>
             <a:noFill/>
@@ -28569,7 +28585,7 @@
             <a:r>
               <a:rPr lang="it-IT" sz="1150" b="1" dirty="0">
                 <a:solidFill>
-                  <a:srgbClr val="B3261E"/>
+                  <a:srgbClr val="E07B00"/>
                 </a:solidFill>
                 <a:latin typeface="Arial"/>
               </a:rPr>
@@ -28602,7 +28618,7 @@
         </p:nvSpPr>
         <p:spPr>
           <a:xfrm>
-            <a:off x="3860000" y="2830000"/>
+            <a:off x="3860000" y="2800000"/>
             <a:ext cx="1150000" cy="440000"/>
           </a:xfrm>
           <a:prstGeom prst="rect">
@@ -28621,13 +28637,13 @@
               </a:lnSpc>
             </a:pPr>
             <a:r>
-              <a:rPr lang="it-IT" sz="1250" b="1" dirty="0">
-                <a:solidFill>
-                  <a:srgbClr val="B3261E"/>
-                </a:solidFill>
-                <a:latin typeface="Arial"/>
-              </a:rPr>
-              <a:t>timeout on Neo4j</a:t>
+              <a:rPr lang="it-IT" sz="2000" b="1" dirty="0">
+                <a:solidFill>
+                  <a:srgbClr val="E07B00"/>
+                </a:solidFill>
+                <a:latin typeface="Arial"/>
+              </a:rPr>
+              <a:t>1.4x</a:t>
             </a:r>
           </a:p>
         </p:txBody>
@@ -28674,7 +28690,7 @@
                 </a:solidFill>
                 <a:latin typeface="Arial"/>
               </a:rPr>
-              <a:t>, keeps the outputs it reaches · 9.7 s</a:t>
+              <a:t>, follows the spent outputs · 9.7 s</a:t>
             </a:r>
           </a:p>
         </p:txBody>
@@ -28712,7 +28728,7 @@
                 </a:solidFill>
                 <a:latin typeface="Arial"/>
               </a:rPr>
-              <a:t>lists every path</a:t>
+              <a:t>the same walk</a:t>
             </a:r>
             <a:r>
               <a:rPr lang="it-IT" sz="1100" b="0" dirty="0">
@@ -28721,7 +28737,7 @@
                 </a:solidFill>
                 <a:latin typeface="Arial"/>
               </a:rPr>
-              <a:t> up to 8 hops · &gt; 90 s</a:t>
+              <a:t>, output by output · 13.8 s</a:t>
             </a:r>
           </a:p>
         </p:txBody>
@@ -28983,7 +28999,7 @@
                 </a:solidFill>
                 <a:latin typeface="Arial"/>
               </a:rPr>
-              <a:t>Local query, or paths instead of nodes   →   </a:t>
+              <a:t>Local query  →  8.4x     same walk on both  →  1.4x     </a:t>
             </a:r>
             <a:r>
               <a:rPr lang="it-IT" sz="1300" b="1" dirty="0">

</xml_diff>

<commit_message>
Fair queries and a single final benchmark run
- Q3/Q7 sum unspent outputs instead of received minus spent
- Q8 in Cypher uses the same MAX + lookup as SQL
- MATERIALIZED CTEs in Q1/Q8, no tie-breaks in measured queries
- Both scaling runs redone from scratch; results JSON, README and
  slides regenerated from the CSVs
- Slide 9 shows Q1 as the SQL vs Cypher example
- demo/demo_queries.cypher no longer tracked; the READMEs point to
  queries/queries.cypher
</commit_message>
<xml_diff>
--- a/presentation/NodeCoin - Damiano Spadaccini.pptx
+++ b/presentation/NodeCoin - Damiano Spadaccini.pptx
@@ -769,7 +769,7 @@
                 </a:solidFill>
                 <a:latin typeface="Arial"/>
               </a:rPr>
-              <a:t>1-2 s → 40-60 s</a:t>
+              <a:t>0.86-1.8 s → 26-56 s</a:t>
             </a:r>
           </a:p>
           <a:p>
@@ -785,7 +785,7 @@
                 </a:solidFill>
                 <a:latin typeface="Arial"/>
               </a:rPr>
-              <a:t>30x the time for 19x the data</a:t>
+              <a:t>30-31x the time for 19x the data</a:t>
             </a:r>
           </a:p>
         </p:txBody>
@@ -888,7 +888,7 @@
                 </a:solidFill>
                 <a:latin typeface="Arial"/>
               </a:rPr>
-              <a:t>0.3-0.5 s → 9-15 s</a:t>
+              <a:t>0.31-0.61 s → 9-16 s</a:t>
             </a:r>
           </a:p>
           <a:p>
@@ -904,7 +904,7 @@
                 </a:solidFill>
                 <a:latin typeface="Arial"/>
               </a:rPr>
-              <a:t>grow with the data, stay usable</a:t>
+              <a:t>27-30x the time, but stay under 16 s</a:t>
             </a:r>
           </a:p>
         </p:txBody>
@@ -1007,7 +1007,7 @@
                 </a:solidFill>
                 <a:latin typeface="Arial"/>
               </a:rPr>
-              <a:t>0.1 s → 9 s, in jumps</a:t>
+              <a:t>0.12 s → 8.9 s, in jumps</a:t>
             </a:r>
           </a:p>
           <a:p>
@@ -1126,7 +1126,7 @@
                 </a:solidFill>
                 <a:latin typeface="Arial"/>
               </a:rPr>
-              <a:t>0.07 ms → 1.8 ms</a:t>
+              <a:t>0.073 ms → 1.8 ms</a:t>
             </a:r>
           </a:p>
           <a:p>
@@ -1143,6 +1143,134 @@
                 <a:latin typeface="Arial"/>
               </a:rPr>
               <a:t>reads only the blocks table, ≤ 977 rows</a:t>
+            </a:r>
+          </a:p>
+        </p:txBody>
+      </p:sp>
+      <p:sp>
+        <p:nvSpPr>
+          <p:cNvPr id="32" name="sr32"/>
+          <p:cNvSpPr/>
+          <p:nvPr/>
+        </p:nvSpPr>
+        <p:spPr>
+          <a:xfrm>
+            <a:off x="8510000" y="4340000"/>
+            <a:ext cx="45000" cy="580000"/>
+          </a:xfrm>
+          <a:prstGeom prst="rect">
+            <a:avLst/>
+          </a:prstGeom>
+          <a:solidFill>
+            <a:srgbClr val="7B3FA0"/>
+          </a:solidFill>
+          <a:ln>
+            <a:noFill/>
+          </a:ln>
+        </p:spPr>
+        <p:txBody>
+          <a:bodyPr/>
+          <a:lstStyle/>
+          <a:p/>
+        </p:txBody>
+      </p:sp>
+      <p:sp>
+        <p:nvSpPr>
+          <p:cNvPr id="33" name="tb33"/>
+          <p:cNvSpPr txBox="1"/>
+          <p:nvPr/>
+        </p:nvSpPr>
+        <p:spPr>
+          <a:xfrm>
+            <a:off x="8640000" y="4320000"/>
+            <a:ext cx="2792000" cy="300000"/>
+          </a:xfrm>
+          <a:prstGeom prst="rect">
+            <a:avLst/>
+          </a:prstGeom>
+        </p:spPr>
+        <p:txBody>
+          <a:bodyPr wrap="square" rtlCol="0" anchor="t">
+            <a:normAutofit/>
+          </a:bodyPr>
+          <a:lstStyle/>
+          <a:p>
+            <a:pPr algn="l">
+              <a:lnSpc>
+                <a:spcPct val="100000"/>
+              </a:lnSpc>
+            </a:pPr>
+            <a:r>
+              <a:rPr lang="it-IT" sz="1150" b="1" dirty="0">
+                <a:solidFill>
+                  <a:srgbClr val="7B3FA0"/>
+                </a:solidFill>
+                <a:latin typeface="Arial"/>
+              </a:rPr>
+              <a:t>Q7 wallet</a:t>
+            </a:r>
+            <a:r>
+              <a:rPr lang="it-IT" sz="800" b="0" dirty="0">
+                <a:solidFill>
+                  <a:srgbClr val="B3261E"/>
+                </a:solidFill>
+                <a:latin typeface="Arial"/>
+              </a:rPr>
+              <a:t>*</a:t>
+            </a:r>
+          </a:p>
+        </p:txBody>
+      </p:sp>
+      <p:sp>
+        <p:nvSpPr>
+          <p:cNvPr id="34" name="tb34"/>
+          <p:cNvSpPr txBox="1"/>
+          <p:nvPr/>
+        </p:nvSpPr>
+        <p:spPr>
+          <a:xfrm>
+            <a:off x="8640000" y="4590000"/>
+            <a:ext cx="2792000" cy="440000"/>
+          </a:xfrm>
+          <a:prstGeom prst="rect">
+            <a:avLst/>
+          </a:prstGeom>
+        </p:spPr>
+        <p:txBody>
+          <a:bodyPr wrap="square" rtlCol="0" anchor="t">
+            <a:normAutofit/>
+          </a:bodyPr>
+          <a:lstStyle/>
+          <a:p>
+            <a:pPr algn="l">
+              <a:lnSpc>
+                <a:spcPct val="110000"/>
+              </a:lnSpc>
+            </a:pPr>
+            <a:r>
+              <a:rPr lang="it-IT" sz="1000" b="0" dirty="0">
+                <a:solidFill>
+                  <a:srgbClr val="4A4A4A"/>
+                </a:solidFill>
+                <a:latin typeface="Arial"/>
+              </a:rPr>
+              <a:t>1.0 s → 5.1 s, at 50-200 blocks</a:t>
+            </a:r>
+          </a:p>
+          <a:p>
+            <a:pPr algn="l">
+              <a:lnSpc>
+                <a:spcPct val="110000"/>
+              </a:lnSpc>
+            </a:pPr>
+            <a:r>
+              <a:rPr lang="it-IT" sz="1000" b="0" dirty="0">
+                <a:solidFill>
+                  <a:srgbClr val="4A4A4A"/>
+                </a:solidFill>
+                <a:latin typeface="Arial"/>
+              </a:rPr>
+              <a:t>grows like Q3 · dashed = projected</a:t>
             </a:r>
           </a:p>
         </p:txBody>
@@ -1255,13 +1383,13 @@
                     </p:cTn>
                   </p:par>
                   <p:par>
-                    <p:cTn id="100" fill="hold">
+                    <p:cTn id="115" fill="hold">
                       <p:stCondLst>
                         <p:cond delay="indefinite"/>
                       </p:stCondLst>
                       <p:childTnLst>
                         <p:par>
-                          <p:cTn id="101" fill="hold">
+                          <p:cTn id="116" fill="hold">
                             <p:stCondLst>
                               <p:cond delay="0"/>
                             </p:stCondLst>
@@ -1700,6 +1828,111 @@
                                           </p:stCondLst>
                                         </p:cTn>
                                         <p:tgtEl>
+                                          <p:spTgt spid="32"/>
+                                        </p:tgtEl>
+                                        <p:attrNameLst>
+                                          <p:attrName>style.visibility</p:attrName>
+                                        </p:attrNameLst>
+                                      </p:cBhvr>
+                                      <p:to>
+                                        <p:strVal val="visible"/>
+                                      </p:to>
+                                    </p:set>
+                                    <p:animEffect transition="in" filter="fade">
+                                      <p:cBhvr>
+                                        <p:cTn id="99" dur="400"/>
+                                        <p:tgtEl>
+                                          <p:spTgt spid="32"/>
+                                        </p:tgtEl>
+                                      </p:cBhvr>
+                                    </p:animEffect>
+                                  </p:childTnLst>
+                                </p:cTn>
+                              </p:par>
+                              <p:par>
+                                <p:cTn id="102" presetID="10" presetClass="entr" presetSubtype="0" fill="hold" nodeType="withEffect">
+                                  <p:stCondLst>
+                                    <p:cond delay="0"/>
+                                  </p:stCondLst>
+                                  <p:childTnLst>
+                                    <p:set>
+                                      <p:cBhvr>
+                                        <p:cTn id="103" dur="1" fill="hold">
+                                          <p:stCondLst>
+                                            <p:cond delay="0"/>
+                                          </p:stCondLst>
+                                        </p:cTn>
+                                        <p:tgtEl>
+                                          <p:spTgt spid="33"/>
+                                        </p:tgtEl>
+                                        <p:attrNameLst>
+                                          <p:attrName>style.visibility</p:attrName>
+                                        </p:attrNameLst>
+                                      </p:cBhvr>
+                                      <p:to>
+                                        <p:strVal val="visible"/>
+                                      </p:to>
+                                    </p:set>
+                                    <p:animEffect transition="in" filter="fade">
+                                      <p:cBhvr>
+                                        <p:cTn id="104" dur="400"/>
+                                        <p:tgtEl>
+                                          <p:spTgt spid="33"/>
+                                        </p:tgtEl>
+                                      </p:cBhvr>
+                                    </p:animEffect>
+                                  </p:childTnLst>
+                                </p:cTn>
+                              </p:par>
+                              <p:par>
+                                <p:cTn id="107" presetID="10" presetClass="entr" presetSubtype="0" fill="hold" nodeType="withEffect">
+                                  <p:stCondLst>
+                                    <p:cond delay="0"/>
+                                  </p:stCondLst>
+                                  <p:childTnLst>
+                                    <p:set>
+                                      <p:cBhvr>
+                                        <p:cTn id="108" dur="1" fill="hold">
+                                          <p:stCondLst>
+                                            <p:cond delay="0"/>
+                                          </p:stCondLst>
+                                        </p:cTn>
+                                        <p:tgtEl>
+                                          <p:spTgt spid="34"/>
+                                        </p:tgtEl>
+                                        <p:attrNameLst>
+                                          <p:attrName>style.visibility</p:attrName>
+                                        </p:attrNameLst>
+                                      </p:cBhvr>
+                                      <p:to>
+                                        <p:strVal val="visible"/>
+                                      </p:to>
+                                    </p:set>
+                                    <p:animEffect transition="in" filter="fade">
+                                      <p:cBhvr>
+                                        <p:cTn id="109" dur="400"/>
+                                        <p:tgtEl>
+                                          <p:spTgt spid="34"/>
+                                        </p:tgtEl>
+                                      </p:cBhvr>
+                                    </p:animEffect>
+                                  </p:childTnLst>
+                                </p:cTn>
+                              </p:par>
+                              <p:par>
+                                <p:cTn id="112" presetID="10" presetClass="entr" presetSubtype="0" fill="hold" nodeType="withEffect">
+                                  <p:stCondLst>
+                                    <p:cond delay="0"/>
+                                  </p:stCondLst>
+                                  <p:childTnLst>
+                                    <p:set>
+                                      <p:cBhvr>
+                                        <p:cTn id="113" dur="1" fill="hold">
+                                          <p:stCondLst>
+                                            <p:cond delay="0"/>
+                                          </p:stCondLst>
+                                        </p:cTn>
+                                        <p:tgtEl>
                                           <p:spTgt spid="40"/>
                                         </p:tgtEl>
                                         <p:attrNameLst>
@@ -1712,7 +1945,7 @@
                                     </p:set>
                                     <p:animEffect transition="in" filter="fade">
                                       <p:cBhvr>
-                                        <p:cTn id="99" dur="400"/>
+                                        <p:cTn id="114" dur="400"/>
                                         <p:tgtEl>
                                           <p:spTgt spid="40"/>
                                         </p:tgtEl>
@@ -2105,7 +2338,7 @@
                 </a:solidFill>
                 <a:latin typeface="Arial"/>
               </a:rPr>
-              <a:t>0.14 s → 13.8 s</a:t>
+              <a:t>0.13 s → 10 s</a:t>
             </a:r>
           </a:p>
           <a:p>
@@ -2256,7 +2489,7 @@
                 </a:solidFill>
                 <a:latin typeface="Arial"/>
               </a:rPr>
-              <a:t>20-40x the time for 19x the data</a:t>
+              <a:t>19-36x the time for 19x the data</a:t>
             </a:r>
           </a:p>
         </p:txBody>
@@ -2359,7 +2592,7 @@
                 </a:solidFill>
                 <a:latin typeface="Arial"/>
               </a:rPr>
-              <a:t>8 ms → 17 ms</a:t>
+              <a:t>4.6 ms → 16 ms</a:t>
             </a:r>
           </a:p>
           <a:p>
@@ -2392,6 +2625,134 @@
                 <a:latin typeface="Arial"/>
               </a:rPr>
               <a:t>never touches the millions of outputs</a:t>
+            </a:r>
+          </a:p>
+        </p:txBody>
+      </p:sp>
+      <p:sp>
+        <p:nvSpPr>
+          <p:cNvPr id="29" name="sr29"/>
+          <p:cNvSpPr/>
+          <p:nvPr/>
+        </p:nvSpPr>
+        <p:spPr>
+          <a:xfrm>
+            <a:off x="8510000" y="3960000"/>
+            <a:ext cx="45000" cy="580000"/>
+          </a:xfrm>
+          <a:prstGeom prst="rect">
+            <a:avLst/>
+          </a:prstGeom>
+          <a:solidFill>
+            <a:srgbClr val="7B3FA0"/>
+          </a:solidFill>
+          <a:ln>
+            <a:noFill/>
+          </a:ln>
+        </p:spPr>
+        <p:txBody>
+          <a:bodyPr/>
+          <a:lstStyle/>
+          <a:p/>
+        </p:txBody>
+      </p:sp>
+      <p:sp>
+        <p:nvSpPr>
+          <p:cNvPr id="30" name="tb30"/>
+          <p:cNvSpPr txBox="1"/>
+          <p:nvPr/>
+        </p:nvSpPr>
+        <p:spPr>
+          <a:xfrm>
+            <a:off x="8640000" y="3940000"/>
+            <a:ext cx="2792000" cy="300000"/>
+          </a:xfrm>
+          <a:prstGeom prst="rect">
+            <a:avLst/>
+          </a:prstGeom>
+        </p:spPr>
+        <p:txBody>
+          <a:bodyPr wrap="square" rtlCol="0" anchor="t">
+            <a:normAutofit/>
+          </a:bodyPr>
+          <a:lstStyle/>
+          <a:p>
+            <a:pPr algn="l">
+              <a:lnSpc>
+                <a:spcPct val="100000"/>
+              </a:lnSpc>
+            </a:pPr>
+            <a:r>
+              <a:rPr lang="it-IT" sz="1150" b="1" dirty="0">
+                <a:solidFill>
+                  <a:srgbClr val="7B3FA0"/>
+                </a:solidFill>
+                <a:latin typeface="Arial"/>
+              </a:rPr>
+              <a:t>Q7 wallet</a:t>
+            </a:r>
+            <a:r>
+              <a:rPr lang="it-IT" sz="800" b="0" dirty="0">
+                <a:solidFill>
+                  <a:srgbClr val="B3261E"/>
+                </a:solidFill>
+                <a:latin typeface="Arial"/>
+              </a:rPr>
+              <a:t>*</a:t>
+            </a:r>
+          </a:p>
+        </p:txBody>
+      </p:sp>
+      <p:sp>
+        <p:nvSpPr>
+          <p:cNvPr id="31" name="tb31"/>
+          <p:cNvSpPr txBox="1"/>
+          <p:nvPr/>
+        </p:nvSpPr>
+        <p:spPr>
+          <a:xfrm>
+            <a:off x="8640000" y="4210000"/>
+            <a:ext cx="2792000" cy="440000"/>
+          </a:xfrm>
+          <a:prstGeom prst="rect">
+            <a:avLst/>
+          </a:prstGeom>
+        </p:spPr>
+        <p:txBody>
+          <a:bodyPr wrap="square" rtlCol="0" anchor="t">
+            <a:normAutofit/>
+          </a:bodyPr>
+          <a:lstStyle/>
+          <a:p>
+            <a:pPr algn="l">
+              <a:lnSpc>
+                <a:spcPct val="110000"/>
+              </a:lnSpc>
+            </a:pPr>
+            <a:r>
+              <a:rPr lang="it-IT" sz="1000" b="0" dirty="0">
+                <a:solidFill>
+                  <a:srgbClr val="4A4A4A"/>
+                </a:solidFill>
+                <a:latin typeface="Arial"/>
+              </a:rPr>
+              <a:t>0.4 s → 1.9 s, at 50-200 blocks</a:t>
+            </a:r>
+          </a:p>
+          <a:p>
+            <a:pPr algn="l">
+              <a:lnSpc>
+                <a:spcPct val="110000"/>
+              </a:lnSpc>
+            </a:pPr>
+            <a:r>
+              <a:rPr lang="it-IT" sz="1000" b="0" dirty="0">
+                <a:solidFill>
+                  <a:srgbClr val="4A4A4A"/>
+                </a:solidFill>
+                <a:latin typeface="Arial"/>
+              </a:rPr>
+              <a:t>grows like Q3 · dashed = projected</a:t>
             </a:r>
           </a:p>
         </p:txBody>
@@ -2504,13 +2865,13 @@
                     </p:cTn>
                   </p:par>
                   <p:par>
-                    <p:cTn id="85" fill="hold">
+                    <p:cTn id="100" fill="hold">
                       <p:stCondLst>
                         <p:cond delay="indefinite"/>
                       </p:stCondLst>
                       <p:childTnLst>
                         <p:par>
-                          <p:cTn id="86" fill="hold">
+                          <p:cTn id="101" fill="hold">
                             <p:stCondLst>
                               <p:cond delay="0"/>
                             </p:stCondLst>
@@ -2844,6 +3205,111 @@
                                           </p:stCondLst>
                                         </p:cTn>
                                         <p:tgtEl>
+                                          <p:spTgt spid="29"/>
+                                        </p:tgtEl>
+                                        <p:attrNameLst>
+                                          <p:attrName>style.visibility</p:attrName>
+                                        </p:attrNameLst>
+                                      </p:cBhvr>
+                                      <p:to>
+                                        <p:strVal val="visible"/>
+                                      </p:to>
+                                    </p:set>
+                                    <p:animEffect transition="in" filter="fade">
+                                      <p:cBhvr>
+                                        <p:cTn id="84" dur="400"/>
+                                        <p:tgtEl>
+                                          <p:spTgt spid="29"/>
+                                        </p:tgtEl>
+                                      </p:cBhvr>
+                                    </p:animEffect>
+                                  </p:childTnLst>
+                                </p:cTn>
+                              </p:par>
+                              <p:par>
+                                <p:cTn id="87" presetID="10" presetClass="entr" presetSubtype="0" fill="hold" nodeType="withEffect">
+                                  <p:stCondLst>
+                                    <p:cond delay="0"/>
+                                  </p:stCondLst>
+                                  <p:childTnLst>
+                                    <p:set>
+                                      <p:cBhvr>
+                                        <p:cTn id="88" dur="1" fill="hold">
+                                          <p:stCondLst>
+                                            <p:cond delay="0"/>
+                                          </p:stCondLst>
+                                        </p:cTn>
+                                        <p:tgtEl>
+                                          <p:spTgt spid="30"/>
+                                        </p:tgtEl>
+                                        <p:attrNameLst>
+                                          <p:attrName>style.visibility</p:attrName>
+                                        </p:attrNameLst>
+                                      </p:cBhvr>
+                                      <p:to>
+                                        <p:strVal val="visible"/>
+                                      </p:to>
+                                    </p:set>
+                                    <p:animEffect transition="in" filter="fade">
+                                      <p:cBhvr>
+                                        <p:cTn id="89" dur="400"/>
+                                        <p:tgtEl>
+                                          <p:spTgt spid="30"/>
+                                        </p:tgtEl>
+                                      </p:cBhvr>
+                                    </p:animEffect>
+                                  </p:childTnLst>
+                                </p:cTn>
+                              </p:par>
+                              <p:par>
+                                <p:cTn id="92" presetID="10" presetClass="entr" presetSubtype="0" fill="hold" nodeType="withEffect">
+                                  <p:stCondLst>
+                                    <p:cond delay="0"/>
+                                  </p:stCondLst>
+                                  <p:childTnLst>
+                                    <p:set>
+                                      <p:cBhvr>
+                                        <p:cTn id="93" dur="1" fill="hold">
+                                          <p:stCondLst>
+                                            <p:cond delay="0"/>
+                                          </p:stCondLst>
+                                        </p:cTn>
+                                        <p:tgtEl>
+                                          <p:spTgt spid="31"/>
+                                        </p:tgtEl>
+                                        <p:attrNameLst>
+                                          <p:attrName>style.visibility</p:attrName>
+                                        </p:attrNameLst>
+                                      </p:cBhvr>
+                                      <p:to>
+                                        <p:strVal val="visible"/>
+                                      </p:to>
+                                    </p:set>
+                                    <p:animEffect transition="in" filter="fade">
+                                      <p:cBhvr>
+                                        <p:cTn id="94" dur="400"/>
+                                        <p:tgtEl>
+                                          <p:spTgt spid="31"/>
+                                        </p:tgtEl>
+                                      </p:cBhvr>
+                                    </p:animEffect>
+                                  </p:childTnLst>
+                                </p:cTn>
+                              </p:par>
+                              <p:par>
+                                <p:cTn id="97" presetID="10" presetClass="entr" presetSubtype="0" fill="hold" nodeType="withEffect">
+                                  <p:stCondLst>
+                                    <p:cond delay="0"/>
+                                  </p:stCondLst>
+                                  <p:childTnLst>
+                                    <p:set>
+                                      <p:cBhvr>
+                                        <p:cTn id="98" dur="1" fill="hold">
+                                          <p:stCondLst>
+                                            <p:cond delay="0"/>
+                                          </p:stCondLst>
+                                        </p:cTn>
+                                        <p:tgtEl>
                                           <p:spTgt spid="40"/>
                                         </p:tgtEl>
                                         <p:attrNameLst>
@@ -2856,7 +3322,7 @@
                                     </p:set>
                                     <p:animEffect transition="in" filter="fade">
                                       <p:cBhvr>
-                                        <p:cTn id="84" dur="400"/>
+                                        <p:cTn id="99" dur="400"/>
                                         <p:tgtEl>
                                           <p:spTgt spid="40"/>
                                         </p:tgtEl>
@@ -3211,7 +3677,16 @@
                 </a:solidFill>
                 <a:latin typeface="Arial"/>
               </a:rPr>
-              <a:t>Neo4j side · Q3 · Q1</a:t>
+              <a:t>Neo4j side · Q1 · Q2 · Q3 · Q7</a:t>
+            </a:r>
+            <a:r>
+              <a:rPr lang="it-IT" sz="800" b="0" dirty="0">
+                <a:solidFill>
+                  <a:srgbClr val="B3261E"/>
+                </a:solidFill>
+                <a:latin typeface="Arial"/>
+              </a:rPr>
+              <a:t>*</a:t>
             </a:r>
           </a:p>
         </p:txBody>
@@ -3249,7 +3724,7 @@
                 </a:solidFill>
                 <a:latin typeface="Arial"/>
               </a:rPr>
-              <a:t>2-3x faster at every size</a:t>
+              <a:t>1.2-2.6x faster at every size</a:t>
             </a:r>
           </a:p>
           <a:p>
@@ -3330,7 +3805,7 @@
                 </a:solidFill>
                 <a:latin typeface="Arial"/>
               </a:rPr>
-              <a:t>about equal · Q2 · Q5</a:t>
+              <a:t>about equal · Q5</a:t>
             </a:r>
           </a:p>
         </p:txBody>
@@ -3368,7 +3843,7 @@
                 </a:solidFill>
                 <a:latin typeface="Arial"/>
               </a:rPr>
-              <a:t>within 1.5x either way</a:t>
+              <a:t>within 1.2x either way</a:t>
             </a:r>
           </a:p>
           <a:p>
@@ -3384,7 +3859,7 @@
                 </a:solidFill>
                 <a:latin typeface="Arial"/>
               </a:rPr>
-              <a:t>both scan every output</a:t>
+              <a:t>both count every output</a:t>
             </a:r>
           </a:p>
         </p:txBody>
@@ -3449,7 +3924,7 @@
                 </a:solidFill>
                 <a:latin typeface="Arial"/>
               </a:rPr>
-              <a:t>SQLite side · Q4</a:t>
+              <a:t>close · Q4</a:t>
             </a:r>
           </a:p>
         </p:txBody>
@@ -3487,7 +3962,7 @@
                 </a:solidFill>
                 <a:latin typeface="Arial"/>
               </a:rPr>
-              <a:t>1.2x → 1.5x, equal at 500</a:t>
+              <a:t>SQLite ahead at 3 sizes of 4</a:t>
             </a:r>
           </a:p>
           <a:p>
@@ -3503,7 +3978,7 @@
                 </a:solidFill>
                 <a:latin typeface="Arial"/>
               </a:rPr>
-              <a:t>same walk, SQLite a bit faster</a:t>
+              <a:t>same walk, within 1.5x either way</a:t>
             </a:r>
           </a:p>
         </p:txBody>
@@ -3606,7 +4081,7 @@
                 </a:solidFill>
                 <a:latin typeface="Arial"/>
               </a:rPr>
-              <a:t>3x → 4x for SQLite</a:t>
+              <a:t>2.3x → 1.8x for SQLite</a:t>
             </a:r>
           </a:p>
           <a:p>
@@ -3622,7 +4097,7 @@
                 </a:solidFill>
                 <a:latin typeface="Arial"/>
               </a:rPr>
-              <a:t>Cypher sorts the prices per transaction</a:t>
+              <a:t>no edge to follow, same lookup on both</a:t>
             </a:r>
           </a:p>
         </p:txBody>
@@ -3725,7 +4200,7 @@
                 </a:solidFill>
                 <a:latin typeface="Arial"/>
               </a:rPr>
-              <a:t>117x → 9x, always SQLite</a:t>
+              <a:t>62x → 8x, always SQLite</a:t>
             </a:r>
           </a:p>
           <a:p>
@@ -4829,7 +5304,7 @@
                 </a:solidFill>
                 <a:latin typeface="Arial"/>
               </a:rPr>
-              <a:t>9.4 min  ·  6.2 GB</a:t>
+              <a:t>5.5 min  ·  6.2 GB</a:t>
             </a:r>
           </a:p>
         </p:txBody>
@@ -4938,7 +5413,7 @@
                 </a:solidFill>
                 <a:latin typeface="Arial"/>
               </a:rPr>
-              <a:t>40.2 min  ·  16.3 GB</a:t>
+              <a:t>26.1 min  ·  17.4 GB</a:t>
             </a:r>
           </a:p>
         </p:txBody>
@@ -4976,7 +5451,7 @@
                 </a:solidFill>
                 <a:latin typeface="Arial"/>
               </a:rPr>
-              <a:t>4.3x slower, 2.6x disk</a:t>
+              <a:t>4.7x slower, 2.8x disk</a:t>
             </a:r>
             <a:r>
               <a:rPr lang="it-IT" sz="1100" b="0" dirty="0">
@@ -5023,7 +5498,25 @@
                 </a:solidFill>
                 <a:latin typeface="Arial"/>
               </a:rPr>
-              <a:t>WALLETS FOR Q7, BUILT BEFORE THE QUERY</a:t>
+              <a:t>WALLETS FOR Q7</a:t>
+            </a:r>
+            <a:r>
+              <a:rPr lang="it-IT" sz="800" b="0" dirty="0">
+                <a:solidFill>
+                  <a:srgbClr val="B3261E"/>
+                </a:solidFill>
+                <a:latin typeface="Arial"/>
+              </a:rPr>
+              <a:t>*</a:t>
+            </a:r>
+            <a:r>
+              <a:rPr lang="it-IT" sz="950" b="1" dirty="0">
+                <a:solidFill>
+                  <a:srgbClr val="8A8A8A"/>
+                </a:solidFill>
+                <a:latin typeface="Arial"/>
+              </a:rPr>
+              <a:t>, BUILT BEFORE THE QUERY  ·  200 BLOCKS</a:t>
             </a:r>
           </a:p>
         </p:txBody>
@@ -5132,7 +5625,7 @@
                 </a:solidFill>
                 <a:latin typeface="Arial"/>
               </a:rPr>
-              <a:t>84 min once  ·  then 12.3 s</a:t>
+              <a:t>clustering 7 min  ·  then 1.9 s</a:t>
             </a:r>
           </a:p>
         </p:txBody>
@@ -5154,13 +5647,13 @@
             </a:avLst>
           </a:prstGeom>
           <a:solidFill>
-            <a:srgbClr val="B3261E">
+            <a:srgbClr val="E07B00">
               <a:alpha val="10000"/>
             </a:srgbClr>
           </a:solidFill>
           <a:ln w="12700">
             <a:solidFill>
-              <a:srgbClr val="B3261E"/>
+              <a:srgbClr val="E07B00"/>
             </a:solidFill>
           </a:ln>
         </p:spPr>
@@ -5199,7 +5692,7 @@
             <a:r>
               <a:rPr lang="it-IT" sz="1150" b="1" dirty="0">
                 <a:solidFill>
-                  <a:srgbClr val="B3261E"/>
+                  <a:srgbClr val="E07B00"/>
                 </a:solidFill>
                 <a:latin typeface="Arial"/>
               </a:rPr>
@@ -5241,7 +5734,7 @@
                 </a:solidFill>
                 <a:latin typeface="Arial"/>
               </a:rPr>
-              <a:t>never finishes at 977 blocks</a:t>
+              <a:t>clustering 27 min  ·  then 5.1 s</a:t>
             </a:r>
           </a:p>
         </p:txBody>
@@ -5279,7 +5772,7 @@
                 </a:solidFill>
                 <a:latin typeface="Arial"/>
               </a:rPr>
-              <a:t>each round rereads 276 M rows</a:t>
+              <a:t>each round rereads every edge from disk</a:t>
             </a:r>
             <a:r>
               <a:rPr lang="it-IT" sz="1100" b="0" dirty="0">
@@ -5288,7 +5781,7 @@
                 </a:solidFill>
                 <a:latin typeface="Arial"/>
               </a:rPr>
-              <a:t>  from disk</a:t>
+              <a:t>  ·  ≈ 5 h at 977 blocks, projected</a:t>
             </a:r>
           </a:p>
         </p:txBody>
@@ -5350,7 +5843,7 @@
                 </a:solidFill>
                 <a:latin typeface="Arial"/>
               </a:rPr>
-              <a:t>load gap ≈ 4x at every size</a:t>
+              <a:t>load gap 4.6-5.1x at every size</a:t>
             </a:r>
           </a:p>
         </p:txBody>
@@ -6447,7 +6940,7 @@
                 </a:solidFill>
                 <a:latin typeface="Arial"/>
               </a:rPr>
-              <a:t>Neo4j up to 3.7x  ·  SQLite up to 8.4x</a:t>
+              <a:t>Neo4j up to 2.5x  ·  SQLite up to 8.4x</a:t>
             </a:r>
           </a:p>
         </p:txBody>
@@ -6800,7 +7293,7 @@
                 </a:solidFill>
                 <a:latin typeface="Arial"/>
               </a:rPr>
-              <a:t>SQLite = 1 file, 9 min to load</a:t>
+              <a:t>SQLite = 1 file, 5.5 min to load</a:t>
             </a:r>
           </a:p>
           <a:p>
@@ -6816,7 +7309,7 @@
                 </a:solidFill>
                 <a:latin typeface="Arial"/>
               </a:rPr>
-              <a:t>Neo4j = server, 8 GB heap, 40 min</a:t>
+              <a:t>Neo4j = server, 8 GB heap, 26 min</a:t>
             </a:r>
           </a:p>
         </p:txBody>
@@ -7895,7 +8388,7 @@
                 </a:solidFill>
                 <a:latin typeface="Arial"/>
               </a:rPr>
-              <a:t>   of the same data   ·   loads in 2 s instead of 40 min</a:t>
+              <a:t>   of the same data   ·   loads in 2 s instead of 26 min</a:t>
             </a:r>
           </a:p>
         </p:txBody>
@@ -17512,7 +18005,7 @@
                 </a:solidFill>
                 <a:latin typeface="Arial"/>
               </a:rPr>
-              <a:t>61.5 s</a:t>
+              <a:t>56.0 s</a:t>
             </a:r>
           </a:p>
         </p:txBody>
@@ -17550,7 +18043,7 @@
                 </a:solidFill>
                 <a:latin typeface="Arial"/>
               </a:rPr>
-              <a:t>24.6 s</a:t>
+              <a:t>22.3 s</a:t>
             </a:r>
           </a:p>
         </p:txBody>
@@ -17702,7 +18195,7 @@
                 </a:solidFill>
                 <a:latin typeface="Arial"/>
               </a:rPr>
-              <a:t>12.5 s</a:t>
+              <a:t>12.3 s</a:t>
             </a:r>
           </a:p>
         </p:txBody>
@@ -17740,7 +18233,7 @@
                 </a:solidFill>
                 <a:latin typeface="Arial"/>
               </a:rPr>
-              <a:t>9.4 s</a:t>
+              <a:t>6.6 s</a:t>
             </a:r>
           </a:p>
         </p:txBody>
@@ -17778,7 +18271,7 @@
                 </a:solidFill>
                 <a:latin typeface="Arial"/>
               </a:rPr>
-              <a:t>Neo4j 1.3x</a:t>
+              <a:t>Neo4j 1.9x</a:t>
             </a:r>
           </a:p>
         </p:txBody>
@@ -17919,7 +18412,7 @@
                 </a:solidFill>
                 <a:latin typeface="Arial"/>
               </a:rPr>
-              <a:t>40.3 s</a:t>
+              <a:t>25.9 s</a:t>
             </a:r>
           </a:p>
         </p:txBody>
@@ -17957,7 +18450,7 @@
                 </a:solidFill>
                 <a:latin typeface="Arial"/>
               </a:rPr>
-              <a:t>10.8 s</a:t>
+              <a:t>19.1 s</a:t>
             </a:r>
           </a:p>
         </p:txBody>
@@ -17995,7 +18488,7 @@
                 </a:solidFill>
                 <a:latin typeface="Arial"/>
               </a:rPr>
-              <a:t>Neo4j 3.7x</a:t>
+              <a:t>Neo4j 1.4x</a:t>
             </a:r>
           </a:p>
         </p:txBody>
@@ -18109,7 +18602,7 @@
                 </a:solidFill>
                 <a:latin typeface="Arial"/>
               </a:rPr>
-              <a:t>9.7 s</a:t>
+              <a:t>8.9 s</a:t>
             </a:r>
           </a:p>
         </p:txBody>
@@ -18147,7 +18640,7 @@
                 </a:solidFill>
                 <a:latin typeface="Arial"/>
               </a:rPr>
-              <a:t>13.8 s</a:t>
+              <a:t>10.0 s</a:t>
             </a:r>
           </a:p>
         </p:txBody>
@@ -18185,7 +18678,7 @@
                 </a:solidFill>
                 <a:latin typeface="Arial"/>
               </a:rPr>
-              <a:t>SQLite 1.4x</a:t>
+              <a:t>SQLite 1.1x</a:t>
             </a:r>
           </a:p>
         </p:txBody>
@@ -18326,7 +18819,7 @@
                 </a:solidFill>
                 <a:latin typeface="Arial"/>
               </a:rPr>
-              <a:t>9.6 s</a:t>
+              <a:t>9.0 s</a:t>
             </a:r>
           </a:p>
         </p:txBody>
@@ -18364,7 +18857,7 @@
                 </a:solidFill>
                 <a:latin typeface="Arial"/>
               </a:rPr>
-              <a:t>9.0 s</a:t>
+              <a:t>8.2 s</a:t>
             </a:r>
           </a:p>
         </p:txBody>
@@ -18516,7 +19009,7 @@
                 </a:solidFill>
                 <a:latin typeface="Arial"/>
               </a:rPr>
-              <a:t>2.1 ms</a:t>
+              <a:t>1.8 ms</a:t>
             </a:r>
           </a:p>
         </p:txBody>
@@ -18554,7 +19047,7 @@
                 </a:solidFill>
                 <a:latin typeface="Arial"/>
               </a:rPr>
-              <a:t>17.7 ms</a:t>
+              <a:t>15.6 ms</a:t>
             </a:r>
           </a:p>
         </p:txBody>
@@ -18729,11 +19222,20 @@
             <a:r>
               <a:rPr lang="it-IT" sz="1250" b="0" dirty="0">
                 <a:solidFill>
+                  <a:srgbClr val="1F1F1F"/>
+                </a:solidFill>
+                <a:latin typeface="Arial"/>
+              </a:rPr>
+              <a:t>5.1 s</a:t>
+            </a:r>
+            <a:r>
+              <a:rPr lang="it-IT" sz="800" b="0" dirty="0">
+                <a:solidFill>
                   <a:srgbClr val="B3261E"/>
                 </a:solidFill>
                 <a:latin typeface="Arial"/>
               </a:rPr>
-              <a:t>not available</a:t>
+              <a:t>*</a:t>
             </a:r>
           </a:p>
         </p:txBody>
@@ -18771,7 +19273,16 @@
                 </a:solidFill>
                 <a:latin typeface="Arial"/>
               </a:rPr>
-              <a:t>12.3 s</a:t>
+              <a:t>1.9 s</a:t>
+            </a:r>
+            <a:r>
+              <a:rPr lang="it-IT" sz="800" b="0" dirty="0">
+                <a:solidFill>
+                  <a:srgbClr val="B3261E"/>
+                </a:solidFill>
+                <a:latin typeface="Arial"/>
+              </a:rPr>
+              <a:t>*</a:t>
             </a:r>
           </a:p>
         </p:txBody>
@@ -18809,7 +19320,16 @@
                 </a:solidFill>
                 <a:latin typeface="Arial"/>
               </a:rPr>
-              <a:t>Neo4j only</a:t>
+              <a:t>Neo4j 2.7x</a:t>
+            </a:r>
+            <a:r>
+              <a:rPr lang="it-IT" sz="800" b="0" dirty="0">
+                <a:solidFill>
+                  <a:srgbClr val="B3261E"/>
+                </a:solidFill>
+                <a:latin typeface="Arial"/>
+              </a:rPr>
+              <a:t>*</a:t>
             </a:r>
           </a:p>
         </p:txBody>
@@ -18923,7 +19443,7 @@
                 </a:solidFill>
                 <a:latin typeface="Arial"/>
               </a:rPr>
-              <a:t>16.7 s</a:t>
+              <a:t>16.2 s</a:t>
             </a:r>
           </a:p>
         </p:txBody>
@@ -18961,7 +19481,7 @@
                 </a:solidFill>
                 <a:latin typeface="Arial"/>
               </a:rPr>
-              <a:t>12.4 s</a:t>
+              <a:t>29.1 s</a:t>
             </a:r>
           </a:p>
         </p:txBody>
@@ -18995,11 +19515,11 @@
             <a:r>
               <a:rPr lang="it-IT" sz="1150" b="1" dirty="0">
                 <a:solidFill>
-                  <a:srgbClr val="00838F"/>
-                </a:solidFill>
-                <a:latin typeface="Arial"/>
-              </a:rPr>
-              <a:t>Neo4j 1.3x</a:t>
+                  <a:srgbClr val="E07B00"/>
+                </a:solidFill>
+                <a:latin typeface="Arial"/>
+              </a:rPr>
+              <a:t>SQLite 1.8x</a:t>
             </a:r>
           </a:p>
         </p:txBody>
@@ -19012,7 +19532,7 @@
         </p:nvSpPr>
         <p:spPr>
           <a:xfrm>
-            <a:off x="1646000" y="5300000"/>
+            <a:off x="3246000" y="5300000"/>
             <a:ext cx="2000000" cy="460000"/>
           </a:xfrm>
           <a:prstGeom prst="roundRect">
@@ -19045,7 +19565,7 @@
         </p:nvSpPr>
         <p:spPr>
           <a:xfrm>
-            <a:off x="1646000" y="5380000"/>
+            <a:off x="3246000" y="5380000"/>
             <a:ext cx="2000000" cy="320000"/>
           </a:xfrm>
           <a:prstGeom prst="rect">
@@ -19070,7 +19590,7 @@
                 </a:solidFill>
                 <a:latin typeface="Arial"/>
               </a:rPr>
-              <a:t>Neo4j wins 5</a:t>
+              <a:t>Neo4j wins 4</a:t>
             </a:r>
           </a:p>
         </p:txBody>
@@ -19083,7 +19603,7 @@
         </p:nvSpPr>
         <p:spPr>
           <a:xfrm>
-            <a:off x="3846000" y="5300000"/>
+            <a:off x="5446000" y="5300000"/>
             <a:ext cx="2000000" cy="460000"/>
           </a:xfrm>
           <a:prstGeom prst="roundRect">
@@ -19116,7 +19636,7 @@
         </p:nvSpPr>
         <p:spPr>
           <a:xfrm>
-            <a:off x="3846000" y="5380000"/>
+            <a:off x="5446000" y="5380000"/>
             <a:ext cx="2000000" cy="320000"/>
           </a:xfrm>
           <a:prstGeom prst="rect">
@@ -19141,7 +19661,7 @@
                 </a:solidFill>
                 <a:latin typeface="Arial"/>
               </a:rPr>
-              <a:t>SQLite wins 2</a:t>
+              <a:t>SQLite wins 3</a:t>
             </a:r>
           </a:p>
         </p:txBody>
@@ -19154,7 +19674,7 @@
         </p:nvSpPr>
         <p:spPr>
           <a:xfrm>
-            <a:off x="6046000" y="5300000"/>
+            <a:off x="7646000" y="5300000"/>
             <a:ext cx="1300000" cy="460000"/>
           </a:xfrm>
           <a:prstGeom prst="roundRect">
@@ -19187,7 +19707,7 @@
         </p:nvSpPr>
         <p:spPr>
           <a:xfrm>
-            <a:off x="6046000" y="5380000"/>
+            <a:off x="7646000" y="5380000"/>
             <a:ext cx="1300000" cy="320000"/>
           </a:xfrm>
           <a:prstGeom prst="rect">
@@ -19219,47 +19739,14 @@
       </p:sp>
       <p:sp>
         <p:nvSpPr>
-          <p:cNvPr id="106" name="rc106"/>
-          <p:cNvSpPr/>
-          <p:nvPr/>
-        </p:nvSpPr>
-        <p:spPr>
-          <a:xfrm>
-            <a:off x="7546000" y="5300000"/>
-            <a:ext cx="3000000" cy="460000"/>
-          </a:xfrm>
-          <a:prstGeom prst="roundRect">
-            <a:avLst>
-              <a:gd name="adj" fmla="val 6000"/>
-            </a:avLst>
-          </a:prstGeom>
-          <a:solidFill>
-            <a:srgbClr val="B3261E">
-              <a:alpha val="14000"/>
-            </a:srgbClr>
-          </a:solidFill>
-          <a:ln w="12700">
-            <a:solidFill>
-              <a:srgbClr val="B3261E"/>
-            </a:solidFill>
-          </a:ln>
-        </p:spPr>
-        <p:txBody>
-          <a:bodyPr/>
-          <a:lstStyle/>
-          <a:p/>
-        </p:txBody>
-      </p:sp>
-      <p:sp>
-        <p:nvSpPr>
-          <p:cNvPr id="107" name="tb107"/>
+          <p:cNvPr id="110" name="tb110"/>
           <p:cNvSpPr txBox="1"/>
           <p:nvPr/>
         </p:nvSpPr>
         <p:spPr>
           <a:xfrm>
-            <a:off x="7546000" y="5380000"/>
-            <a:ext cx="3000000" cy="320000"/>
+            <a:off x="760000" y="5800000"/>
+            <a:ext cx="10672000" cy="240000"/>
           </a:xfrm>
           <a:prstGeom prst="rect">
             <a:avLst/>
@@ -19277,13 +19764,31 @@
               </a:lnSpc>
             </a:pPr>
             <a:r>
-              <a:rPr lang="it-IT" sz="1200" b="1" dirty="0">
+              <a:rPr lang="it-IT" sz="900" b="0" dirty="0">
+                <a:solidFill>
+                  <a:srgbClr val="8A8A8A"/>
+                </a:solidFill>
+                <a:latin typeface="Arial"/>
+              </a:rPr>
+              <a:t>times: scaling run at 977 blocks   </a:t>
+            </a:r>
+            <a:r>
+              <a:rPr lang="it-IT" sz="800" b="0" dirty="0">
                 <a:solidFill>
                   <a:srgbClr val="B3261E"/>
                 </a:solidFill>
                 <a:latin typeface="Arial"/>
               </a:rPr>
-              <a:t>only Neo4j answers Q7</a:t>
+              <a:t>*</a:t>
+            </a:r>
+            <a:r>
+              <a:rPr lang="it-IT" sz="900" b="0" dirty="0">
+                <a:solidFill>
+                  <a:srgbClr val="8A8A8A"/>
+                </a:solidFill>
+                <a:latin typeface="Arial"/>
+              </a:rPr>
+              <a:t> Q7 at 200 blocks: its clustering was measured only at 50 and 200</a:t>
             </a:r>
           </a:p>
         </p:txBody>
@@ -19358,13 +19863,13 @@
                     </p:cTn>
                   </p:par>
                   <p:par>
-                    <p:cTn id="315" fill="hold">
+                    <p:cTn id="310" fill="hold">
                       <p:stCondLst>
                         <p:cond delay="indefinite"/>
                       </p:stCondLst>
                       <p:childTnLst>
                         <p:par>
-                          <p:cTn id="316" fill="hold">
+                          <p:cTn id="311" fill="hold">
                             <p:stCondLst>
                               <p:cond delay="0"/>
                             </p:stCondLst>
@@ -21273,7 +21778,7 @@
                                           </p:stCondLst>
                                         </p:cTn>
                                         <p:tgtEl>
-                                          <p:spTgt spid="106"/>
+                                          <p:spTgt spid="110"/>
                                         </p:tgtEl>
                                         <p:attrNameLst>
                                           <p:attrName>style.visibility</p:attrName>
@@ -21287,42 +21792,7 @@
                                       <p:cBhvr>
                                         <p:cTn id="309" dur="400"/>
                                         <p:tgtEl>
-                                          <p:spTgt spid="106"/>
-                                        </p:tgtEl>
-                                      </p:cBhvr>
-                                    </p:animEffect>
-                                  </p:childTnLst>
-                                </p:cTn>
-                              </p:par>
-                              <p:par>
-                                <p:cTn id="312" presetID="10" presetClass="entr" presetSubtype="0" fill="hold" nodeType="withEffect">
-                                  <p:stCondLst>
-                                    <p:cond delay="0"/>
-                                  </p:stCondLst>
-                                  <p:childTnLst>
-                                    <p:set>
-                                      <p:cBhvr>
-                                        <p:cTn id="313" dur="1" fill="hold">
-                                          <p:stCondLst>
-                                            <p:cond delay="0"/>
-                                          </p:stCondLst>
-                                        </p:cTn>
-                                        <p:tgtEl>
-                                          <p:spTgt spid="107"/>
-                                        </p:tgtEl>
-                                        <p:attrNameLst>
-                                          <p:attrName>style.visibility</p:attrName>
-                                        </p:attrNameLst>
-                                      </p:cBhvr>
-                                      <p:to>
-                                        <p:strVal val="visible"/>
-                                      </p:to>
-                                    </p:set>
-                                    <p:animEffect transition="in" filter="fade">
-                                      <p:cBhvr>
-                                        <p:cTn id="314" dur="400"/>
-                                        <p:tgtEl>
-                                          <p:spTgt spid="107"/>
+                                          <p:spTgt spid="110"/>
                                         </p:tgtEl>
                                       </p:cBhvr>
                                     </p:animEffect>
@@ -24740,7 +25210,7 @@
         <p:spPr>
           <a:xfrm>
             <a:off x="760000" y="1650000"/>
-            <a:ext cx="10672000" cy="590000"/>
+            <a:ext cx="10672000" cy="650000"/>
           </a:xfrm>
           <a:prstGeom prst="rect">
             <a:avLst/>
@@ -24769,7 +25239,7 @@
         <p:spPr>
           <a:xfrm>
             <a:off x="760000" y="1650000"/>
-            <a:ext cx="50000" cy="590000"/>
+            <a:ext cx="50000" cy="650000"/>
           </a:xfrm>
           <a:prstGeom prst="rect">
             <a:avLst/>
@@ -24795,7 +25265,7 @@
         </p:nvSpPr>
         <p:spPr>
           <a:xfrm>
-            <a:off x="880000" y="1735000"/>
+            <a:off x="880000" y="1765000"/>
             <a:ext cx="3100000" cy="440000"/>
           </a:xfrm>
           <a:prstGeom prst="rect">
@@ -24820,7 +25290,7 @@
                 </a:solidFill>
                 <a:latin typeface="Arial"/>
               </a:rPr>
-              <a:t>Q3</a:t>
+              <a:t>Q1</a:t>
             </a:r>
           </a:p>
           <a:p>
@@ -24836,7 +25306,7 @@
                 </a:solidFill>
                 <a:latin typeface="Arial"/>
               </a:rPr>
-              <a:t>How much does each address hold?</a:t>
+              <a:t>How much fee did each transaction pay?</a:t>
             </a:r>
           </a:p>
         </p:txBody>
@@ -24849,7 +25319,7 @@
         </p:nvSpPr>
         <p:spPr>
           <a:xfrm>
-            <a:off x="3860000" y="1705000"/>
+            <a:off x="3860000" y="1735000"/>
             <a:ext cx="1150000" cy="440000"/>
           </a:xfrm>
           <a:prstGeom prst="rect">
@@ -24874,7 +25344,7 @@
                 </a:solidFill>
                 <a:latin typeface="Arial"/>
               </a:rPr>
-              <a:t>3.7x</a:t>
+              <a:t>2.5x</a:t>
             </a:r>
           </a:p>
         </p:txBody>
@@ -24887,7 +25357,7 @@
         </p:nvSpPr>
         <p:spPr>
           <a:xfrm>
-            <a:off x="5130000" y="1735000"/>
+            <a:off x="5130000" y="1765000"/>
             <a:ext cx="3050000" cy="440000"/>
           </a:xfrm>
           <a:prstGeom prst="rect">
@@ -24912,7 +25382,7 @@
                 </a:solidFill>
                 <a:latin typeface="Arial"/>
               </a:rPr>
-              <a:t>2 GROUP BY + 1 JOIN</a:t>
+              <a:t>JOIN on 2 columns</a:t>
             </a:r>
             <a:r>
               <a:rPr lang="it-IT" sz="1100" b="0" dirty="0">
@@ -24921,7 +25391,7 @@
                 </a:solidFill>
                 <a:latin typeface="Arial"/>
               </a:rPr>
-              <a:t> over millions of rows</a:t>
+              <a:t> to find each input's value</a:t>
             </a:r>
           </a:p>
         </p:txBody>
@@ -24934,7 +25404,7 @@
         </p:nvSpPr>
         <p:spPr>
           <a:xfrm>
-            <a:off x="8330000" y="1735000"/>
+            <a:off x="8330000" y="1765000"/>
             <a:ext cx="3072000" cy="440000"/>
           </a:xfrm>
           <a:prstGeom prst="rect">
@@ -24959,7 +25429,7 @@
                 </a:solidFill>
                 <a:latin typeface="Arial"/>
               </a:rPr>
-              <a:t>1 pass</a:t>
+              <a:t>follows SPENDS</a:t>
             </a:r>
             <a:r>
               <a:rPr lang="it-IT" sz="1100" b="0" dirty="0">
@@ -24968,7 +25438,7 @@
                 </a:solidFill>
                 <a:latin typeface="Arial"/>
               </a:rPr>
-              <a:t>, checks SPENDS on each output</a:t>
+              <a:t> to the output</a:t>
             </a:r>
           </a:p>
         </p:txBody>
@@ -24981,8 +25451,8 @@
         </p:nvSpPr>
         <p:spPr>
           <a:xfrm>
-            <a:off x="760000" y="2310000"/>
-            <a:ext cx="10672000" cy="590000"/>
+            <a:off x="760000" y="2370000"/>
+            <a:ext cx="10672000" cy="650000"/>
           </a:xfrm>
           <a:prstGeom prst="rect">
             <a:avLst/>
@@ -25010,8 +25480,8 @@
         </p:nvSpPr>
         <p:spPr>
           <a:xfrm>
-            <a:off x="760000" y="2310000"/>
-            <a:ext cx="50000" cy="590000"/>
+            <a:off x="760000" y="2370000"/>
+            <a:ext cx="50000" cy="650000"/>
           </a:xfrm>
           <a:prstGeom prst="rect">
             <a:avLst/>
@@ -25037,7 +25507,7 @@
         </p:nvSpPr>
         <p:spPr>
           <a:xfrm>
-            <a:off x="880000" y="2395000"/>
+            <a:off x="880000" y="2485000"/>
             <a:ext cx="3100000" cy="440000"/>
           </a:xfrm>
           <a:prstGeom prst="rect">
@@ -25062,7 +25532,7 @@
                 </a:solidFill>
                 <a:latin typeface="Arial"/>
               </a:rPr>
-              <a:t>Q1</a:t>
+              <a:t>Q2</a:t>
             </a:r>
           </a:p>
           <a:p>
@@ -25078,7 +25548,7 @@
                 </a:solidFill>
                 <a:latin typeface="Arial"/>
               </a:rPr>
-              <a:t>How much fee did each transaction pay?</a:t>
+              <a:t>Which outputs are still unspent?</a:t>
             </a:r>
           </a:p>
         </p:txBody>
@@ -25091,7 +25561,7 @@
         </p:nvSpPr>
         <p:spPr>
           <a:xfrm>
-            <a:off x="3860000" y="2365000"/>
+            <a:off x="3860000" y="2455000"/>
             <a:ext cx="1150000" cy="440000"/>
           </a:xfrm>
           <a:prstGeom prst="rect">
@@ -25116,7 +25586,7 @@
                 </a:solidFill>
                 <a:latin typeface="Arial"/>
               </a:rPr>
-              <a:t>2.5x</a:t>
+              <a:t>1.9x</a:t>
             </a:r>
           </a:p>
         </p:txBody>
@@ -25129,7 +25599,7 @@
         </p:nvSpPr>
         <p:spPr>
           <a:xfrm>
-            <a:off x="5130000" y="2395000"/>
+            <a:off x="5130000" y="2485000"/>
             <a:ext cx="3050000" cy="440000"/>
           </a:xfrm>
           <a:prstGeom prst="rect">
@@ -25154,7 +25624,7 @@
                 </a:solidFill>
                 <a:latin typeface="Arial"/>
               </a:rPr>
-              <a:t>JOIN on 2 columns</a:t>
+              <a:t>looks for an input row</a:t>
             </a:r>
             <a:r>
               <a:rPr lang="it-IT" sz="1100" b="0" dirty="0">
@@ -25163,7 +25633,7 @@
                 </a:solidFill>
                 <a:latin typeface="Arial"/>
               </a:rPr>
-              <a:t> to find each input's value</a:t>
+              <a:t> that is not there</a:t>
             </a:r>
           </a:p>
         </p:txBody>
@@ -25176,7 +25646,7 @@
         </p:nvSpPr>
         <p:spPr>
           <a:xfrm>
-            <a:off x="8330000" y="2395000"/>
+            <a:off x="8330000" y="2485000"/>
             <a:ext cx="3072000" cy="440000"/>
           </a:xfrm>
           <a:prstGeom prst="rect">
@@ -25201,7 +25671,7 @@
                 </a:solidFill>
                 <a:latin typeface="Arial"/>
               </a:rPr>
-              <a:t>follows SPENDS</a:t>
+              <a:t>checks that no SPENDS</a:t>
             </a:r>
             <a:r>
               <a:rPr lang="it-IT" sz="1100" b="0" dirty="0">
@@ -25210,7 +25680,7 @@
                 </a:solidFill>
                 <a:latin typeface="Arial"/>
               </a:rPr>
-              <a:t> to the output</a:t>
+              <a:t> edge arrives</a:t>
             </a:r>
           </a:p>
         </p:txBody>
@@ -25223,8 +25693,8 @@
         </p:nvSpPr>
         <p:spPr>
           <a:xfrm>
-            <a:off x="760000" y="2970000"/>
-            <a:ext cx="10672000" cy="590000"/>
+            <a:off x="760000" y="3090000"/>
+            <a:ext cx="10672000" cy="650000"/>
           </a:xfrm>
           <a:prstGeom prst="rect">
             <a:avLst/>
@@ -25252,8 +25722,8 @@
         </p:nvSpPr>
         <p:spPr>
           <a:xfrm>
-            <a:off x="760000" y="2970000"/>
-            <a:ext cx="50000" cy="590000"/>
+            <a:off x="760000" y="3090000"/>
+            <a:ext cx="50000" cy="650000"/>
           </a:xfrm>
           <a:prstGeom prst="rect">
             <a:avLst/>
@@ -25279,7 +25749,7 @@
         </p:nvSpPr>
         <p:spPr>
           <a:xfrm>
-            <a:off x="880000" y="3055000"/>
+            <a:off x="880000" y="3205000"/>
             <a:ext cx="3100000" cy="440000"/>
           </a:xfrm>
           <a:prstGeom prst="rect">
@@ -25304,7 +25774,7 @@
                 </a:solidFill>
                 <a:latin typeface="Arial"/>
               </a:rPr>
-              <a:t>Q2</a:t>
+              <a:t>Q3</a:t>
             </a:r>
           </a:p>
           <a:p>
@@ -25320,7 +25790,7 @@
                 </a:solidFill>
                 <a:latin typeface="Arial"/>
               </a:rPr>
-              <a:t>Which outputs are still unspent?</a:t>
+              <a:t>How much does each address hold?</a:t>
             </a:r>
           </a:p>
         </p:txBody>
@@ -25333,7 +25803,7 @@
         </p:nvSpPr>
         <p:spPr>
           <a:xfrm>
-            <a:off x="3860000" y="3025000"/>
+            <a:off x="3860000" y="3175000"/>
             <a:ext cx="1150000" cy="440000"/>
           </a:xfrm>
           <a:prstGeom prst="rect">
@@ -25358,7 +25828,7 @@
                 </a:solidFill>
                 <a:latin typeface="Arial"/>
               </a:rPr>
-              <a:t>1.3x</a:t>
+              <a:t>1.4x</a:t>
             </a:r>
           </a:p>
         </p:txBody>
@@ -25371,7 +25841,7 @@
         </p:nvSpPr>
         <p:spPr>
           <a:xfrm>
-            <a:off x="5130000" y="3055000"/>
+            <a:off x="5130000" y="3205000"/>
             <a:ext cx="3050000" cy="440000"/>
           </a:xfrm>
           <a:prstGeom prst="rect">
@@ -25396,7 +25866,7 @@
                 </a:solidFill>
                 <a:latin typeface="Arial"/>
               </a:rPr>
-              <a:t>looks for an input row</a:t>
+              <a:t>NOT EXISTS on 2 columns</a:t>
             </a:r>
             <a:r>
               <a:rPr lang="it-IT" sz="1100" b="0" dirty="0">
@@ -25405,7 +25875,7 @@
                 </a:solidFill>
                 <a:latin typeface="Arial"/>
               </a:rPr>
-              <a:t> that is not there</a:t>
+              <a:t> for every output, then GROUP BY</a:t>
             </a:r>
           </a:p>
         </p:txBody>
@@ -25418,7 +25888,7 @@
         </p:nvSpPr>
         <p:spPr>
           <a:xfrm>
-            <a:off x="8330000" y="3055000"/>
+            <a:off x="8330000" y="3205000"/>
             <a:ext cx="3072000" cy="440000"/>
           </a:xfrm>
           <a:prstGeom prst="rect">
@@ -25443,7 +25913,7 @@
                 </a:solidFill>
                 <a:latin typeface="Arial"/>
               </a:rPr>
-              <a:t>checks that no SPENDS</a:t>
+              <a:t>no SPENDS edge</a:t>
             </a:r>
             <a:r>
               <a:rPr lang="it-IT" sz="1100" b="0" dirty="0">
@@ -25452,7 +25922,7 @@
                 </a:solidFill>
                 <a:latin typeface="Arial"/>
               </a:rPr>
-              <a:t> edge arrives</a:t>
+              <a:t> on each output of the address</a:t>
             </a:r>
           </a:p>
         </p:txBody>
@@ -25465,8 +25935,8 @@
         </p:nvSpPr>
         <p:spPr>
           <a:xfrm>
-            <a:off x="760000" y="3630000"/>
-            <a:ext cx="10672000" cy="590000"/>
+            <a:off x="760000" y="3810000"/>
+            <a:ext cx="10672000" cy="650000"/>
           </a:xfrm>
           <a:prstGeom prst="rect">
             <a:avLst/>
@@ -25494,8 +25964,8 @@
         </p:nvSpPr>
         <p:spPr>
           <a:xfrm>
-            <a:off x="760000" y="3630000"/>
-            <a:ext cx="50000" cy="590000"/>
+            <a:off x="760000" y="3810000"/>
+            <a:ext cx="50000" cy="650000"/>
           </a:xfrm>
           <a:prstGeom prst="rect">
             <a:avLst/>
@@ -25521,7 +25991,7 @@
         </p:nvSpPr>
         <p:spPr>
           <a:xfrm>
-            <a:off x="880000" y="3715000"/>
+            <a:off x="880000" y="3925000"/>
             <a:ext cx="3100000" cy="440000"/>
           </a:xfrm>
           <a:prstGeom prst="rect">
@@ -25546,7 +26016,7 @@
                 </a:solidFill>
                 <a:latin typeface="Arial"/>
               </a:rPr>
-              <a:t>Q8</a:t>
+              <a:t>Q7</a:t>
             </a:r>
           </a:p>
           <a:p>
@@ -25562,7 +26032,7 @@
                 </a:solidFill>
                 <a:latin typeface="Arial"/>
               </a:rPr>
-              <a:t>What is each transaction worth in USD?</a:t>
+              <a:t>How much does each wallet hold?</a:t>
             </a:r>
           </a:p>
         </p:txBody>
@@ -25575,7 +26045,7 @@
         </p:nvSpPr>
         <p:spPr>
           <a:xfrm>
-            <a:off x="3860000" y="3685000"/>
+            <a:off x="3860000" y="3895000"/>
             <a:ext cx="1150000" cy="440000"/>
           </a:xfrm>
           <a:prstGeom prst="rect">
@@ -25600,7 +26070,16 @@
                 </a:solidFill>
                 <a:latin typeface="Arial"/>
               </a:rPr>
-              <a:t>1.3x</a:t>
+              <a:t>2.7x</a:t>
+            </a:r>
+            <a:r>
+              <a:rPr lang="it-IT" sz="800" b="0" dirty="0">
+                <a:solidFill>
+                  <a:srgbClr val="B3261E"/>
+                </a:solidFill>
+                <a:latin typeface="Arial"/>
+              </a:rPr>
+              <a:t>*</a:t>
             </a:r>
           </a:p>
         </p:txBody>
@@ -25613,7 +26092,7 @@
         </p:nvSpPr>
         <p:spPr>
           <a:xfrm>
-            <a:off x="5130000" y="3715000"/>
+            <a:off x="5130000" y="3925000"/>
             <a:ext cx="3050000" cy="440000"/>
           </a:xfrm>
           <a:prstGeom prst="rect">
@@ -25638,7 +26117,7 @@
                 </a:solidFill>
                 <a:latin typeface="Arial"/>
               </a:rPr>
-              <a:t>price lookup</a:t>
+              <a:t>clustering 27 min</a:t>
             </a:r>
             <a:r>
               <a:rPr lang="it-IT" sz="1100" b="0" dirty="0">
@@ -25647,7 +26126,7 @@
                 </a:solidFill>
                 <a:latin typeface="Arial"/>
               </a:rPr>
-              <a:t> per transaction</a:t>
+              <a:t>, then 5.1 s</a:t>
             </a:r>
           </a:p>
         </p:txBody>
@@ -25660,7 +26139,7 @@
         </p:nvSpPr>
         <p:spPr>
           <a:xfrm>
-            <a:off x="8330000" y="3715000"/>
+            <a:off x="8330000" y="3925000"/>
             <a:ext cx="3072000" cy="440000"/>
           </a:xfrm>
           <a:prstGeom prst="rect">
@@ -25685,7 +26164,7 @@
                 </a:solidFill>
                 <a:latin typeface="Arial"/>
               </a:rPr>
-              <a:t>same lookup</a:t>
+              <a:t>clustering 7 min</a:t>
             </a:r>
             <a:r>
               <a:rPr lang="it-IT" sz="1100" b="0" dirty="0">
@@ -25694,240 +26173,7 @@
                 </a:solidFill>
                 <a:latin typeface="Arial"/>
               </a:rPr>
-              <a:t>, prices have no edges</a:t>
-            </a:r>
-          </a:p>
-        </p:txBody>
-      </p:sp>
-      <p:sp>
-        <p:nvSpPr>
-          <p:cNvPr id="38" name="sr38"/>
-          <p:cNvSpPr/>
-          <p:nvPr/>
-        </p:nvSpPr>
-        <p:spPr>
-          <a:xfrm>
-            <a:off x="760000" y="4290000"/>
-            <a:ext cx="10672000" cy="590000"/>
-          </a:xfrm>
-          <a:prstGeom prst="rect">
-            <a:avLst/>
-          </a:prstGeom>
-          <a:solidFill>
-            <a:srgbClr val="F3F6F8"/>
-          </a:solidFill>
-          <a:ln w="9525">
-            <a:solidFill>
-              <a:srgbClr val="D5DCE2"/>
-            </a:solidFill>
-          </a:ln>
-        </p:spPr>
-        <p:txBody>
-          <a:bodyPr/>
-          <a:lstStyle/>
-          <a:p/>
-        </p:txBody>
-      </p:sp>
-      <p:sp>
-        <p:nvSpPr>
-          <p:cNvPr id="39" name="sr39"/>
-          <p:cNvSpPr/>
-          <p:nvPr/>
-        </p:nvSpPr>
-        <p:spPr>
-          <a:xfrm>
-            <a:off x="760000" y="4290000"/>
-            <a:ext cx="50000" cy="590000"/>
-          </a:xfrm>
-          <a:prstGeom prst="rect">
-            <a:avLst/>
-          </a:prstGeom>
-          <a:solidFill>
-            <a:srgbClr val="00838F"/>
-          </a:solidFill>
-          <a:ln>
-            <a:noFill/>
-          </a:ln>
-        </p:spPr>
-        <p:txBody>
-          <a:bodyPr/>
-          <a:lstStyle/>
-          <a:p/>
-        </p:txBody>
-      </p:sp>
-      <p:sp>
-        <p:nvSpPr>
-          <p:cNvPr id="40" name="tb40"/>
-          <p:cNvSpPr txBox="1"/>
-          <p:nvPr/>
-        </p:nvSpPr>
-        <p:spPr>
-          <a:xfrm>
-            <a:off x="880000" y="4375000"/>
-            <a:ext cx="3100000" cy="440000"/>
-          </a:xfrm>
-          <a:prstGeom prst="rect">
-            <a:avLst/>
-          </a:prstGeom>
-        </p:spPr>
-        <p:txBody>
-          <a:bodyPr wrap="square" rtlCol="0" anchor="t">
-            <a:normAutofit/>
-          </a:bodyPr>
-          <a:lstStyle/>
-          <a:p>
-            <a:pPr algn="l">
-              <a:lnSpc>
-                <a:spcPct val="100000"/>
-              </a:lnSpc>
-            </a:pPr>
-            <a:r>
-              <a:rPr lang="it-IT" sz="1150" b="1" dirty="0">
-                <a:solidFill>
-                  <a:srgbClr val="00838F"/>
-                </a:solidFill>
-                <a:latin typeface="Arial"/>
-              </a:rPr>
-              <a:t>Q7</a:t>
-            </a:r>
-          </a:p>
-          <a:p>
-            <a:pPr algn="l">
-              <a:lnSpc>
-                <a:spcPct val="100000"/>
-              </a:lnSpc>
-            </a:pPr>
-            <a:r>
-              <a:rPr lang="it-IT" sz="1150" b="0" dirty="0">
-                <a:solidFill>
-                  <a:srgbClr val="4A4A4A"/>
-                </a:solidFill>
-                <a:latin typeface="Arial"/>
-              </a:rPr>
-              <a:t>How much does each wallet hold?</a:t>
-            </a:r>
-          </a:p>
-        </p:txBody>
-      </p:sp>
-      <p:sp>
-        <p:nvSpPr>
-          <p:cNvPr id="41" name="tb41"/>
-          <p:cNvSpPr txBox="1"/>
-          <p:nvPr/>
-        </p:nvSpPr>
-        <p:spPr>
-          <a:xfrm>
-            <a:off x="3860000" y="4375000"/>
-            <a:ext cx="1150000" cy="440000"/>
-          </a:xfrm>
-          <a:prstGeom prst="rect">
-            <a:avLst/>
-          </a:prstGeom>
-        </p:spPr>
-        <p:txBody>
-          <a:bodyPr wrap="square" rtlCol="0" anchor="t">
-            <a:normAutofit/>
-          </a:bodyPr>
-          <a:lstStyle/>
-          <a:p>
-            <a:pPr algn="ctr">
-              <a:lnSpc>
-                <a:spcPct val="100000"/>
-              </a:lnSpc>
-            </a:pPr>
-            <a:r>
-              <a:rPr lang="it-IT" sz="1250" b="1" dirty="0">
-                <a:solidFill>
-                  <a:srgbClr val="00838F"/>
-                </a:solidFill>
-                <a:latin typeface="Arial"/>
-              </a:rPr>
-              <a:t>only Neo4j</a:t>
-            </a:r>
-          </a:p>
-        </p:txBody>
-      </p:sp>
-      <p:sp>
-        <p:nvSpPr>
-          <p:cNvPr id="42" name="tb42"/>
-          <p:cNvSpPr txBox="1"/>
-          <p:nvPr/>
-        </p:nvSpPr>
-        <p:spPr>
-          <a:xfrm>
-            <a:off x="5130000" y="4375000"/>
-            <a:ext cx="3050000" cy="440000"/>
-          </a:xfrm>
-          <a:prstGeom prst="rect">
-            <a:avLst/>
-          </a:prstGeom>
-        </p:spPr>
-        <p:txBody>
-          <a:bodyPr wrap="square" rtlCol="0" anchor="t">
-            <a:normAutofit/>
-          </a:bodyPr>
-          <a:lstStyle/>
-          <a:p>
-            <a:pPr algn="l">
-              <a:lnSpc>
-                <a:spcPct val="100000"/>
-              </a:lnSpc>
-            </a:pPr>
-            <a:r>
-              <a:rPr lang="it-IT" sz="1100" b="1" dirty="0">
-                <a:solidFill>
-                  <a:srgbClr val="1F1F1F"/>
-                </a:solidFill>
-                <a:latin typeface="Arial"/>
-              </a:rPr>
-              <a:t>clustering never finishes</a:t>
-            </a:r>
-          </a:p>
-        </p:txBody>
-      </p:sp>
-      <p:sp>
-        <p:nvSpPr>
-          <p:cNvPr id="43" name="tb43"/>
-          <p:cNvSpPr txBox="1"/>
-          <p:nvPr/>
-        </p:nvSpPr>
-        <p:spPr>
-          <a:xfrm>
-            <a:off x="8330000" y="4375000"/>
-            <a:ext cx="3072000" cy="440000"/>
-          </a:xfrm>
-          <a:prstGeom prst="rect">
-            <a:avLst/>
-          </a:prstGeom>
-        </p:spPr>
-        <p:txBody>
-          <a:bodyPr wrap="square" rtlCol="0" anchor="t">
-            <a:normAutofit/>
-          </a:bodyPr>
-          <a:lstStyle/>
-          <a:p>
-            <a:pPr algn="l">
-              <a:lnSpc>
-                <a:spcPct val="100000"/>
-              </a:lnSpc>
-            </a:pPr>
-            <a:r>
-              <a:rPr lang="it-IT" sz="1100" b="1" dirty="0">
-                <a:solidFill>
-                  <a:srgbClr val="1F1F1F"/>
-                </a:solidFill>
-                <a:latin typeface="Arial"/>
-              </a:rPr>
-              <a:t>84 min once</a:t>
-            </a:r>
-            <a:r>
-              <a:rPr lang="it-IT" sz="1100" b="0" dirty="0">
-                <a:solidFill>
-                  <a:srgbClr val="4A4A4A"/>
-                </a:solidFill>
-                <a:latin typeface="Arial"/>
-              </a:rPr>
-              <a:t>, then 12.3 s</a:t>
+              <a:t>, then 1.9 s</a:t>
             </a:r>
           </a:p>
         </p:txBody>
@@ -25940,7 +26186,7 @@
         </p:nvSpPr>
         <p:spPr>
           <a:xfrm>
-            <a:off x="760000" y="5100000"/>
+            <a:off x="760000" y="4750000"/>
             <a:ext cx="10672000" cy="500000"/>
           </a:xfrm>
           <a:prstGeom prst="rect">
@@ -27505,7 +27751,7 @@
                                           </p:stCondLst>
                                         </p:cTn>
                                         <p:tgtEl>
-                                          <p:spTgt spid="38"/>
+                                          <p:spTgt spid="60"/>
                                         </p:tgtEl>
                                         <p:attrNameLst>
                                           <p:attrName>style.visibility</p:attrName>
@@ -27518,324 +27764,6 @@
                                     <p:animEffect transition="in" filter="fade">
                                       <p:cBhvr>
                                         <p:cTn id="444" dur="400"/>
-                                        <p:tgtEl>
-                                          <p:spTgt spid="38"/>
-                                        </p:tgtEl>
-                                      </p:cBhvr>
-                                    </p:animEffect>
-                                  </p:childTnLst>
-                                </p:cTn>
-                              </p:par>
-                            </p:childTnLst>
-                          </p:cTn>
-                        </p:par>
-                      </p:childTnLst>
-                    </p:cTn>
-                  </p:par>
-                  <p:par>
-                    <p:cTn id="460" fill="hold">
-                      <p:stCondLst>
-                        <p:cond delay="indefinite"/>
-                      </p:stCondLst>
-                      <p:childTnLst>
-                        <p:par>
-                          <p:cTn id="461" fill="hold">
-                            <p:stCondLst>
-                              <p:cond delay="0"/>
-                            </p:stCondLst>
-                            <p:childTnLst>
-                              <p:par>
-                                <p:cTn id="457" presetID="10" presetClass="entr" presetSubtype="0" fill="hold" nodeType="clickEffect">
-                                  <p:stCondLst>
-                                    <p:cond delay="0"/>
-                                  </p:stCondLst>
-                                  <p:childTnLst>
-                                    <p:set>
-                                      <p:cBhvr>
-                                        <p:cTn id="458" dur="1" fill="hold">
-                                          <p:stCondLst>
-                                            <p:cond delay="0"/>
-                                          </p:stCondLst>
-                                        </p:cTn>
-                                        <p:tgtEl>
-                                          <p:spTgt spid="39"/>
-                                        </p:tgtEl>
-                                        <p:attrNameLst>
-                                          <p:attrName>style.visibility</p:attrName>
-                                        </p:attrNameLst>
-                                      </p:cBhvr>
-                                      <p:to>
-                                        <p:strVal val="visible"/>
-                                      </p:to>
-                                    </p:set>
-                                    <p:animEffect transition="in" filter="fade">
-                                      <p:cBhvr>
-                                        <p:cTn id="459" dur="400"/>
-                                        <p:tgtEl>
-                                          <p:spTgt spid="39"/>
-                                        </p:tgtEl>
-                                      </p:cBhvr>
-                                    </p:animEffect>
-                                  </p:childTnLst>
-                                </p:cTn>
-                              </p:par>
-                            </p:childTnLst>
-                          </p:cTn>
-                        </p:par>
-                      </p:childTnLst>
-                    </p:cTn>
-                  </p:par>
-                  <p:par>
-                    <p:cTn id="475" fill="hold">
-                      <p:stCondLst>
-                        <p:cond delay="indefinite"/>
-                      </p:stCondLst>
-                      <p:childTnLst>
-                        <p:par>
-                          <p:cTn id="476" fill="hold">
-                            <p:stCondLst>
-                              <p:cond delay="0"/>
-                            </p:stCondLst>
-                            <p:childTnLst>
-                              <p:par>
-                                <p:cTn id="472" presetID="10" presetClass="entr" presetSubtype="0" fill="hold" nodeType="clickEffect">
-                                  <p:stCondLst>
-                                    <p:cond delay="0"/>
-                                  </p:stCondLst>
-                                  <p:childTnLst>
-                                    <p:set>
-                                      <p:cBhvr>
-                                        <p:cTn id="473" dur="1" fill="hold">
-                                          <p:stCondLst>
-                                            <p:cond delay="0"/>
-                                          </p:stCondLst>
-                                        </p:cTn>
-                                        <p:tgtEl>
-                                          <p:spTgt spid="40"/>
-                                        </p:tgtEl>
-                                        <p:attrNameLst>
-                                          <p:attrName>style.visibility</p:attrName>
-                                        </p:attrNameLst>
-                                      </p:cBhvr>
-                                      <p:to>
-                                        <p:strVal val="visible"/>
-                                      </p:to>
-                                    </p:set>
-                                    <p:animEffect transition="in" filter="fade">
-                                      <p:cBhvr>
-                                        <p:cTn id="474" dur="400"/>
-                                        <p:tgtEl>
-                                          <p:spTgt spid="40"/>
-                                        </p:tgtEl>
-                                      </p:cBhvr>
-                                    </p:animEffect>
-                                  </p:childTnLst>
-                                </p:cTn>
-                              </p:par>
-                            </p:childTnLst>
-                          </p:cTn>
-                        </p:par>
-                      </p:childTnLst>
-                    </p:cTn>
-                  </p:par>
-                  <p:par>
-                    <p:cTn id="490" fill="hold">
-                      <p:stCondLst>
-                        <p:cond delay="indefinite"/>
-                      </p:stCondLst>
-                      <p:childTnLst>
-                        <p:par>
-                          <p:cTn id="491" fill="hold">
-                            <p:stCondLst>
-                              <p:cond delay="0"/>
-                            </p:stCondLst>
-                            <p:childTnLst>
-                              <p:par>
-                                <p:cTn id="487" presetID="10" presetClass="entr" presetSubtype="0" fill="hold" nodeType="clickEffect">
-                                  <p:stCondLst>
-                                    <p:cond delay="0"/>
-                                  </p:stCondLst>
-                                  <p:childTnLst>
-                                    <p:set>
-                                      <p:cBhvr>
-                                        <p:cTn id="488" dur="1" fill="hold">
-                                          <p:stCondLst>
-                                            <p:cond delay="0"/>
-                                          </p:stCondLst>
-                                        </p:cTn>
-                                        <p:tgtEl>
-                                          <p:spTgt spid="41"/>
-                                        </p:tgtEl>
-                                        <p:attrNameLst>
-                                          <p:attrName>style.visibility</p:attrName>
-                                        </p:attrNameLst>
-                                      </p:cBhvr>
-                                      <p:to>
-                                        <p:strVal val="visible"/>
-                                      </p:to>
-                                    </p:set>
-                                    <p:animEffect transition="in" filter="fade">
-                                      <p:cBhvr>
-                                        <p:cTn id="489" dur="400"/>
-                                        <p:tgtEl>
-                                          <p:spTgt spid="41"/>
-                                        </p:tgtEl>
-                                      </p:cBhvr>
-                                    </p:animEffect>
-                                  </p:childTnLst>
-                                </p:cTn>
-                              </p:par>
-                            </p:childTnLst>
-                          </p:cTn>
-                        </p:par>
-                      </p:childTnLst>
-                    </p:cTn>
-                  </p:par>
-                  <p:par>
-                    <p:cTn id="505" fill="hold">
-                      <p:stCondLst>
-                        <p:cond delay="indefinite"/>
-                      </p:stCondLst>
-                      <p:childTnLst>
-                        <p:par>
-                          <p:cTn id="506" fill="hold">
-                            <p:stCondLst>
-                              <p:cond delay="0"/>
-                            </p:stCondLst>
-                            <p:childTnLst>
-                              <p:par>
-                                <p:cTn id="502" presetID="10" presetClass="entr" presetSubtype="0" fill="hold" nodeType="clickEffect">
-                                  <p:stCondLst>
-                                    <p:cond delay="0"/>
-                                  </p:stCondLst>
-                                  <p:childTnLst>
-                                    <p:set>
-                                      <p:cBhvr>
-                                        <p:cTn id="503" dur="1" fill="hold">
-                                          <p:stCondLst>
-                                            <p:cond delay="0"/>
-                                          </p:stCondLst>
-                                        </p:cTn>
-                                        <p:tgtEl>
-                                          <p:spTgt spid="42"/>
-                                        </p:tgtEl>
-                                        <p:attrNameLst>
-                                          <p:attrName>style.visibility</p:attrName>
-                                        </p:attrNameLst>
-                                      </p:cBhvr>
-                                      <p:to>
-                                        <p:strVal val="visible"/>
-                                      </p:to>
-                                    </p:set>
-                                    <p:animEffect transition="in" filter="fade">
-                                      <p:cBhvr>
-                                        <p:cTn id="504" dur="400"/>
-                                        <p:tgtEl>
-                                          <p:spTgt spid="42"/>
-                                        </p:tgtEl>
-                                      </p:cBhvr>
-                                    </p:animEffect>
-                                  </p:childTnLst>
-                                </p:cTn>
-                              </p:par>
-                            </p:childTnLst>
-                          </p:cTn>
-                        </p:par>
-                      </p:childTnLst>
-                    </p:cTn>
-                  </p:par>
-                  <p:par>
-                    <p:cTn id="520" fill="hold">
-                      <p:stCondLst>
-                        <p:cond delay="indefinite"/>
-                      </p:stCondLst>
-                      <p:childTnLst>
-                        <p:par>
-                          <p:cTn id="521" fill="hold">
-                            <p:stCondLst>
-                              <p:cond delay="0"/>
-                            </p:stCondLst>
-                            <p:childTnLst>
-                              <p:par>
-                                <p:cTn id="517" presetID="10" presetClass="entr" presetSubtype="0" fill="hold" nodeType="clickEffect">
-                                  <p:stCondLst>
-                                    <p:cond delay="0"/>
-                                  </p:stCondLst>
-                                  <p:childTnLst>
-                                    <p:set>
-                                      <p:cBhvr>
-                                        <p:cTn id="518" dur="1" fill="hold">
-                                          <p:stCondLst>
-                                            <p:cond delay="0"/>
-                                          </p:stCondLst>
-                                        </p:cTn>
-                                        <p:tgtEl>
-                                          <p:spTgt spid="43"/>
-                                        </p:tgtEl>
-                                        <p:attrNameLst>
-                                          <p:attrName>style.visibility</p:attrName>
-                                        </p:attrNameLst>
-                                      </p:cBhvr>
-                                      <p:to>
-                                        <p:strVal val="visible"/>
-                                      </p:to>
-                                    </p:set>
-                                    <p:animEffect transition="in" filter="fade">
-                                      <p:cBhvr>
-                                        <p:cTn id="519" dur="400"/>
-                                        <p:tgtEl>
-                                          <p:spTgt spid="43"/>
-                                        </p:tgtEl>
-                                      </p:cBhvr>
-                                    </p:animEffect>
-                                  </p:childTnLst>
-                                </p:cTn>
-                              </p:par>
-                            </p:childTnLst>
-                          </p:cTn>
-                        </p:par>
-                      </p:childTnLst>
-                    </p:cTn>
-                  </p:par>
-                  <p:par>
-                    <p:cTn id="535" fill="hold">
-                      <p:stCondLst>
-                        <p:cond delay="indefinite"/>
-                      </p:stCondLst>
-                      <p:childTnLst>
-                        <p:par>
-                          <p:cTn id="536" fill="hold">
-                            <p:stCondLst>
-                              <p:cond delay="0"/>
-                            </p:stCondLst>
-                            <p:childTnLst>
-                              <p:par>
-                                <p:cTn id="532" presetID="10" presetClass="entr" presetSubtype="0" fill="hold" nodeType="clickEffect">
-                                  <p:stCondLst>
-                                    <p:cond delay="0"/>
-                                  </p:stCondLst>
-                                  <p:childTnLst>
-                                    <p:set>
-                                      <p:cBhvr>
-                                        <p:cTn id="533" dur="1" fill="hold">
-                                          <p:stCondLst>
-                                            <p:cond delay="0"/>
-                                          </p:stCondLst>
-                                        </p:cTn>
-                                        <p:tgtEl>
-                                          <p:spTgt spid="60"/>
-                                        </p:tgtEl>
-                                        <p:attrNameLst>
-                                          <p:attrName>style.visibility</p:attrName>
-                                        </p:attrNameLst>
-                                      </p:cBhvr>
-                                      <p:to>
-                                        <p:strVal val="visible"/>
-                                      </p:to>
-                                    </p:set>
-                                    <p:animEffect transition="in" filter="fade">
-                                      <p:cBhvr>
-                                        <p:cTn id="534" dur="400"/>
                                         <p:tgtEl>
                                           <p:spTgt spid="60"/>
                                         </p:tgtEl>
@@ -28267,7 +28195,7 @@
         <p:spPr>
           <a:xfrm>
             <a:off x="760000" y="1650000"/>
-            <a:ext cx="10672000" cy="880000"/>
+            <a:ext cx="10672000" cy="650000"/>
           </a:xfrm>
           <a:prstGeom prst="rect">
             <a:avLst/>
@@ -28296,7 +28224,7 @@
         <p:spPr>
           <a:xfrm>
             <a:off x="760000" y="1650000"/>
-            <a:ext cx="50000" cy="880000"/>
+            <a:ext cx="50000" cy="650000"/>
           </a:xfrm>
           <a:prstGeom prst="rect">
             <a:avLst/>
@@ -28322,7 +28250,7 @@
         </p:nvSpPr>
         <p:spPr>
           <a:xfrm>
-            <a:off x="880000" y="1880000"/>
+            <a:off x="880000" y="1765000"/>
             <a:ext cx="3100000" cy="440000"/>
           </a:xfrm>
           <a:prstGeom prst="rect">
@@ -28376,7 +28304,7 @@
         </p:nvSpPr>
         <p:spPr>
           <a:xfrm>
-            <a:off x="3860000" y="1850000"/>
+            <a:off x="3860000" y="1735000"/>
             <a:ext cx="1150000" cy="440000"/>
           </a:xfrm>
           <a:prstGeom prst="rect">
@@ -28414,7 +28342,7 @@
         </p:nvSpPr>
         <p:spPr>
           <a:xfrm>
-            <a:off x="5130000" y="1880000"/>
+            <a:off x="5130000" y="1765000"/>
             <a:ext cx="3050000" cy="440000"/>
           </a:xfrm>
           <a:prstGeom prst="rect">
@@ -28448,7 +28376,7 @@
                 </a:solidFill>
                 <a:latin typeface="Arial"/>
               </a:rPr>
-              <a:t> of one table, no join</a:t>
+              <a:t> of one table, follows prev_hash by key</a:t>
             </a:r>
           </a:p>
         </p:txBody>
@@ -28461,7 +28389,7 @@
         </p:nvSpPr>
         <p:spPr>
           <a:xfrm>
-            <a:off x="8330000" y="1880000"/>
+            <a:off x="8330000" y="1765000"/>
             <a:ext cx="3072000" cy="440000"/>
           </a:xfrm>
           <a:prstGeom prst="rect">
@@ -28508,8 +28436,8 @@
         </p:nvSpPr>
         <p:spPr>
           <a:xfrm>
-            <a:off x="760000" y="2600000"/>
-            <a:ext cx="10672000" cy="880000"/>
+            <a:off x="760000" y="2370000"/>
+            <a:ext cx="10672000" cy="650000"/>
           </a:xfrm>
           <a:prstGeom prst="rect">
             <a:avLst/>
@@ -28537,8 +28465,8 @@
         </p:nvSpPr>
         <p:spPr>
           <a:xfrm>
-            <a:off x="760000" y="2600000"/>
-            <a:ext cx="50000" cy="880000"/>
+            <a:off x="760000" y="2370000"/>
+            <a:ext cx="50000" cy="650000"/>
           </a:xfrm>
           <a:prstGeom prst="rect">
             <a:avLst/>
@@ -28564,7 +28492,7 @@
         </p:nvSpPr>
         <p:spPr>
           <a:xfrm>
-            <a:off x="880000" y="2830000"/>
+            <a:off x="880000" y="2485000"/>
             <a:ext cx="3100000" cy="440000"/>
           </a:xfrm>
           <a:prstGeom prst="rect">
@@ -28589,7 +28517,7 @@
                 </a:solidFill>
                 <a:latin typeface="Arial"/>
               </a:rPr>
-              <a:t>Q4</a:t>
+              <a:t>Q8</a:t>
             </a:r>
           </a:p>
           <a:p>
@@ -28605,7 +28533,7 @@
                 </a:solidFill>
                 <a:latin typeface="Arial"/>
               </a:rPr>
-              <a:t>Where did one address's money go?</a:t>
+              <a:t>What is each transaction worth in USD?</a:t>
             </a:r>
           </a:p>
         </p:txBody>
@@ -28618,7 +28546,7 @@
         </p:nvSpPr>
         <p:spPr>
           <a:xfrm>
-            <a:off x="3860000" y="2800000"/>
+            <a:off x="3860000" y="2455000"/>
             <a:ext cx="1150000" cy="440000"/>
           </a:xfrm>
           <a:prstGeom prst="rect">
@@ -28643,7 +28571,7 @@
                 </a:solidFill>
                 <a:latin typeface="Arial"/>
               </a:rPr>
-              <a:t>1.4x</a:t>
+              <a:t>1.8x</a:t>
             </a:r>
           </a:p>
         </p:txBody>
@@ -28656,7 +28584,7 @@
         </p:nvSpPr>
         <p:spPr>
           <a:xfrm>
-            <a:off x="5130000" y="2830000"/>
+            <a:off x="5130000" y="2485000"/>
             <a:ext cx="3050000" cy="440000"/>
           </a:xfrm>
           <a:prstGeom prst="rect">
@@ -28681,7 +28609,7 @@
                 </a:solidFill>
                 <a:latin typeface="Arial"/>
               </a:rPr>
-              <a:t>recursive CTE</a:t>
+              <a:t>MAX on the price key</a:t>
             </a:r>
             <a:r>
               <a:rPr lang="it-IT" sz="1100" b="0" dirty="0">
@@ -28690,7 +28618,7 @@
                 </a:solidFill>
                 <a:latin typeface="Arial"/>
               </a:rPr>
-              <a:t>, follows the spent outputs · 9.7 s</a:t>
+              <a:t>, one index lookup per transaction</a:t>
             </a:r>
           </a:p>
         </p:txBody>
@@ -28703,7 +28631,7 @@
         </p:nvSpPr>
         <p:spPr>
           <a:xfrm>
-            <a:off x="8330000" y="2830000"/>
+            <a:off x="8330000" y="2485000"/>
             <a:ext cx="3072000" cy="440000"/>
           </a:xfrm>
           <a:prstGeom prst="rect">
@@ -28728,7 +28656,7 @@
                 </a:solidFill>
                 <a:latin typeface="Arial"/>
               </a:rPr>
-              <a:t>the same walk</a:t>
+              <a:t>no edge to follow</a:t>
             </a:r>
             <a:r>
               <a:rPr lang="it-IT" sz="1100" b="0" dirty="0">
@@ -28737,7 +28665,7 @@
                 </a:solidFill>
                 <a:latin typeface="Arial"/>
               </a:rPr>
-              <a:t>, output by output · 13.8 s</a:t>
+              <a:t>: the same MAX, then a lookup</a:t>
             </a:r>
           </a:p>
         </p:txBody>
@@ -28750,8 +28678,8 @@
         </p:nvSpPr>
         <p:spPr>
           <a:xfrm>
-            <a:off x="760000" y="3550000"/>
-            <a:ext cx="10672000" cy="880000"/>
+            <a:off x="760000" y="3090000"/>
+            <a:ext cx="10672000" cy="650000"/>
           </a:xfrm>
           <a:prstGeom prst="rect">
             <a:avLst/>
@@ -28779,8 +28707,250 @@
         </p:nvSpPr>
         <p:spPr>
           <a:xfrm>
-            <a:off x="760000" y="3550000"/>
-            <a:ext cx="50000" cy="880000"/>
+            <a:off x="760000" y="3090000"/>
+            <a:ext cx="50000" cy="650000"/>
+          </a:xfrm>
+          <a:prstGeom prst="rect">
+            <a:avLst/>
+          </a:prstGeom>
+          <a:solidFill>
+            <a:srgbClr val="E07B00"/>
+          </a:solidFill>
+          <a:ln>
+            <a:noFill/>
+          </a:ln>
+        </p:spPr>
+        <p:txBody>
+          <a:bodyPr/>
+          <a:lstStyle/>
+          <a:p/>
+        </p:txBody>
+      </p:sp>
+      <p:sp>
+        <p:nvSpPr>
+          <p:cNvPr id="28" name="tb28"/>
+          <p:cNvSpPr txBox="1"/>
+          <p:nvPr/>
+        </p:nvSpPr>
+        <p:spPr>
+          <a:xfrm>
+            <a:off x="880000" y="3205000"/>
+            <a:ext cx="3100000" cy="440000"/>
+          </a:xfrm>
+          <a:prstGeom prst="rect">
+            <a:avLst/>
+          </a:prstGeom>
+        </p:spPr>
+        <p:txBody>
+          <a:bodyPr wrap="square" rtlCol="0" anchor="t">
+            <a:normAutofit/>
+          </a:bodyPr>
+          <a:lstStyle/>
+          <a:p>
+            <a:pPr algn="l">
+              <a:lnSpc>
+                <a:spcPct val="100000"/>
+              </a:lnSpc>
+            </a:pPr>
+            <a:r>
+              <a:rPr lang="it-IT" sz="1150" b="1" dirty="0">
+                <a:solidFill>
+                  <a:srgbClr val="E07B00"/>
+                </a:solidFill>
+                <a:latin typeface="Arial"/>
+              </a:rPr>
+              <a:t>Q4</a:t>
+            </a:r>
+          </a:p>
+          <a:p>
+            <a:pPr algn="l">
+              <a:lnSpc>
+                <a:spcPct val="100000"/>
+              </a:lnSpc>
+            </a:pPr>
+            <a:r>
+              <a:rPr lang="it-IT" sz="1150" b="0" dirty="0">
+                <a:solidFill>
+                  <a:srgbClr val="4A4A4A"/>
+                </a:solidFill>
+                <a:latin typeface="Arial"/>
+              </a:rPr>
+              <a:t>Where did one address's money go?</a:t>
+            </a:r>
+          </a:p>
+        </p:txBody>
+      </p:sp>
+      <p:sp>
+        <p:nvSpPr>
+          <p:cNvPr id="29" name="tb29"/>
+          <p:cNvSpPr txBox="1"/>
+          <p:nvPr/>
+        </p:nvSpPr>
+        <p:spPr>
+          <a:xfrm>
+            <a:off x="3860000" y="3175000"/>
+            <a:ext cx="1150000" cy="440000"/>
+          </a:xfrm>
+          <a:prstGeom prst="rect">
+            <a:avLst/>
+          </a:prstGeom>
+        </p:spPr>
+        <p:txBody>
+          <a:bodyPr wrap="square" rtlCol="0" anchor="t">
+            <a:normAutofit/>
+          </a:bodyPr>
+          <a:lstStyle/>
+          <a:p>
+            <a:pPr algn="ctr">
+              <a:lnSpc>
+                <a:spcPct val="100000"/>
+              </a:lnSpc>
+            </a:pPr>
+            <a:r>
+              <a:rPr lang="it-IT" sz="2000" b="1" dirty="0">
+                <a:solidFill>
+                  <a:srgbClr val="E07B00"/>
+                </a:solidFill>
+                <a:latin typeface="Arial"/>
+              </a:rPr>
+              <a:t>1.1x</a:t>
+            </a:r>
+          </a:p>
+        </p:txBody>
+      </p:sp>
+      <p:sp>
+        <p:nvSpPr>
+          <p:cNvPr id="30" name="tb30"/>
+          <p:cNvSpPr txBox="1"/>
+          <p:nvPr/>
+        </p:nvSpPr>
+        <p:spPr>
+          <a:xfrm>
+            <a:off x="5130000" y="3205000"/>
+            <a:ext cx="3050000" cy="440000"/>
+          </a:xfrm>
+          <a:prstGeom prst="rect">
+            <a:avLst/>
+          </a:prstGeom>
+        </p:spPr>
+        <p:txBody>
+          <a:bodyPr wrap="square" rtlCol="0" anchor="t">
+            <a:normAutofit/>
+          </a:bodyPr>
+          <a:lstStyle/>
+          <a:p>
+            <a:pPr algn="l">
+              <a:lnSpc>
+                <a:spcPct val="100000"/>
+              </a:lnSpc>
+            </a:pPr>
+            <a:r>
+              <a:rPr lang="it-IT" sz="1100" b="1" dirty="0">
+                <a:solidFill>
+                  <a:srgbClr val="1F1F1F"/>
+                </a:solidFill>
+                <a:latin typeface="Arial"/>
+              </a:rPr>
+              <a:t>recursive CTE</a:t>
+            </a:r>
+            <a:r>
+              <a:rPr lang="it-IT" sz="1100" b="0" dirty="0">
+                <a:solidFill>
+                  <a:srgbClr val="4A4A4A"/>
+                </a:solidFill>
+                <a:latin typeface="Arial"/>
+              </a:rPr>
+              <a:t>, follows the spent outputs · 8.9 s</a:t>
+            </a:r>
+          </a:p>
+        </p:txBody>
+      </p:sp>
+      <p:sp>
+        <p:nvSpPr>
+          <p:cNvPr id="31" name="tb31"/>
+          <p:cNvSpPr txBox="1"/>
+          <p:nvPr/>
+        </p:nvSpPr>
+        <p:spPr>
+          <a:xfrm>
+            <a:off x="8330000" y="3205000"/>
+            <a:ext cx="3072000" cy="440000"/>
+          </a:xfrm>
+          <a:prstGeom prst="rect">
+            <a:avLst/>
+          </a:prstGeom>
+        </p:spPr>
+        <p:txBody>
+          <a:bodyPr wrap="square" rtlCol="0" anchor="t">
+            <a:normAutofit/>
+          </a:bodyPr>
+          <a:lstStyle/>
+          <a:p>
+            <a:pPr algn="l">
+              <a:lnSpc>
+                <a:spcPct val="100000"/>
+              </a:lnSpc>
+            </a:pPr>
+            <a:r>
+              <a:rPr lang="it-IT" sz="1100" b="1" dirty="0">
+                <a:solidFill>
+                  <a:srgbClr val="1F1F1F"/>
+                </a:solidFill>
+                <a:latin typeface="Arial"/>
+              </a:rPr>
+              <a:t>the same walk</a:t>
+            </a:r>
+            <a:r>
+              <a:rPr lang="it-IT" sz="1100" b="0" dirty="0">
+                <a:solidFill>
+                  <a:srgbClr val="4A4A4A"/>
+                </a:solidFill>
+                <a:latin typeface="Arial"/>
+              </a:rPr>
+              <a:t>, output by output · 10 s</a:t>
+            </a:r>
+          </a:p>
+        </p:txBody>
+      </p:sp>
+      <p:sp>
+        <p:nvSpPr>
+          <p:cNvPr id="32" name="sr32"/>
+          <p:cNvSpPr/>
+          <p:nvPr/>
+        </p:nvSpPr>
+        <p:spPr>
+          <a:xfrm>
+            <a:off x="760000" y="3810000"/>
+            <a:ext cx="10672000" cy="650000"/>
+          </a:xfrm>
+          <a:prstGeom prst="rect">
+            <a:avLst/>
+          </a:prstGeom>
+          <a:solidFill>
+            <a:srgbClr val="F3F6F8"/>
+          </a:solidFill>
+          <a:ln w="9525">
+            <a:solidFill>
+              <a:srgbClr val="D5DCE2"/>
+            </a:solidFill>
+          </a:ln>
+        </p:spPr>
+        <p:txBody>
+          <a:bodyPr/>
+          <a:lstStyle/>
+          <a:p/>
+        </p:txBody>
+      </p:sp>
+      <p:sp>
+        <p:nvSpPr>
+          <p:cNvPr id="33" name="sr33"/>
+          <p:cNvSpPr/>
+          <p:nvPr/>
+        </p:nvSpPr>
+        <p:spPr>
+          <a:xfrm>
+            <a:off x="760000" y="3810000"/>
+            <a:ext cx="50000" cy="650000"/>
           </a:xfrm>
           <a:prstGeom prst="rect">
             <a:avLst/>
@@ -28800,13 +28970,13 @@
       </p:sp>
       <p:sp>
         <p:nvSpPr>
-          <p:cNvPr id="28" name="tb28"/>
+          <p:cNvPr id="34" name="tb34"/>
           <p:cNvSpPr txBox="1"/>
           <p:nvPr/>
         </p:nvSpPr>
         <p:spPr>
           <a:xfrm>
-            <a:off x="880000" y="3780000"/>
+            <a:off x="880000" y="3925000"/>
             <a:ext cx="3100000" cy="440000"/>
           </a:xfrm>
           <a:prstGeom prst="rect">
@@ -28854,13 +29024,13 @@
       </p:sp>
       <p:sp>
         <p:nvSpPr>
-          <p:cNvPr id="29" name="tb29"/>
+          <p:cNvPr id="35" name="tb35"/>
           <p:cNvSpPr txBox="1"/>
           <p:nvPr/>
         </p:nvSpPr>
         <p:spPr>
           <a:xfrm>
-            <a:off x="3860000" y="3750000"/>
+            <a:off x="3860000" y="3895000"/>
             <a:ext cx="1150000" cy="440000"/>
           </a:xfrm>
           <a:prstGeom prst="rect">
@@ -28892,13 +29062,13 @@
       </p:sp>
       <p:sp>
         <p:nvSpPr>
-          <p:cNvPr id="30" name="tb30"/>
+          <p:cNvPr id="36" name="tb36"/>
           <p:cNvSpPr txBox="1"/>
           <p:nvPr/>
         </p:nvSpPr>
         <p:spPr>
           <a:xfrm>
-            <a:off x="5130000" y="3780000"/>
+            <a:off x="5130000" y="3925000"/>
             <a:ext cx="3050000" cy="440000"/>
           </a:xfrm>
           <a:prstGeom prst="rect">
@@ -28930,13 +29100,13 @@
       </p:sp>
       <p:sp>
         <p:nvSpPr>
-          <p:cNvPr id="31" name="tb31"/>
+          <p:cNvPr id="37" name="tb37"/>
           <p:cNvSpPr txBox="1"/>
           <p:nvPr/>
         </p:nvSpPr>
         <p:spPr>
           <a:xfrm>
-            <a:off x="8330000" y="3780000"/>
+            <a:off x="8330000" y="3925000"/>
             <a:ext cx="3072000" cy="440000"/>
           </a:xfrm>
           <a:prstGeom prst="rect">
@@ -28974,7 +29144,7 @@
         </p:nvSpPr>
         <p:spPr>
           <a:xfrm>
-            <a:off x="760000" y="4700000"/>
+            <a:off x="760000" y="4750000"/>
             <a:ext cx="10672000" cy="500000"/>
           </a:xfrm>
           <a:prstGeom prst="rect">
@@ -28999,7 +29169,7 @@
                 </a:solidFill>
                 <a:latin typeface="Arial"/>
               </a:rPr>
-              <a:t>Local query  →  8.4x     same walk on both  →  1.4x     </a:t>
+              <a:t>Local query  →  8.4x     no edge to follow  →  1.8x     same walk  →  1.1x     </a:t>
             </a:r>
             <a:r>
               <a:rPr lang="it-IT" sz="1300" b="1" dirty="0">
@@ -30221,6 +30391,324 @@
                                           </p:stCondLst>
                                         </p:cTn>
                                         <p:tgtEl>
+                                          <p:spTgt spid="32"/>
+                                        </p:tgtEl>
+                                        <p:attrNameLst>
+                                          <p:attrName>style.visibility</p:attrName>
+                                        </p:attrNameLst>
+                                      </p:cBhvr>
+                                      <p:to>
+                                        <p:strVal val="visible"/>
+                                      </p:to>
+                                    </p:set>
+                                    <p:animEffect transition="in" filter="fade">
+                                      <p:cBhvr>
+                                        <p:cTn id="354" dur="400"/>
+                                        <p:tgtEl>
+                                          <p:spTgt spid="32"/>
+                                        </p:tgtEl>
+                                      </p:cBhvr>
+                                    </p:animEffect>
+                                  </p:childTnLst>
+                                </p:cTn>
+                              </p:par>
+                            </p:childTnLst>
+                          </p:cTn>
+                        </p:par>
+                      </p:childTnLst>
+                    </p:cTn>
+                  </p:par>
+                  <p:par>
+                    <p:cTn id="370" fill="hold">
+                      <p:stCondLst>
+                        <p:cond delay="indefinite"/>
+                      </p:stCondLst>
+                      <p:childTnLst>
+                        <p:par>
+                          <p:cTn id="371" fill="hold">
+                            <p:stCondLst>
+                              <p:cond delay="0"/>
+                            </p:stCondLst>
+                            <p:childTnLst>
+                              <p:par>
+                                <p:cTn id="367" presetID="10" presetClass="entr" presetSubtype="0" fill="hold" nodeType="clickEffect">
+                                  <p:stCondLst>
+                                    <p:cond delay="0"/>
+                                  </p:stCondLst>
+                                  <p:childTnLst>
+                                    <p:set>
+                                      <p:cBhvr>
+                                        <p:cTn id="368" dur="1" fill="hold">
+                                          <p:stCondLst>
+                                            <p:cond delay="0"/>
+                                          </p:stCondLst>
+                                        </p:cTn>
+                                        <p:tgtEl>
+                                          <p:spTgt spid="33"/>
+                                        </p:tgtEl>
+                                        <p:attrNameLst>
+                                          <p:attrName>style.visibility</p:attrName>
+                                        </p:attrNameLst>
+                                      </p:cBhvr>
+                                      <p:to>
+                                        <p:strVal val="visible"/>
+                                      </p:to>
+                                    </p:set>
+                                    <p:animEffect transition="in" filter="fade">
+                                      <p:cBhvr>
+                                        <p:cTn id="369" dur="400"/>
+                                        <p:tgtEl>
+                                          <p:spTgt spid="33"/>
+                                        </p:tgtEl>
+                                      </p:cBhvr>
+                                    </p:animEffect>
+                                  </p:childTnLst>
+                                </p:cTn>
+                              </p:par>
+                            </p:childTnLst>
+                          </p:cTn>
+                        </p:par>
+                      </p:childTnLst>
+                    </p:cTn>
+                  </p:par>
+                  <p:par>
+                    <p:cTn id="385" fill="hold">
+                      <p:stCondLst>
+                        <p:cond delay="indefinite"/>
+                      </p:stCondLst>
+                      <p:childTnLst>
+                        <p:par>
+                          <p:cTn id="386" fill="hold">
+                            <p:stCondLst>
+                              <p:cond delay="0"/>
+                            </p:stCondLst>
+                            <p:childTnLst>
+                              <p:par>
+                                <p:cTn id="382" presetID="10" presetClass="entr" presetSubtype="0" fill="hold" nodeType="clickEffect">
+                                  <p:stCondLst>
+                                    <p:cond delay="0"/>
+                                  </p:stCondLst>
+                                  <p:childTnLst>
+                                    <p:set>
+                                      <p:cBhvr>
+                                        <p:cTn id="383" dur="1" fill="hold">
+                                          <p:stCondLst>
+                                            <p:cond delay="0"/>
+                                          </p:stCondLst>
+                                        </p:cTn>
+                                        <p:tgtEl>
+                                          <p:spTgt spid="34"/>
+                                        </p:tgtEl>
+                                        <p:attrNameLst>
+                                          <p:attrName>style.visibility</p:attrName>
+                                        </p:attrNameLst>
+                                      </p:cBhvr>
+                                      <p:to>
+                                        <p:strVal val="visible"/>
+                                      </p:to>
+                                    </p:set>
+                                    <p:animEffect transition="in" filter="fade">
+                                      <p:cBhvr>
+                                        <p:cTn id="384" dur="400"/>
+                                        <p:tgtEl>
+                                          <p:spTgt spid="34"/>
+                                        </p:tgtEl>
+                                      </p:cBhvr>
+                                    </p:animEffect>
+                                  </p:childTnLst>
+                                </p:cTn>
+                              </p:par>
+                            </p:childTnLst>
+                          </p:cTn>
+                        </p:par>
+                      </p:childTnLst>
+                    </p:cTn>
+                  </p:par>
+                  <p:par>
+                    <p:cTn id="400" fill="hold">
+                      <p:stCondLst>
+                        <p:cond delay="indefinite"/>
+                      </p:stCondLst>
+                      <p:childTnLst>
+                        <p:par>
+                          <p:cTn id="401" fill="hold">
+                            <p:stCondLst>
+                              <p:cond delay="0"/>
+                            </p:stCondLst>
+                            <p:childTnLst>
+                              <p:par>
+                                <p:cTn id="397" presetID="10" presetClass="entr" presetSubtype="0" fill="hold" nodeType="clickEffect">
+                                  <p:stCondLst>
+                                    <p:cond delay="0"/>
+                                  </p:stCondLst>
+                                  <p:childTnLst>
+                                    <p:set>
+                                      <p:cBhvr>
+                                        <p:cTn id="398" dur="1" fill="hold">
+                                          <p:stCondLst>
+                                            <p:cond delay="0"/>
+                                          </p:stCondLst>
+                                        </p:cTn>
+                                        <p:tgtEl>
+                                          <p:spTgt spid="35"/>
+                                        </p:tgtEl>
+                                        <p:attrNameLst>
+                                          <p:attrName>style.visibility</p:attrName>
+                                        </p:attrNameLst>
+                                      </p:cBhvr>
+                                      <p:to>
+                                        <p:strVal val="visible"/>
+                                      </p:to>
+                                    </p:set>
+                                    <p:animEffect transition="in" filter="fade">
+                                      <p:cBhvr>
+                                        <p:cTn id="399" dur="400"/>
+                                        <p:tgtEl>
+                                          <p:spTgt spid="35"/>
+                                        </p:tgtEl>
+                                      </p:cBhvr>
+                                    </p:animEffect>
+                                  </p:childTnLst>
+                                </p:cTn>
+                              </p:par>
+                            </p:childTnLst>
+                          </p:cTn>
+                        </p:par>
+                      </p:childTnLst>
+                    </p:cTn>
+                  </p:par>
+                  <p:par>
+                    <p:cTn id="415" fill="hold">
+                      <p:stCondLst>
+                        <p:cond delay="indefinite"/>
+                      </p:stCondLst>
+                      <p:childTnLst>
+                        <p:par>
+                          <p:cTn id="416" fill="hold">
+                            <p:stCondLst>
+                              <p:cond delay="0"/>
+                            </p:stCondLst>
+                            <p:childTnLst>
+                              <p:par>
+                                <p:cTn id="412" presetID="10" presetClass="entr" presetSubtype="0" fill="hold" nodeType="clickEffect">
+                                  <p:stCondLst>
+                                    <p:cond delay="0"/>
+                                  </p:stCondLst>
+                                  <p:childTnLst>
+                                    <p:set>
+                                      <p:cBhvr>
+                                        <p:cTn id="413" dur="1" fill="hold">
+                                          <p:stCondLst>
+                                            <p:cond delay="0"/>
+                                          </p:stCondLst>
+                                        </p:cTn>
+                                        <p:tgtEl>
+                                          <p:spTgt spid="36"/>
+                                        </p:tgtEl>
+                                        <p:attrNameLst>
+                                          <p:attrName>style.visibility</p:attrName>
+                                        </p:attrNameLst>
+                                      </p:cBhvr>
+                                      <p:to>
+                                        <p:strVal val="visible"/>
+                                      </p:to>
+                                    </p:set>
+                                    <p:animEffect transition="in" filter="fade">
+                                      <p:cBhvr>
+                                        <p:cTn id="414" dur="400"/>
+                                        <p:tgtEl>
+                                          <p:spTgt spid="36"/>
+                                        </p:tgtEl>
+                                      </p:cBhvr>
+                                    </p:animEffect>
+                                  </p:childTnLst>
+                                </p:cTn>
+                              </p:par>
+                            </p:childTnLst>
+                          </p:cTn>
+                        </p:par>
+                      </p:childTnLst>
+                    </p:cTn>
+                  </p:par>
+                  <p:par>
+                    <p:cTn id="430" fill="hold">
+                      <p:stCondLst>
+                        <p:cond delay="indefinite"/>
+                      </p:stCondLst>
+                      <p:childTnLst>
+                        <p:par>
+                          <p:cTn id="431" fill="hold">
+                            <p:stCondLst>
+                              <p:cond delay="0"/>
+                            </p:stCondLst>
+                            <p:childTnLst>
+                              <p:par>
+                                <p:cTn id="427" presetID="10" presetClass="entr" presetSubtype="0" fill="hold" nodeType="clickEffect">
+                                  <p:stCondLst>
+                                    <p:cond delay="0"/>
+                                  </p:stCondLst>
+                                  <p:childTnLst>
+                                    <p:set>
+                                      <p:cBhvr>
+                                        <p:cTn id="428" dur="1" fill="hold">
+                                          <p:stCondLst>
+                                            <p:cond delay="0"/>
+                                          </p:stCondLst>
+                                        </p:cTn>
+                                        <p:tgtEl>
+                                          <p:spTgt spid="37"/>
+                                        </p:tgtEl>
+                                        <p:attrNameLst>
+                                          <p:attrName>style.visibility</p:attrName>
+                                        </p:attrNameLst>
+                                      </p:cBhvr>
+                                      <p:to>
+                                        <p:strVal val="visible"/>
+                                      </p:to>
+                                    </p:set>
+                                    <p:animEffect transition="in" filter="fade">
+                                      <p:cBhvr>
+                                        <p:cTn id="429" dur="400"/>
+                                        <p:tgtEl>
+                                          <p:spTgt spid="37"/>
+                                        </p:tgtEl>
+                                      </p:cBhvr>
+                                    </p:animEffect>
+                                  </p:childTnLst>
+                                </p:cTn>
+                              </p:par>
+                            </p:childTnLst>
+                          </p:cTn>
+                        </p:par>
+                      </p:childTnLst>
+                    </p:cTn>
+                  </p:par>
+                  <p:par>
+                    <p:cTn id="445" fill="hold">
+                      <p:stCondLst>
+                        <p:cond delay="indefinite"/>
+                      </p:stCondLst>
+                      <p:childTnLst>
+                        <p:par>
+                          <p:cTn id="446" fill="hold">
+                            <p:stCondLst>
+                              <p:cond delay="0"/>
+                            </p:stCondLst>
+                            <p:childTnLst>
+                              <p:par>
+                                <p:cTn id="442" presetID="10" presetClass="entr" presetSubtype="0" fill="hold" nodeType="clickEffect">
+                                  <p:stCondLst>
+                                    <p:cond delay="0"/>
+                                  </p:stCondLst>
+                                  <p:childTnLst>
+                                    <p:set>
+                                      <p:cBhvr>
+                                        <p:cTn id="443" dur="1" fill="hold">
+                                          <p:stCondLst>
+                                            <p:cond delay="0"/>
+                                          </p:stCondLst>
+                                        </p:cTn>
+                                        <p:tgtEl>
                                           <p:spTgt spid="60"/>
                                         </p:tgtEl>
                                         <p:attrNameLst>
@@ -30233,7 +30721,7 @@
                                     </p:set>
                                     <p:animEffect transition="in" filter="fade">
                                       <p:cBhvr>
-                                        <p:cTn id="354" dur="400"/>
+                                        <p:cTn id="444" dur="400"/>
                                         <p:tgtEl>
                                           <p:spTgt spid="60"/>
                                         </p:tgtEl>
@@ -30537,7 +31025,7 @@
                 </a:solidFill>
                 <a:latin typeface="Arial"/>
               </a:rPr>
-              <a:t>Q3   How much does each address hold?</a:t>
+              <a:t>Q1   How much fee did each transaction pay?</a:t>
             </a:r>
             <a:r>
               <a:rPr lang="it-IT" sz="1250" b="0" dirty="0">
@@ -30546,7 +31034,7 @@
                 </a:solidFill>
                 <a:latin typeface="Arial"/>
               </a:rPr>
-              <a:t>      Neo4j 3.7x faster</a:t>
+              <a:t>      Neo4j 2.5x faster</a:t>
             </a:r>
           </a:p>
         </p:txBody>
@@ -30593,7 +31081,7 @@
                 </a:solidFill>
                 <a:latin typeface="Arial"/>
               </a:rPr>
-              <a:t>22 lines  ·  2 subqueries  ·  2 joins</a:t>
+              <a:t>19 lines  ·  2 subqueries  ·  JOIN on 2 columns</a:t>
             </a:r>
           </a:p>
         </p:txBody>
@@ -30660,7 +31148,7 @@
                 </a:solidFill>
                 <a:latin typeface="Consolas"/>
               </a:rPr>
-              <a:t>WITH received AS (</a:t>
+              <a:t>WITH with_input AS MATERIALIZED (</a:t>
             </a:r>
           </a:p>
           <a:p>
@@ -30676,7 +31164,7 @@
                 </a:solidFill>
                 <a:latin typeface="Consolas"/>
               </a:rPr>
-              <a:t>  SELECT address, SUM(value) AS total_received</a:t>
+              <a:t>  SELECT tx.txid,</a:t>
             </a:r>
           </a:p>
           <a:p>
@@ -30692,7 +31180,7 @@
                 </a:solidFill>
                 <a:latin typeface="Consolas"/>
               </a:rPr>
-              <a:t>  FROM tx_outputs WHERE address IS NOT NULL</a:t>
+              <a:t>    (SELECT SUM(o.value) FROM tx_inputs i</a:t>
             </a:r>
           </a:p>
           <a:p>
@@ -30702,13 +31190,61 @@
               </a:lnSpc>
             </a:pPr>
             <a:r>
+              <a:rPr lang="it-IT" sz="820" b="1" dirty="0">
+                <a:solidFill>
+                  <a:srgbClr val="1F1F1F"/>
+                </a:solidFill>
+                <a:latin typeface="Consolas"/>
+              </a:rPr>
+              <a:t>     JOIN tx_outputs o</a:t>
+            </a:r>
+          </a:p>
+          <a:p>
+            <a:pPr algn="l">
+              <a:lnSpc>
+                <a:spcPct val="100000"/>
+              </a:lnSpc>
+            </a:pPr>
+            <a:r>
+              <a:rPr lang="it-IT" sz="820" b="1" dirty="0">
+                <a:solidFill>
+                  <a:srgbClr val="1F1F1F"/>
+                </a:solidFill>
+                <a:latin typeface="Consolas"/>
+              </a:rPr>
+              <a:t>       ON o.txid = i.prev_txid</a:t>
+            </a:r>
+          </a:p>
+          <a:p>
+            <a:pPr algn="l">
+              <a:lnSpc>
+                <a:spcPct val="100000"/>
+              </a:lnSpc>
+            </a:pPr>
+            <a:r>
+              <a:rPr lang="it-IT" sz="820" b="1" dirty="0">
+                <a:solidFill>
+                  <a:srgbClr val="1F1F1F"/>
+                </a:solidFill>
+                <a:latin typeface="Consolas"/>
+              </a:rPr>
+              <a:t>      AND o.output_index = i.prev_output_index</a:t>
+            </a:r>
+          </a:p>
+          <a:p>
+            <a:pPr algn="l">
+              <a:lnSpc>
+                <a:spcPct val="100000"/>
+              </a:lnSpc>
+            </a:pPr>
+            <a:r>
               <a:rPr lang="it-IT" sz="820" b="0" dirty="0">
                 <a:solidFill>
                   <a:srgbClr val="8A8A8A"/>
                 </a:solidFill>
                 <a:latin typeface="Consolas"/>
               </a:rPr>
-              <a:t>  GROUP BY address</a:t>
+              <a:t>     WHERE i.txid = tx.txid</a:t>
             </a:r>
           </a:p>
           <a:p>
@@ -30724,6 +31260,38 @@
                 </a:solidFill>
                 <a:latin typeface="Consolas"/>
               </a:rPr>
+              <a:t>       AND i.prev_output_index != 4294967295) AS total_input</a:t>
+            </a:r>
+          </a:p>
+          <a:p>
+            <a:pPr algn="l">
+              <a:lnSpc>
+                <a:spcPct val="100000"/>
+              </a:lnSpc>
+            </a:pPr>
+            <a:r>
+              <a:rPr lang="it-IT" sz="820" b="0" dirty="0">
+                <a:solidFill>
+                  <a:srgbClr val="8A8A8A"/>
+                </a:solidFill>
+                <a:latin typeface="Consolas"/>
+              </a:rPr>
+              <a:t>  FROM transactions tx</a:t>
+            </a:r>
+          </a:p>
+          <a:p>
+            <a:pPr algn="l">
+              <a:lnSpc>
+                <a:spcPct val="100000"/>
+              </a:lnSpc>
+            </a:pPr>
+            <a:r>
+              <a:rPr lang="it-IT" sz="820" b="0" dirty="0">
+                <a:solidFill>
+                  <a:srgbClr val="8A8A8A"/>
+                </a:solidFill>
+                <a:latin typeface="Consolas"/>
+              </a:rPr>
               <a:t>),</a:t>
             </a:r>
           </a:p>
@@ -30740,7 +31308,7 @@
                 </a:solidFill>
                 <a:latin typeface="Consolas"/>
               </a:rPr>
-              <a:t>spent AS (</a:t>
+              <a:t>amounts AS MATERIALIZED (</a:t>
             </a:r>
           </a:p>
           <a:p>
@@ -30756,7 +31324,7 @@
                 </a:solidFill>
                 <a:latin typeface="Consolas"/>
               </a:rPr>
-              <a:t>  SELECT o.address, SUM(o.value) AS total_spent</a:t>
+              <a:t>  SELECT w.txid, w.total_input,</a:t>
             </a:r>
           </a:p>
           <a:p>
@@ -30772,7 +31340,7 @@
                 </a:solidFill>
                 <a:latin typeface="Consolas"/>
               </a:rPr>
-              <a:t>  FROM tx_outputs o</a:t>
+              <a:t>    (SELECT SUM(value) FROM tx_outputs</a:t>
             </a:r>
           </a:p>
           <a:p>
@@ -30782,13 +31350,13 @@
               </a:lnSpc>
             </a:pPr>
             <a:r>
-              <a:rPr lang="it-IT" sz="820" b="1" dirty="0">
-                <a:solidFill>
-                  <a:srgbClr val="1F1F1F"/>
+              <a:rPr lang="it-IT" sz="820" b="0" dirty="0">
+                <a:solidFill>
+                  <a:srgbClr val="8A8A8A"/>
                 </a:solidFill>
                 <a:latin typeface="Consolas"/>
               </a:rPr>
-              <a:t>  JOIN tx_inputs i</a:t>
+              <a:t>     WHERE txid = w.txid) AS total_output</a:t>
             </a:r>
           </a:p>
           <a:p>
@@ -30798,13 +31366,13 @@
               </a:lnSpc>
             </a:pPr>
             <a:r>
-              <a:rPr lang="it-IT" sz="820" b="1" dirty="0">
-                <a:solidFill>
-                  <a:srgbClr val="1F1F1F"/>
+              <a:rPr lang="it-IT" sz="820" b="0" dirty="0">
+                <a:solidFill>
+                  <a:srgbClr val="8A8A8A"/>
                 </a:solidFill>
                 <a:latin typeface="Consolas"/>
               </a:rPr>
-              <a:t>    ON i.prev_txid = o.txid</a:t>
+              <a:t>  FROM with_input w WHERE w.total_input IS NOT NULL</a:t>
             </a:r>
           </a:p>
           <a:p>
@@ -30814,13 +31382,13 @@
               </a:lnSpc>
             </a:pPr>
             <a:r>
-              <a:rPr lang="it-IT" sz="820" b="1" dirty="0">
-                <a:solidFill>
-                  <a:srgbClr val="1F1F1F"/>
+              <a:rPr lang="it-IT" sz="820" b="0" dirty="0">
+                <a:solidFill>
+                  <a:srgbClr val="8A8A8A"/>
                 </a:solidFill>
                 <a:latin typeface="Consolas"/>
               </a:rPr>
-              <a:t>   AND i.prev_output_index = o.output_index</a:t>
+              <a:t>)</a:t>
             </a:r>
           </a:p>
           <a:p>
@@ -30836,7 +31404,7 @@
                 </a:solidFill>
                 <a:latin typeface="Consolas"/>
               </a:rPr>
-              <a:t>  WHERE o.address IS NOT NULL</a:t>
+              <a:t>SELECT txid, total_input, total_output,</a:t>
             </a:r>
           </a:p>
           <a:p>
@@ -30852,7 +31420,7 @@
                 </a:solidFill>
                 <a:latin typeface="Consolas"/>
               </a:rPr>
-              <a:t>  GROUP BY o.address</a:t>
+              <a:t>       total_input - total_output AS fee</a:t>
             </a:r>
           </a:p>
           <a:p>
@@ -30868,135 +31436,7 @@
                 </a:solidFill>
                 <a:latin typeface="Consolas"/>
               </a:rPr>
-              <a:t>)</a:t>
-            </a:r>
-          </a:p>
-          <a:p>
-            <a:pPr algn="l">
-              <a:lnSpc>
-                <a:spcPct val="100000"/>
-              </a:lnSpc>
-            </a:pPr>
-            <a:r>
-              <a:rPr lang="it-IT" sz="820" b="0" dirty="0">
-                <a:solidFill>
-                  <a:srgbClr val="8A8A8A"/>
-                </a:solidFill>
-                <a:latin typeface="Consolas"/>
-              </a:rPr>
-              <a:t>SELECT r.address, r.total_received,</a:t>
-            </a:r>
-          </a:p>
-          <a:p>
-            <a:pPr algn="l">
-              <a:lnSpc>
-                <a:spcPct val="100000"/>
-              </a:lnSpc>
-            </a:pPr>
-            <a:r>
-              <a:rPr lang="it-IT" sz="820" b="0" dirty="0">
-                <a:solidFill>
-                  <a:srgbClr val="8A8A8A"/>
-                </a:solidFill>
-                <a:latin typeface="Consolas"/>
-              </a:rPr>
-              <a:t>       COALESCE(s.total_spent, 0) AS total_spent,</a:t>
-            </a:r>
-          </a:p>
-          <a:p>
-            <a:pPr algn="l">
-              <a:lnSpc>
-                <a:spcPct val="100000"/>
-              </a:lnSpc>
-            </a:pPr>
-            <a:r>
-              <a:rPr lang="it-IT" sz="820" b="0" dirty="0">
-                <a:solidFill>
-                  <a:srgbClr val="8A8A8A"/>
-                </a:solidFill>
-                <a:latin typeface="Consolas"/>
-              </a:rPr>
-              <a:t>       r.total_received - COALESCE(s.total_spent, 0) AS balance</a:t>
-            </a:r>
-          </a:p>
-          <a:p>
-            <a:pPr algn="l">
-              <a:lnSpc>
-                <a:spcPct val="100000"/>
-              </a:lnSpc>
-            </a:pPr>
-            <a:r>
-              <a:rPr lang="it-IT" sz="820" b="0" dirty="0">
-                <a:solidFill>
-                  <a:srgbClr val="8A8A8A"/>
-                </a:solidFill>
-                <a:latin typeface="Consolas"/>
-              </a:rPr>
-              <a:t>FROM received r</a:t>
-            </a:r>
-          </a:p>
-          <a:p>
-            <a:pPr algn="l">
-              <a:lnSpc>
-                <a:spcPct val="100000"/>
-              </a:lnSpc>
-            </a:pPr>
-            <a:r>
-              <a:rPr lang="it-IT" sz="820" b="1" dirty="0">
-                <a:solidFill>
-                  <a:srgbClr val="1F1F1F"/>
-                </a:solidFill>
-                <a:latin typeface="Consolas"/>
-              </a:rPr>
-              <a:t>LEFT JOIN spent s ON r.address = s.address</a:t>
-            </a:r>
-          </a:p>
-          <a:p>
-            <a:pPr algn="l">
-              <a:lnSpc>
-                <a:spcPct val="100000"/>
-              </a:lnSpc>
-            </a:pPr>
-            <a:r>
-              <a:rPr lang="it-IT" sz="820" b="0" dirty="0">
-                <a:solidFill>
-                  <a:srgbClr val="8A8A8A"/>
-                </a:solidFill>
-                <a:latin typeface="Consolas"/>
-              </a:rPr>
-              <a:t>WHERE r.total_received - COALESCE(s.total_spent, 0) &gt; 0</a:t>
-            </a:r>
-          </a:p>
-          <a:p>
-            <a:pPr algn="l">
-              <a:lnSpc>
-                <a:spcPct val="100000"/>
-              </a:lnSpc>
-            </a:pPr>
-            <a:r>
-              <a:rPr lang="it-IT" sz="820" b="0" dirty="0">
-                <a:solidFill>
-                  <a:srgbClr val="8A8A8A"/>
-                </a:solidFill>
-                <a:latin typeface="Consolas"/>
-              </a:rPr>
-              <a:t>ORDER BY balance DESC</a:t>
-            </a:r>
-          </a:p>
-          <a:p>
-            <a:pPr algn="l">
-              <a:lnSpc>
-                <a:spcPct val="100000"/>
-              </a:lnSpc>
-            </a:pPr>
-            <a:r>
-              <a:rPr lang="it-IT" sz="820" b="0" dirty="0">
-                <a:solidFill>
-                  <a:srgbClr val="8A8A8A"/>
-                </a:solidFill>
-                <a:latin typeface="Consolas"/>
-              </a:rPr>
-              <a:t>LIMIT 100;</a:t>
+              <a:t>FROM amounts ORDER BY fee DESC LIMIT 100;</a:t>
             </a:r>
           </a:p>
         </p:txBody>
@@ -31043,7 +31483,7 @@
                 </a:solidFill>
                 <a:latin typeface="Arial"/>
               </a:rPr>
-              <a:t>13 lines  ·  1 pattern  ·  no joins</a:t>
+              <a:t>10 lines  ·  1 pattern  ·  no joins</a:t>
             </a:r>
           </a:p>
         </p:txBody>
@@ -31104,13 +31544,29 @@
               </a:lnSpc>
             </a:pPr>
             <a:r>
+              <a:rPr lang="it-IT" sz="820" b="0" dirty="0">
+                <a:solidFill>
+                  <a:srgbClr val="8A8A8A"/>
+                </a:solidFill>
+                <a:latin typeface="Consolas"/>
+              </a:rPr>
+              <a:t>MATCH (t:Transaction)-[:HAS_INPUT]-&gt;(i:Input)</a:t>
+            </a:r>
+          </a:p>
+          <a:p>
+            <a:pPr algn="l">
+              <a:lnSpc>
+                <a:spcPct val="100000"/>
+              </a:lnSpc>
+            </a:pPr>
+            <a:r>
               <a:rPr lang="it-IT" sz="820" b="1" dirty="0">
                 <a:solidFill>
                   <a:srgbClr val="1F1F1F"/>
                 </a:solidFill>
                 <a:latin typeface="Consolas"/>
               </a:rPr>
-              <a:t>MATCH (a:Address)&lt;-[:LOCKED_TO]-(o:Output)</a:t>
+              <a:t>      -[:SPENDS]-&gt;(prevOut:Output)</a:t>
             </a:r>
           </a:p>
           <a:p>
@@ -31126,7 +31582,7 @@
                 </a:solidFill>
                 <a:latin typeface="Consolas"/>
               </a:rPr>
-              <a:t>WITH a, o,</a:t>
+              <a:t>WHERE i.prevIndex &lt;&gt; 4294967295</a:t>
             </a:r>
           </a:p>
           <a:p>
@@ -31136,13 +31592,13 @@
               </a:lnSpc>
             </a:pPr>
             <a:r>
-              <a:rPr lang="it-IT" sz="820" b="1" dirty="0">
-                <a:solidFill>
-                  <a:srgbClr val="1F1F1F"/>
+              <a:rPr lang="it-IT" sz="820" b="0" dirty="0">
+                <a:solidFill>
+                  <a:srgbClr val="8A8A8A"/>
                 </a:solidFill>
                 <a:latin typeface="Consolas"/>
               </a:rPr>
-              <a:t>     EXISTS { (o)&lt;-[:SPENDS]-(:Input) } AS is_spent</a:t>
+              <a:t>WITH t, SUM(prevOut.value) AS total_input</a:t>
             </a:r>
           </a:p>
           <a:p>
@@ -31158,7 +31614,7 @@
                 </a:solidFill>
                 <a:latin typeface="Consolas"/>
               </a:rPr>
-              <a:t>WITH a,</a:t>
+              <a:t>MATCH (t)-[:HAS_OUTPUT]-&gt;(o:Output)</a:t>
             </a:r>
           </a:p>
           <a:p>
@@ -31174,7 +31630,7 @@
                 </a:solidFill>
                 <a:latin typeface="Consolas"/>
               </a:rPr>
-              <a:t>     SUM(o.value) AS total_received,</a:t>
+              <a:t>WITH t, total_input, SUM(o.value) AS total_output</a:t>
             </a:r>
           </a:p>
           <a:p>
@@ -31190,7 +31646,7 @@
                 </a:solidFill>
                 <a:latin typeface="Consolas"/>
               </a:rPr>
-              <a:t>     SUM(CASE WHEN is_spent THEN o.value ELSE 0 END)</a:t>
+              <a:t>RETURN t.txid, total_input, total_output,</a:t>
             </a:r>
           </a:p>
           <a:p>
@@ -31206,7 +31662,7 @@
                 </a:solidFill>
                 <a:latin typeface="Consolas"/>
               </a:rPr>
-              <a:t>       AS total_spent</a:t>
+              <a:t>       total_input - total_output AS fee</a:t>
             </a:r>
           </a:p>
           <a:p>
@@ -31222,71 +31678,7 @@
                 </a:solidFill>
                 <a:latin typeface="Consolas"/>
               </a:rPr>
-              <a:t>WITH a, total_received, total_spent,</a:t>
-            </a:r>
-          </a:p>
-          <a:p>
-            <a:pPr algn="l">
-              <a:lnSpc>
-                <a:spcPct val="100000"/>
-              </a:lnSpc>
-            </a:pPr>
-            <a:r>
-              <a:rPr lang="it-IT" sz="820" b="0" dirty="0">
-                <a:solidFill>
-                  <a:srgbClr val="8A8A8A"/>
-                </a:solidFill>
-                <a:latin typeface="Consolas"/>
-              </a:rPr>
-              <a:t>     total_received - total_spent AS balance</a:t>
-            </a:r>
-          </a:p>
-          <a:p>
-            <a:pPr algn="l">
-              <a:lnSpc>
-                <a:spcPct val="100000"/>
-              </a:lnSpc>
-            </a:pPr>
-            <a:r>
-              <a:rPr lang="it-IT" sz="820" b="0" dirty="0">
-                <a:solidFill>
-                  <a:srgbClr val="8A8A8A"/>
-                </a:solidFill>
-                <a:latin typeface="Consolas"/>
-              </a:rPr>
-              <a:t>WHERE balance &gt; 0</a:t>
-            </a:r>
-          </a:p>
-          <a:p>
-            <a:pPr algn="l">
-              <a:lnSpc>
-                <a:spcPct val="100000"/>
-              </a:lnSpc>
-            </a:pPr>
-            <a:r>
-              <a:rPr lang="it-IT" sz="820" b="0" dirty="0">
-                <a:solidFill>
-                  <a:srgbClr val="8A8A8A"/>
-                </a:solidFill>
-                <a:latin typeface="Consolas"/>
-              </a:rPr>
-              <a:t>RETURN a.address, total_received, total_spent, balance</a:t>
-            </a:r>
-          </a:p>
-          <a:p>
-            <a:pPr algn="l">
-              <a:lnSpc>
-                <a:spcPct val="100000"/>
-              </a:lnSpc>
-            </a:pPr>
-            <a:r>
-              <a:rPr lang="it-IT" sz="820" b="0" dirty="0">
-                <a:solidFill>
-                  <a:srgbClr val="8A8A8A"/>
-                </a:solidFill>
-                <a:latin typeface="Consolas"/>
-              </a:rPr>
-              <a:t>ORDER BY balance DESC</a:t>
+              <a:t>ORDER BY fee DESC</a:t>
             </a:r>
           </a:p>
           <a:p>
@@ -31365,7 +31757,7 @@
                 </a:solidFill>
                 <a:latin typeface="Arial"/>
               </a:rPr>
-              <a:t>matches every input to its output, at every query</a:t>
+              <a:t>matches every input with its output, at every query</a:t>
             </a:r>
           </a:p>
         </p:txBody>

</xml_diff>